<commit_message>
Add Manifest/Service Worker/Security explainer slide
</commit_message>
<xml_diff>
--- a/Publishing-PWA-to-Microsoft-Store.pptx
+++ b/Publishing-PWA-to-Microsoft-Store.pptx
@@ -16,6 +16,7 @@
     <p:sldId id="264" r:id="rId15"/>
     <p:sldId id="265" r:id="rId16"/>
     <p:sldId id="266" r:id="rId17"/>
+    <p:sldId id="267" r:id="rId18"/>
   </p:sldIdLst>
   <p:sldSz cx="12191695" cy="6858000" type="screen4x3"/>
   <p:notesSz cx="6858000" cy="9144000"/>
@@ -3375,7 +3376,7 @@
                   <a:srgbClr val="1B2A4A"/>
                 </a:solidFill>
               </a:rPr>
-              <a:t>Step 5 - Maintain &amp; update</a:t>
+              <a:t>Step 4 - Submit in Partner Center</a:t>
             </a:r>
           </a:p>
         </p:txBody>
@@ -3457,7 +3458,7 @@
                   <a:srgbClr val="272E3B"/>
                 </a:solidFill>
               </a:rPr>
-              <a:t>•  Content/UI changes: just deploy to your HTTPS host - users get them automatically</a:t>
+              <a:t>•  Register a developer account once (individual ~$19 / company ~$99)</a:t>
             </a:r>
           </a:p>
           <a:p>
@@ -3472,7 +3473,7 @@
                   <a:srgbClr val="272E3B"/>
                 </a:solidFill>
               </a:rPr>
-              <a:t>•  Bump the service worker cache version so clients pick up new assets</a:t>
+              <a:t>•  Reserve the app name, then upload the .msixbundle under Packages</a:t>
             </a:r>
           </a:p>
           <a:p>
@@ -3487,7 +3488,7 @@
                   <a:srgbClr val="272E3B"/>
                 </a:solidFill>
               </a:rPr>
-              <a:t>•  Only repackage + resubmit when the app package version/identity changes</a:t>
+              <a:t>•  Complete the listing: description, screenshots, category, age rating</a:t>
             </a:r>
           </a:p>
           <a:p>
@@ -3502,7 +3503,22 @@
                   <a:srgbClr val="272E3B"/>
                 </a:solidFill>
               </a:rPr>
-              <a:t>•  Watch Partner Center for certification status, ratings, and health metrics</a:t>
+              <a:t>•  Provide a privacy policy URL - it is required to pass certification</a:t>
+            </a:r>
+          </a:p>
+          <a:p>
+            <a:pPr>
+              <a:spcAft>
+                <a:spcPts val="1200"/>
+              </a:spcAft>
+            </a:pPr>
+            <a:r>
+              <a:rPr sz="1800">
+                <a:solidFill>
+                  <a:srgbClr val="272E3B"/>
+                </a:solidFill>
+              </a:rPr>
+              <a:t>•  Submit and wait for Store certification review</a:t>
             </a:r>
           </a:p>
         </p:txBody>
@@ -3631,6 +3647,262 @@
                   <a:srgbClr val="1B2A4A"/>
                 </a:solidFill>
               </a:rPr>
+              <a:t>Step 5 - Maintain &amp; update</a:t>
+            </a:r>
+          </a:p>
+        </p:txBody>
+      </p:sp>
+      <p:sp>
+        <p:nvSpPr>
+          <p:cNvPr id="4" name="Rectangle 3"/>
+          <p:cNvSpPr/>
+          <p:nvPr/>
+        </p:nvSpPr>
+        <p:spPr>
+          <a:xfrm>
+            <a:off x="566928" y="1325880"/>
+            <a:ext cx="1828800" cy="54864"/>
+          </a:xfrm>
+          <a:prstGeom prst="rect">
+            <a:avLst/>
+          </a:prstGeom>
+          <a:solidFill>
+            <a:srgbClr val="4F8CFF"/>
+          </a:solidFill>
+          <a:ln>
+            <a:noFill/>
+          </a:ln>
+          <a:effectLst/>
+        </p:spPr>
+        <p:style>
+          <a:lnRef idx="1">
+            <a:schemeClr val="accent1"/>
+          </a:lnRef>
+          <a:fillRef idx="3">
+            <a:schemeClr val="accent1"/>
+          </a:fillRef>
+          <a:effectRef idx="2">
+            <a:schemeClr val="accent1"/>
+          </a:effectRef>
+          <a:fontRef idx="minor">
+            <a:schemeClr val="lt1"/>
+          </a:fontRef>
+        </p:style>
+        <p:txBody>
+          <a:bodyPr rtlCol="0" anchor="ctr"/>
+          <a:lstStyle/>
+          <a:p>
+            <a:pPr algn="ctr"/>
+          </a:p>
+        </p:txBody>
+      </p:sp>
+      <p:sp>
+        <p:nvSpPr>
+          <p:cNvPr id="5" name="TextBox 4"/>
+          <p:cNvSpPr txBox="1"/>
+          <p:nvPr/>
+        </p:nvSpPr>
+        <p:spPr>
+          <a:xfrm>
+            <a:off x="548640" y="1645920"/>
+            <a:ext cx="11064240" cy="4480560"/>
+          </a:xfrm>
+          <a:prstGeom prst="rect">
+            <a:avLst/>
+          </a:prstGeom>
+          <a:noFill/>
+        </p:spPr>
+        <p:txBody>
+          <a:bodyPr wrap="square" anchor="t">
+            <a:spAutoFit/>
+          </a:bodyPr>
+          <a:lstStyle/>
+          <a:p>
+            <a:pPr>
+              <a:spcAft>
+                <a:spcPts val="1200"/>
+              </a:spcAft>
+            </a:pPr>
+            <a:r>
+              <a:rPr sz="1800">
+                <a:solidFill>
+                  <a:srgbClr val="272E3B"/>
+                </a:solidFill>
+              </a:rPr>
+              <a:t>•  Content/UI changes: just deploy to your HTTPS host - users get them automatically</a:t>
+            </a:r>
+          </a:p>
+          <a:p>
+            <a:pPr>
+              <a:spcAft>
+                <a:spcPts val="1200"/>
+              </a:spcAft>
+            </a:pPr>
+            <a:r>
+              <a:rPr sz="1800">
+                <a:solidFill>
+                  <a:srgbClr val="272E3B"/>
+                </a:solidFill>
+              </a:rPr>
+              <a:t>•  Bump the service worker cache version so clients pick up new assets</a:t>
+            </a:r>
+          </a:p>
+          <a:p>
+            <a:pPr>
+              <a:spcAft>
+                <a:spcPts val="1200"/>
+              </a:spcAft>
+            </a:pPr>
+            <a:r>
+              <a:rPr sz="1800">
+                <a:solidFill>
+                  <a:srgbClr val="272E3B"/>
+                </a:solidFill>
+              </a:rPr>
+              <a:t>•  Only repackage + resubmit when the app package version/identity changes</a:t>
+            </a:r>
+          </a:p>
+          <a:p>
+            <a:pPr>
+              <a:spcAft>
+                <a:spcPts val="1200"/>
+              </a:spcAft>
+            </a:pPr>
+            <a:r>
+              <a:rPr sz="1800">
+                <a:solidFill>
+                  <a:srgbClr val="272E3B"/>
+                </a:solidFill>
+              </a:rPr>
+              <a:t>•  Watch Partner Center for certification status, ratings, and health metrics</a:t>
+            </a:r>
+          </a:p>
+        </p:txBody>
+      </p:sp>
+      <p:sp>
+        <p:nvSpPr>
+          <p:cNvPr id="6" name="TextBox 5"/>
+          <p:cNvSpPr txBox="1"/>
+          <p:nvPr/>
+        </p:nvSpPr>
+        <p:spPr>
+          <a:xfrm>
+            <a:off x="457200" y="6419088"/>
+            <a:ext cx="11277295" cy="320040"/>
+          </a:xfrm>
+          <a:prstGeom prst="rect">
+            <a:avLst/>
+          </a:prstGeom>
+          <a:noFill/>
+        </p:spPr>
+        <p:txBody>
+          <a:bodyPr wrap="square">
+            <a:spAutoFit/>
+          </a:bodyPr>
+          <a:lstStyle/>
+          <a:p>
+            <a:pPr algn="l"/>
+            <a:r>
+              <a:rPr sz="1000">
+                <a:solidFill>
+                  <a:srgbClr val="8A93A5"/>
+                </a:solidFill>
+              </a:rPr>
+              <a:t>Publishing a PWA to the Microsoft Store</a:t>
+            </a:r>
+          </a:p>
+        </p:txBody>
+      </p:sp>
+    </p:spTree>
+  </p:cSld>
+  <p:clrMapOvr>
+    <a:masterClrMapping/>
+  </p:clrMapOvr>
+</p:sld>
+</file>
+
+<file path=ppt/slides/slide12.xml><?xml version="1.0" encoding="utf-8"?>
+<p:sld xmlns:a="http://schemas.openxmlformats.org/drawingml/2006/main" xmlns:p="http://schemas.openxmlformats.org/presentationml/2006/main" xmlns:r="http://schemas.openxmlformats.org/officeDocument/2006/relationships">
+  <p:cSld>
+    <p:spTree>
+      <p:nvGrpSpPr>
+        <p:cNvPr id="1" name=""/>
+        <p:cNvGrpSpPr/>
+        <p:nvPr/>
+      </p:nvGrpSpPr>
+      <p:grpSpPr/>
+      <p:sp>
+        <p:nvSpPr>
+          <p:cNvPr id="2" name="Rectangle 1"/>
+          <p:cNvSpPr/>
+          <p:nvPr/>
+        </p:nvSpPr>
+        <p:spPr>
+          <a:xfrm>
+            <a:off x="0" y="0"/>
+            <a:ext cx="12191695" cy="6858000"/>
+          </a:xfrm>
+          <a:prstGeom prst="rect">
+            <a:avLst/>
+          </a:prstGeom>
+          <a:solidFill>
+            <a:srgbClr val="FFFFFF"/>
+          </a:solidFill>
+          <a:ln>
+            <a:noFill/>
+          </a:ln>
+          <a:effectLst/>
+        </p:spPr>
+        <p:style>
+          <a:lnRef idx="1">
+            <a:schemeClr val="accent1"/>
+          </a:lnRef>
+          <a:fillRef idx="3">
+            <a:schemeClr val="accent1"/>
+          </a:fillRef>
+          <a:effectRef idx="2">
+            <a:schemeClr val="accent1"/>
+          </a:effectRef>
+          <a:fontRef idx="minor">
+            <a:schemeClr val="lt1"/>
+          </a:fontRef>
+        </p:style>
+        <p:txBody>
+          <a:bodyPr rtlCol="0" anchor="ctr"/>
+          <a:lstStyle/>
+          <a:p>
+            <a:pPr algn="ctr"/>
+          </a:p>
+        </p:txBody>
+      </p:sp>
+      <p:sp>
+        <p:nvSpPr>
+          <p:cNvPr id="3" name="TextBox 2"/>
+          <p:cNvSpPr txBox="1"/>
+          <p:nvPr/>
+        </p:nvSpPr>
+        <p:spPr>
+          <a:xfrm>
+            <a:off x="548640" y="457200"/>
+            <a:ext cx="11064240" cy="914400"/>
+          </a:xfrm>
+          <a:prstGeom prst="rect">
+            <a:avLst/>
+          </a:prstGeom>
+          <a:noFill/>
+        </p:spPr>
+        <p:txBody>
+          <a:bodyPr wrap="square">
+            <a:spAutoFit/>
+          </a:bodyPr>
+          <a:lstStyle/>
+          <a:p>
+            <a:r>
+              <a:rPr sz="3200" b="1">
+                <a:solidFill>
+                  <a:srgbClr val="1B2A4A"/>
+                </a:solidFill>
+              </a:rPr>
               <a:t>Reusable checklist</a:t>
             </a:r>
           </a:p>
@@ -4730,7 +5002,7 @@
                   <a:srgbClr val="1B2A4A"/>
                 </a:solidFill>
               </a:rPr>
-              <a:t>Common gotcha - service worker caching</a:t>
+              <a:t>The three pillars PWABuilder checks</a:t>
             </a:r>
           </a:p>
         </p:txBody>
@@ -4812,7 +5084,7 @@
                   <a:srgbClr val="272E3B"/>
                 </a:solidFill>
               </a:rPr>
-              <a:t>•  Symptom: code/asset edits don't appear after refresh (stale files served)</a:t>
+              <a:t>•  Manifest = identity: a JSON file (manifest.json) describing the app - name, icons, colors, and how it launches. It makes a website installable and gives PWABuilder the metadata to build the Store package.</a:t>
             </a:r>
           </a:p>
           <a:p>
@@ -4827,7 +5099,7 @@
                   <a:srgbClr val="272E3B"/>
                 </a:solidFill>
               </a:rPr>
-              <a:t>•  Cause: a cache-first service worker keeps serving old cached assets</a:t>
+              <a:t>•  Service Worker = offline + installable: a background script (sw.js) between the app and the network. It caches files so the app loads fast and works offline, and it enables installation. Prefer network-first: fresh when online, cached fallback offline.</a:t>
             </a:r>
           </a:p>
           <a:p>
@@ -4842,7 +5114,7 @@
                   <a:srgbClr val="272E3B"/>
                 </a:solidFill>
               </a:rPr>
-              <a:t>•  Fix: use network-first (fresh when online, cache as offline fallback)</a:t>
+              <a:t>•  Security = HTTPS: the app must be served over HTTPS. Service workers only run on secure origins and the Store requires it. Hosting on GitHub Pages satisfies this automatically.</a:t>
             </a:r>
           </a:p>
           <a:p>
@@ -4857,22 +5129,7 @@
                   <a:srgbClr val="272E3B"/>
                 </a:solidFill>
               </a:rPr>
-              <a:t>•  Bump the cache version (CACHE_NAME) whenever cached assets change</a:t>
-            </a:r>
-          </a:p>
-          <a:p>
-            <a:pPr>
-              <a:spcAft>
-                <a:spcPts val="1200"/>
-              </a:spcAft>
-            </a:pPr>
-            <a:r>
-              <a:rPr sz="1800">
-                <a:solidFill>
-                  <a:srgbClr val="272E3B"/>
-                </a:solidFill>
-              </a:rPr>
-              <a:t>•  Hard-refresh (Ctrl+Shift+R) to clear the browser's own HTTP cache</a:t>
+              <a:t>•  In short: Manifest = identity, Service Worker = offline + installable, Security = HTTPS.</a:t>
             </a:r>
           </a:p>
         </p:txBody>
@@ -5001,7 +5258,7 @@
                   <a:srgbClr val="1B2A4A"/>
                 </a:solidFill>
               </a:rPr>
-              <a:t>Step 2 - Host on public HTTPS</a:t>
+              <a:t>Common gotcha - service worker caching</a:t>
             </a:r>
           </a:p>
         </p:txBody>
@@ -5083,7 +5340,7 @@
                   <a:srgbClr val="272E3B"/>
                 </a:solidFill>
               </a:rPr>
-              <a:t>•  You need a stable, public HTTPS URL for PWABuilder to read</a:t>
+              <a:t>•  Symptom: code/asset edits don't appear after refresh (stale files served)</a:t>
             </a:r>
           </a:p>
           <a:p>
@@ -5098,7 +5355,7 @@
                   <a:srgbClr val="272E3B"/>
                 </a:solidFill>
               </a:rPr>
-              <a:t>•  Free options: GitHub Pages, Azure Static Web Apps, Netlify, Vercel, Cloudflare Pages</a:t>
+              <a:t>•  Cause: a cache-first service worker keeps serving old cached assets</a:t>
             </a:r>
           </a:p>
           <a:p>
@@ -5113,7 +5370,7 @@
                   <a:srgbClr val="272E3B"/>
                 </a:solidFill>
               </a:rPr>
-              <a:t>•  GitHub Pages: push to a repo, let a GitHub Actions workflow auto-deploy on each push</a:t>
+              <a:t>•  Fix: use network-first (fresh when online, cache as offline fallback)</a:t>
             </a:r>
           </a:p>
           <a:p>
@@ -5128,7 +5385,22 @@
                   <a:srgbClr val="272E3B"/>
                 </a:solidFill>
               </a:rPr>
-              <a:t>•  Use relative asset paths so the app also works under a /repo-name/ subpath</a:t>
+              <a:t>•  Bump the cache version (CACHE_NAME) whenever cached assets change</a:t>
+            </a:r>
+          </a:p>
+          <a:p>
+            <a:pPr>
+              <a:spcAft>
+                <a:spcPts val="1200"/>
+              </a:spcAft>
+            </a:pPr>
+            <a:r>
+              <a:rPr sz="1800">
+                <a:solidFill>
+                  <a:srgbClr val="272E3B"/>
+                </a:solidFill>
+              </a:rPr>
+              <a:t>•  Hard-refresh (Ctrl+Shift+R) to clear the browser's own HTTP cache</a:t>
             </a:r>
           </a:p>
         </p:txBody>
@@ -5257,7 +5529,7 @@
                   <a:srgbClr val="1B2A4A"/>
                 </a:solidFill>
               </a:rPr>
-              <a:t>Step 3 - Package with PWABuilder</a:t>
+              <a:t>Step 2 - Host on public HTTPS</a:t>
             </a:r>
           </a:p>
         </p:txBody>
@@ -5339,7 +5611,7 @@
                   <a:srgbClr val="272E3B"/>
                 </a:solidFill>
               </a:rPr>
-              <a:t>•  Open pwabuilder.com and enter your live HTTPS URL</a:t>
+              <a:t>•  You need a stable, public HTTPS URL for PWABuilder to read</a:t>
             </a:r>
           </a:p>
           <a:p>
@@ -5354,7 +5626,7 @@
                   <a:srgbClr val="272E3B"/>
                 </a:solidFill>
               </a:rPr>
-              <a:t>•  It audits the manifest, service worker, and security, and reports gaps to fix</a:t>
+              <a:t>•  Free options: GitHub Pages, Azure Static Web Apps, Netlify, Vercel, Cloudflare Pages</a:t>
             </a:r>
           </a:p>
           <a:p>
@@ -5369,7 +5641,7 @@
                   <a:srgbClr val="272E3B"/>
                 </a:solidFill>
               </a:rPr>
-              <a:t>•  Choose Package For Stores -&gt; Windows to generate a signed .msixbundle</a:t>
+              <a:t>•  GitHub Pages: push to a repo, let a GitHub Actions workflow auto-deploy on each push</a:t>
             </a:r>
           </a:p>
           <a:p>
@@ -5384,7 +5656,7 @@
                   <a:srgbClr val="272E3B"/>
                 </a:solidFill>
               </a:rPr>
-              <a:t>•  Supply your Partner Center Publisher ID + display name so the package matches your account</a:t>
+              <a:t>•  Use relative asset paths so the app also works under a /repo-name/ subpath</a:t>
             </a:r>
           </a:p>
         </p:txBody>
@@ -5513,7 +5785,7 @@
                   <a:srgbClr val="1B2A4A"/>
                 </a:solidFill>
               </a:rPr>
-              <a:t>Milestone - Packaging in progress</a:t>
+              <a:t>Step 3 - Package with PWABuilder</a:t>
             </a:r>
           </a:p>
         </p:txBody>
@@ -5595,7 +5867,7 @@
                   <a:srgbClr val="272E3B"/>
                 </a:solidFill>
               </a:rPr>
-              <a:t>•  Live app validated and hosted at https://vijayatmicrosoft.github.io/number-tiles-pwa/</a:t>
+              <a:t>•  Open pwabuilder.com and enter your live HTTPS URL</a:t>
             </a:r>
           </a:p>
           <a:p>
@@ -5610,7 +5882,7 @@
                   <a:srgbClr val="272E3B"/>
                 </a:solidFill>
               </a:rPr>
-              <a:t>•  Privacy policy published at /privacy.html (required for the Store listing)</a:t>
+              <a:t>•  It audits the manifest, service worker, and security, and reports gaps to fix</a:t>
             </a:r>
           </a:p>
           <a:p>
@@ -5625,7 +5897,7 @@
                   <a:srgbClr val="272E3B"/>
                 </a:solidFill>
               </a:rPr>
-              <a:t>•  Ran PWABuilder against the live URL to generate the Windows package</a:t>
+              <a:t>•  Choose Package For Stores -&gt; Windows to generate a signed .msixbundle</a:t>
             </a:r>
           </a:p>
           <a:p>
@@ -5640,22 +5912,7 @@
                   <a:srgbClr val="272E3B"/>
                 </a:solidFill>
               </a:rPr>
-              <a:t>•  Key step: Package ID, Publisher ID, and Publisher display name must match the reserved app in Partner Center exactly</a:t>
-            </a:r>
-          </a:p>
-          <a:p>
-            <a:pPr>
-              <a:spcAft>
-                <a:spcPts val="1200"/>
-              </a:spcAft>
-            </a:pPr>
-            <a:r>
-              <a:rPr sz="1800">
-                <a:solidFill>
-                  <a:srgbClr val="272E3B"/>
-                </a:solidFill>
-              </a:rPr>
-              <a:t>•  Output: a signed .msixbundle ready to upload to Partner Center</a:t>
+              <a:t>•  Supply your Partner Center Publisher ID + display name so the package matches your account</a:t>
             </a:r>
           </a:p>
         </p:txBody>
@@ -5784,7 +6041,7 @@
                   <a:srgbClr val="1B2A4A"/>
                 </a:solidFill>
               </a:rPr>
-              <a:t>Step 4 - Submit in Partner Center</a:t>
+              <a:t>Milestone - Packaging in progress</a:t>
             </a:r>
           </a:p>
         </p:txBody>
@@ -5866,7 +6123,7 @@
                   <a:srgbClr val="272E3B"/>
                 </a:solidFill>
               </a:rPr>
-              <a:t>•  Register a developer account once (individual ~$19 / company ~$99)</a:t>
+              <a:t>•  Live app validated and hosted at https://vijayatmicrosoft.github.io/number-tiles-pwa/</a:t>
             </a:r>
           </a:p>
           <a:p>
@@ -5881,7 +6138,7 @@
                   <a:srgbClr val="272E3B"/>
                 </a:solidFill>
               </a:rPr>
-              <a:t>•  Reserve the app name, then upload the .msixbundle under Packages</a:t>
+              <a:t>•  Privacy policy published at /privacy.html (required for the Store listing)</a:t>
             </a:r>
           </a:p>
           <a:p>
@@ -5896,7 +6153,7 @@
                   <a:srgbClr val="272E3B"/>
                 </a:solidFill>
               </a:rPr>
-              <a:t>•  Complete the listing: description, screenshots, category, age rating</a:t>
+              <a:t>•  Ran PWABuilder against the live URL to generate the Windows package</a:t>
             </a:r>
           </a:p>
           <a:p>
@@ -5911,7 +6168,7 @@
                   <a:srgbClr val="272E3B"/>
                 </a:solidFill>
               </a:rPr>
-              <a:t>•  Provide a privacy policy URL - it is required to pass certification</a:t>
+              <a:t>•  Key step: Package ID, Publisher ID, and Publisher display name must match the reserved app in Partner Center exactly</a:t>
             </a:r>
           </a:p>
           <a:p>
@@ -5926,7 +6183,7 @@
                   <a:srgbClr val="272E3B"/>
                 </a:solidFill>
               </a:rPr>
-              <a:t>•  Submit and wait for Store certification review</a:t>
+              <a:t>•  Output: a signed .msixbundle ready to upload to Partner Center</a:t>
             </a:r>
           </a:p>
         </p:txBody>

</xml_diff>

<commit_message>
Add package-identity mapping and package-contents slides
</commit_message>
<xml_diff>
--- a/Publishing-PWA-to-Microsoft-Store.pptx
+++ b/Publishing-PWA-to-Microsoft-Store.pptx
@@ -17,6 +17,8 @@
     <p:sldId id="265" r:id="rId16"/>
     <p:sldId id="266" r:id="rId17"/>
     <p:sldId id="267" r:id="rId18"/>
+    <p:sldId id="268" r:id="rId19"/>
+    <p:sldId id="269" r:id="rId20"/>
   </p:sldIdLst>
   <p:sldSz cx="12191695" cy="6858000" type="screen4x3"/>
   <p:notesSz cx="6858000" cy="9144000"/>
@@ -3376,7 +3378,7 @@
                   <a:srgbClr val="1B2A4A"/>
                 </a:solidFill>
               </a:rPr>
-              <a:t>Step 4 - Submit in Partner Center</a:t>
+              <a:t>What is inside the PWABuilder package</a:t>
             </a:r>
           </a:p>
         </p:txBody>
@@ -3458,7 +3460,7 @@
                   <a:srgbClr val="272E3B"/>
                 </a:solidFill>
               </a:rPr>
-              <a:t>•  Register a developer account once (individual ~$19 / company ~$99)</a:t>
+              <a:t>•  .msixbundle - the main Store package; upload this to Partner Center</a:t>
             </a:r>
           </a:p>
           <a:p>
@@ -3473,7 +3475,7 @@
                   <a:srgbClr val="272E3B"/>
                 </a:solidFill>
               </a:rPr>
-              <a:t>•  Reserve the app name, then upload the .msixbundle under Packages</a:t>
+              <a:t>•  .classic.appxbundle - compatibility package for older Windows 10; also upload this to Partner Center</a:t>
             </a:r>
           </a:p>
           <a:p>
@@ -3488,7 +3490,7 @@
                   <a:srgbClr val="272E3B"/>
                 </a:solidFill>
               </a:rPr>
-              <a:t>•  Complete the listing: description, screenshots, category, age rating</a:t>
+              <a:t>•  .sideload.msix - a test copy to install locally (bypasses the Store); not uploaded</a:t>
             </a:r>
           </a:p>
           <a:p>
@@ -3503,7 +3505,7 @@
                   <a:srgbClr val="272E3B"/>
                 </a:solidFill>
               </a:rPr>
-              <a:t>•  Provide a privacy policy URL - it is required to pass certification</a:t>
+              <a:t>•  install.ps1 - helper script that installs the sideload package and its test certificate for local testing</a:t>
             </a:r>
           </a:p>
           <a:p>
@@ -3518,7 +3520,37 @@
                   <a:srgbClr val="272E3B"/>
                 </a:solidFill>
               </a:rPr>
-              <a:t>•  Submit and wait for Store certification review</a:t>
+              <a:t>•  utils folder - support files (test certificate and helpers) used by install.ps1</a:t>
+            </a:r>
+          </a:p>
+          <a:p>
+            <a:pPr>
+              <a:spcAft>
+                <a:spcPts val="1200"/>
+              </a:spcAft>
+            </a:pPr>
+            <a:r>
+              <a:rPr sz="1800">
+                <a:solidFill>
+                  <a:srgbClr val="272E3B"/>
+                </a:solidFill>
+              </a:rPr>
+              <a:t>•  readme.html - PWABuilder's own instructions for these files</a:t>
+            </a:r>
+          </a:p>
+          <a:p>
+            <a:pPr>
+              <a:spcAft>
+                <a:spcPts val="1200"/>
+              </a:spcAft>
+            </a:pPr>
+            <a:r>
+              <a:rPr sz="1800">
+                <a:solidFill>
+                  <a:srgbClr val="272E3B"/>
+                </a:solidFill>
+              </a:rPr>
+              <a:t>•  To submit: upload BOTH the .msixbundle and the .classic.appxbundle</a:t>
             </a:r>
           </a:p>
         </p:txBody>
@@ -3647,7 +3679,7 @@
                   <a:srgbClr val="1B2A4A"/>
                 </a:solidFill>
               </a:rPr>
-              <a:t>Step 5 - Maintain &amp; update</a:t>
+              <a:t>Milestone - Packaging in progress</a:t>
             </a:r>
           </a:p>
         </p:txBody>
@@ -3729,7 +3761,7 @@
                   <a:srgbClr val="272E3B"/>
                 </a:solidFill>
               </a:rPr>
-              <a:t>•  Content/UI changes: just deploy to your HTTPS host - users get them automatically</a:t>
+              <a:t>•  Live app validated and hosted at https://vijayatmicrosoft.github.io/number-tiles-pwa/</a:t>
             </a:r>
           </a:p>
           <a:p>
@@ -3744,7 +3776,7 @@
                   <a:srgbClr val="272E3B"/>
                 </a:solidFill>
               </a:rPr>
-              <a:t>•  Bump the service worker cache version so clients pick up new assets</a:t>
+              <a:t>•  Privacy policy published at /privacy.html (required for the Store listing)</a:t>
             </a:r>
           </a:p>
           <a:p>
@@ -3759,7 +3791,7 @@
                   <a:srgbClr val="272E3B"/>
                 </a:solidFill>
               </a:rPr>
-              <a:t>•  Only repackage + resubmit when the app package version/identity changes</a:t>
+              <a:t>•  Ran PWABuilder against the live URL to generate the Windows package</a:t>
             </a:r>
           </a:p>
           <a:p>
@@ -3774,7 +3806,22 @@
                   <a:srgbClr val="272E3B"/>
                 </a:solidFill>
               </a:rPr>
-              <a:t>•  Watch Partner Center for certification status, ratings, and health metrics</a:t>
+              <a:t>•  Key step: Package ID, Publisher ID, and Publisher display name must match the reserved app in Partner Center exactly</a:t>
+            </a:r>
+          </a:p>
+          <a:p>
+            <a:pPr>
+              <a:spcAft>
+                <a:spcPts val="1200"/>
+              </a:spcAft>
+            </a:pPr>
+            <a:r>
+              <a:rPr sz="1800">
+                <a:solidFill>
+                  <a:srgbClr val="272E3B"/>
+                </a:solidFill>
+              </a:rPr>
+              <a:t>•  Output: a signed .msixbundle ready to upload to Partner Center</a:t>
             </a:r>
           </a:p>
         </p:txBody>
@@ -3903,6 +3950,533 @@
                   <a:srgbClr val="1B2A4A"/>
                 </a:solidFill>
               </a:rPr>
+              <a:t>Step 4 - Submit in Partner Center</a:t>
+            </a:r>
+          </a:p>
+        </p:txBody>
+      </p:sp>
+      <p:sp>
+        <p:nvSpPr>
+          <p:cNvPr id="4" name="Rectangle 3"/>
+          <p:cNvSpPr/>
+          <p:nvPr/>
+        </p:nvSpPr>
+        <p:spPr>
+          <a:xfrm>
+            <a:off x="566928" y="1325880"/>
+            <a:ext cx="1828800" cy="54864"/>
+          </a:xfrm>
+          <a:prstGeom prst="rect">
+            <a:avLst/>
+          </a:prstGeom>
+          <a:solidFill>
+            <a:srgbClr val="4F8CFF"/>
+          </a:solidFill>
+          <a:ln>
+            <a:noFill/>
+          </a:ln>
+          <a:effectLst/>
+        </p:spPr>
+        <p:style>
+          <a:lnRef idx="1">
+            <a:schemeClr val="accent1"/>
+          </a:lnRef>
+          <a:fillRef idx="3">
+            <a:schemeClr val="accent1"/>
+          </a:fillRef>
+          <a:effectRef idx="2">
+            <a:schemeClr val="accent1"/>
+          </a:effectRef>
+          <a:fontRef idx="minor">
+            <a:schemeClr val="lt1"/>
+          </a:fontRef>
+        </p:style>
+        <p:txBody>
+          <a:bodyPr rtlCol="0" anchor="ctr"/>
+          <a:lstStyle/>
+          <a:p>
+            <a:pPr algn="ctr"/>
+          </a:p>
+        </p:txBody>
+      </p:sp>
+      <p:sp>
+        <p:nvSpPr>
+          <p:cNvPr id="5" name="TextBox 4"/>
+          <p:cNvSpPr txBox="1"/>
+          <p:nvPr/>
+        </p:nvSpPr>
+        <p:spPr>
+          <a:xfrm>
+            <a:off x="548640" y="1645920"/>
+            <a:ext cx="11064240" cy="4480560"/>
+          </a:xfrm>
+          <a:prstGeom prst="rect">
+            <a:avLst/>
+          </a:prstGeom>
+          <a:noFill/>
+        </p:spPr>
+        <p:txBody>
+          <a:bodyPr wrap="square" anchor="t">
+            <a:spAutoFit/>
+          </a:bodyPr>
+          <a:lstStyle/>
+          <a:p>
+            <a:pPr>
+              <a:spcAft>
+                <a:spcPts val="1200"/>
+              </a:spcAft>
+            </a:pPr>
+            <a:r>
+              <a:rPr sz="1800">
+                <a:solidFill>
+                  <a:srgbClr val="272E3B"/>
+                </a:solidFill>
+              </a:rPr>
+              <a:t>•  Register a developer account once (individual ~$19 / company ~$99)</a:t>
+            </a:r>
+          </a:p>
+          <a:p>
+            <a:pPr>
+              <a:spcAft>
+                <a:spcPts val="1200"/>
+              </a:spcAft>
+            </a:pPr>
+            <a:r>
+              <a:rPr sz="1800">
+                <a:solidFill>
+                  <a:srgbClr val="272E3B"/>
+                </a:solidFill>
+              </a:rPr>
+              <a:t>•  Reserve the app name, then upload the .msixbundle under Packages</a:t>
+            </a:r>
+          </a:p>
+          <a:p>
+            <a:pPr>
+              <a:spcAft>
+                <a:spcPts val="1200"/>
+              </a:spcAft>
+            </a:pPr>
+            <a:r>
+              <a:rPr sz="1800">
+                <a:solidFill>
+                  <a:srgbClr val="272E3B"/>
+                </a:solidFill>
+              </a:rPr>
+              <a:t>•  Complete the listing: description, screenshots, category, age rating</a:t>
+            </a:r>
+          </a:p>
+          <a:p>
+            <a:pPr>
+              <a:spcAft>
+                <a:spcPts val="1200"/>
+              </a:spcAft>
+            </a:pPr>
+            <a:r>
+              <a:rPr sz="1800">
+                <a:solidFill>
+                  <a:srgbClr val="272E3B"/>
+                </a:solidFill>
+              </a:rPr>
+              <a:t>•  Provide a privacy policy URL - it is required to pass certification</a:t>
+            </a:r>
+          </a:p>
+          <a:p>
+            <a:pPr>
+              <a:spcAft>
+                <a:spcPts val="1200"/>
+              </a:spcAft>
+            </a:pPr>
+            <a:r>
+              <a:rPr sz="1800">
+                <a:solidFill>
+                  <a:srgbClr val="272E3B"/>
+                </a:solidFill>
+              </a:rPr>
+              <a:t>•  Submit and wait for Store certification review</a:t>
+            </a:r>
+          </a:p>
+        </p:txBody>
+      </p:sp>
+      <p:sp>
+        <p:nvSpPr>
+          <p:cNvPr id="6" name="TextBox 5"/>
+          <p:cNvSpPr txBox="1"/>
+          <p:nvPr/>
+        </p:nvSpPr>
+        <p:spPr>
+          <a:xfrm>
+            <a:off x="457200" y="6419088"/>
+            <a:ext cx="11277295" cy="320040"/>
+          </a:xfrm>
+          <a:prstGeom prst="rect">
+            <a:avLst/>
+          </a:prstGeom>
+          <a:noFill/>
+        </p:spPr>
+        <p:txBody>
+          <a:bodyPr wrap="square">
+            <a:spAutoFit/>
+          </a:bodyPr>
+          <a:lstStyle/>
+          <a:p>
+            <a:pPr algn="l"/>
+            <a:r>
+              <a:rPr sz="1000">
+                <a:solidFill>
+                  <a:srgbClr val="8A93A5"/>
+                </a:solidFill>
+              </a:rPr>
+              <a:t>Publishing a PWA to the Microsoft Store</a:t>
+            </a:r>
+          </a:p>
+        </p:txBody>
+      </p:sp>
+    </p:spTree>
+  </p:cSld>
+  <p:clrMapOvr>
+    <a:masterClrMapping/>
+  </p:clrMapOvr>
+</p:sld>
+</file>
+
+<file path=ppt/slides/slide13.xml><?xml version="1.0" encoding="utf-8"?>
+<p:sld xmlns:a="http://schemas.openxmlformats.org/drawingml/2006/main" xmlns:p="http://schemas.openxmlformats.org/presentationml/2006/main" xmlns:r="http://schemas.openxmlformats.org/officeDocument/2006/relationships">
+  <p:cSld>
+    <p:spTree>
+      <p:nvGrpSpPr>
+        <p:cNvPr id="1" name=""/>
+        <p:cNvGrpSpPr/>
+        <p:nvPr/>
+      </p:nvGrpSpPr>
+      <p:grpSpPr/>
+      <p:sp>
+        <p:nvSpPr>
+          <p:cNvPr id="2" name="Rectangle 1"/>
+          <p:cNvSpPr/>
+          <p:nvPr/>
+        </p:nvSpPr>
+        <p:spPr>
+          <a:xfrm>
+            <a:off x="0" y="0"/>
+            <a:ext cx="12191695" cy="6858000"/>
+          </a:xfrm>
+          <a:prstGeom prst="rect">
+            <a:avLst/>
+          </a:prstGeom>
+          <a:solidFill>
+            <a:srgbClr val="FFFFFF"/>
+          </a:solidFill>
+          <a:ln>
+            <a:noFill/>
+          </a:ln>
+          <a:effectLst/>
+        </p:spPr>
+        <p:style>
+          <a:lnRef idx="1">
+            <a:schemeClr val="accent1"/>
+          </a:lnRef>
+          <a:fillRef idx="3">
+            <a:schemeClr val="accent1"/>
+          </a:fillRef>
+          <a:effectRef idx="2">
+            <a:schemeClr val="accent1"/>
+          </a:effectRef>
+          <a:fontRef idx="minor">
+            <a:schemeClr val="lt1"/>
+          </a:fontRef>
+        </p:style>
+        <p:txBody>
+          <a:bodyPr rtlCol="0" anchor="ctr"/>
+          <a:lstStyle/>
+          <a:p>
+            <a:pPr algn="ctr"/>
+          </a:p>
+        </p:txBody>
+      </p:sp>
+      <p:sp>
+        <p:nvSpPr>
+          <p:cNvPr id="3" name="TextBox 2"/>
+          <p:cNvSpPr txBox="1"/>
+          <p:nvPr/>
+        </p:nvSpPr>
+        <p:spPr>
+          <a:xfrm>
+            <a:off x="548640" y="457200"/>
+            <a:ext cx="11064240" cy="914400"/>
+          </a:xfrm>
+          <a:prstGeom prst="rect">
+            <a:avLst/>
+          </a:prstGeom>
+          <a:noFill/>
+        </p:spPr>
+        <p:txBody>
+          <a:bodyPr wrap="square">
+            <a:spAutoFit/>
+          </a:bodyPr>
+          <a:lstStyle/>
+          <a:p>
+            <a:r>
+              <a:rPr sz="3200" b="1">
+                <a:solidFill>
+                  <a:srgbClr val="1B2A4A"/>
+                </a:solidFill>
+              </a:rPr>
+              <a:t>Step 5 - Maintain &amp; update</a:t>
+            </a:r>
+          </a:p>
+        </p:txBody>
+      </p:sp>
+      <p:sp>
+        <p:nvSpPr>
+          <p:cNvPr id="4" name="Rectangle 3"/>
+          <p:cNvSpPr/>
+          <p:nvPr/>
+        </p:nvSpPr>
+        <p:spPr>
+          <a:xfrm>
+            <a:off x="566928" y="1325880"/>
+            <a:ext cx="1828800" cy="54864"/>
+          </a:xfrm>
+          <a:prstGeom prst="rect">
+            <a:avLst/>
+          </a:prstGeom>
+          <a:solidFill>
+            <a:srgbClr val="4F8CFF"/>
+          </a:solidFill>
+          <a:ln>
+            <a:noFill/>
+          </a:ln>
+          <a:effectLst/>
+        </p:spPr>
+        <p:style>
+          <a:lnRef idx="1">
+            <a:schemeClr val="accent1"/>
+          </a:lnRef>
+          <a:fillRef idx="3">
+            <a:schemeClr val="accent1"/>
+          </a:fillRef>
+          <a:effectRef idx="2">
+            <a:schemeClr val="accent1"/>
+          </a:effectRef>
+          <a:fontRef idx="minor">
+            <a:schemeClr val="lt1"/>
+          </a:fontRef>
+        </p:style>
+        <p:txBody>
+          <a:bodyPr rtlCol="0" anchor="ctr"/>
+          <a:lstStyle/>
+          <a:p>
+            <a:pPr algn="ctr"/>
+          </a:p>
+        </p:txBody>
+      </p:sp>
+      <p:sp>
+        <p:nvSpPr>
+          <p:cNvPr id="5" name="TextBox 4"/>
+          <p:cNvSpPr txBox="1"/>
+          <p:nvPr/>
+        </p:nvSpPr>
+        <p:spPr>
+          <a:xfrm>
+            <a:off x="548640" y="1645920"/>
+            <a:ext cx="11064240" cy="4480560"/>
+          </a:xfrm>
+          <a:prstGeom prst="rect">
+            <a:avLst/>
+          </a:prstGeom>
+          <a:noFill/>
+        </p:spPr>
+        <p:txBody>
+          <a:bodyPr wrap="square" anchor="t">
+            <a:spAutoFit/>
+          </a:bodyPr>
+          <a:lstStyle/>
+          <a:p>
+            <a:pPr>
+              <a:spcAft>
+                <a:spcPts val="1200"/>
+              </a:spcAft>
+            </a:pPr>
+            <a:r>
+              <a:rPr sz="1800">
+                <a:solidFill>
+                  <a:srgbClr val="272E3B"/>
+                </a:solidFill>
+              </a:rPr>
+              <a:t>•  Content/UI changes: just deploy to your HTTPS host - users get them automatically</a:t>
+            </a:r>
+          </a:p>
+          <a:p>
+            <a:pPr>
+              <a:spcAft>
+                <a:spcPts val="1200"/>
+              </a:spcAft>
+            </a:pPr>
+            <a:r>
+              <a:rPr sz="1800">
+                <a:solidFill>
+                  <a:srgbClr val="272E3B"/>
+                </a:solidFill>
+              </a:rPr>
+              <a:t>•  Bump the service worker cache version so clients pick up new assets</a:t>
+            </a:r>
+          </a:p>
+          <a:p>
+            <a:pPr>
+              <a:spcAft>
+                <a:spcPts val="1200"/>
+              </a:spcAft>
+            </a:pPr>
+            <a:r>
+              <a:rPr sz="1800">
+                <a:solidFill>
+                  <a:srgbClr val="272E3B"/>
+                </a:solidFill>
+              </a:rPr>
+              <a:t>•  Only repackage + resubmit when the app package version/identity changes</a:t>
+            </a:r>
+          </a:p>
+          <a:p>
+            <a:pPr>
+              <a:spcAft>
+                <a:spcPts val="1200"/>
+              </a:spcAft>
+            </a:pPr>
+            <a:r>
+              <a:rPr sz="1800">
+                <a:solidFill>
+                  <a:srgbClr val="272E3B"/>
+                </a:solidFill>
+              </a:rPr>
+              <a:t>•  Watch Partner Center for certification status, ratings, and health metrics</a:t>
+            </a:r>
+          </a:p>
+        </p:txBody>
+      </p:sp>
+      <p:sp>
+        <p:nvSpPr>
+          <p:cNvPr id="6" name="TextBox 5"/>
+          <p:cNvSpPr txBox="1"/>
+          <p:nvPr/>
+        </p:nvSpPr>
+        <p:spPr>
+          <a:xfrm>
+            <a:off x="457200" y="6419088"/>
+            <a:ext cx="11277295" cy="320040"/>
+          </a:xfrm>
+          <a:prstGeom prst="rect">
+            <a:avLst/>
+          </a:prstGeom>
+          <a:noFill/>
+        </p:spPr>
+        <p:txBody>
+          <a:bodyPr wrap="square">
+            <a:spAutoFit/>
+          </a:bodyPr>
+          <a:lstStyle/>
+          <a:p>
+            <a:pPr algn="l"/>
+            <a:r>
+              <a:rPr sz="1000">
+                <a:solidFill>
+                  <a:srgbClr val="8A93A5"/>
+                </a:solidFill>
+              </a:rPr>
+              <a:t>Publishing a PWA to the Microsoft Store</a:t>
+            </a:r>
+          </a:p>
+        </p:txBody>
+      </p:sp>
+    </p:spTree>
+  </p:cSld>
+  <p:clrMapOvr>
+    <a:masterClrMapping/>
+  </p:clrMapOvr>
+</p:sld>
+</file>
+
+<file path=ppt/slides/slide14.xml><?xml version="1.0" encoding="utf-8"?>
+<p:sld xmlns:a="http://schemas.openxmlformats.org/drawingml/2006/main" xmlns:p="http://schemas.openxmlformats.org/presentationml/2006/main" xmlns:r="http://schemas.openxmlformats.org/officeDocument/2006/relationships">
+  <p:cSld>
+    <p:spTree>
+      <p:nvGrpSpPr>
+        <p:cNvPr id="1" name=""/>
+        <p:cNvGrpSpPr/>
+        <p:nvPr/>
+      </p:nvGrpSpPr>
+      <p:grpSpPr/>
+      <p:sp>
+        <p:nvSpPr>
+          <p:cNvPr id="2" name="Rectangle 1"/>
+          <p:cNvSpPr/>
+          <p:nvPr/>
+        </p:nvSpPr>
+        <p:spPr>
+          <a:xfrm>
+            <a:off x="0" y="0"/>
+            <a:ext cx="12191695" cy="6858000"/>
+          </a:xfrm>
+          <a:prstGeom prst="rect">
+            <a:avLst/>
+          </a:prstGeom>
+          <a:solidFill>
+            <a:srgbClr val="FFFFFF"/>
+          </a:solidFill>
+          <a:ln>
+            <a:noFill/>
+          </a:ln>
+          <a:effectLst/>
+        </p:spPr>
+        <p:style>
+          <a:lnRef idx="1">
+            <a:schemeClr val="accent1"/>
+          </a:lnRef>
+          <a:fillRef idx="3">
+            <a:schemeClr val="accent1"/>
+          </a:fillRef>
+          <a:effectRef idx="2">
+            <a:schemeClr val="accent1"/>
+          </a:effectRef>
+          <a:fontRef idx="minor">
+            <a:schemeClr val="lt1"/>
+          </a:fontRef>
+        </p:style>
+        <p:txBody>
+          <a:bodyPr rtlCol="0" anchor="ctr"/>
+          <a:lstStyle/>
+          <a:p>
+            <a:pPr algn="ctr"/>
+          </a:p>
+        </p:txBody>
+      </p:sp>
+      <p:sp>
+        <p:nvSpPr>
+          <p:cNvPr id="3" name="TextBox 2"/>
+          <p:cNvSpPr txBox="1"/>
+          <p:nvPr/>
+        </p:nvSpPr>
+        <p:spPr>
+          <a:xfrm>
+            <a:off x="548640" y="457200"/>
+            <a:ext cx="11064240" cy="914400"/>
+          </a:xfrm>
+          <a:prstGeom prst="rect">
+            <a:avLst/>
+          </a:prstGeom>
+          <a:noFill/>
+        </p:spPr>
+        <p:txBody>
+          <a:bodyPr wrap="square">
+            <a:spAutoFit/>
+          </a:bodyPr>
+          <a:lstStyle/>
+          <a:p>
+            <a:r>
+              <a:rPr sz="3200" b="1">
+                <a:solidFill>
+                  <a:srgbClr val="1B2A4A"/>
+                </a:solidFill>
+              </a:rPr>
               <a:t>Reusable checklist</a:t>
             </a:r>
           </a:p>
@@ -6041,7 +6615,7 @@
                   <a:srgbClr val="1B2A4A"/>
                 </a:solidFill>
               </a:rPr>
-              <a:t>Milestone - Packaging in progress</a:t>
+              <a:t>Matching the package identity to Partner Center</a:t>
             </a:r>
           </a:p>
         </p:txBody>
@@ -6123,7 +6697,7 @@
                   <a:srgbClr val="272E3B"/>
                 </a:solidFill>
               </a:rPr>
-              <a:t>•  Live app validated and hosted at https://vijayatmicrosoft.github.io/number-tiles-pwa/</a:t>
+              <a:t>•  PWABuilder shows example placeholder values - you must overwrite them with your real Partner Center identity</a:t>
             </a:r>
           </a:p>
           <a:p>
@@ -6138,7 +6712,7 @@
                   <a:srgbClr val="272E3B"/>
                 </a:solidFill>
               </a:rPr>
-              <a:t>•  Privacy policy published at /privacy.html (required for the Store listing)</a:t>
+              <a:t>•  Package ID  =  Partner Center 'Package/Identity/Name' (the unique app identity the Store assigns)</a:t>
             </a:r>
           </a:p>
           <a:p>
@@ -6153,7 +6727,7 @@
                   <a:srgbClr val="272E3B"/>
                 </a:solidFill>
               </a:rPr>
-              <a:t>•  Ran PWABuilder against the live URL to generate the Windows package</a:t>
+              <a:t>•  Publisher ID  =  Partner Center 'Package/Identity/Publisher' (the CN=... value)</a:t>
             </a:r>
           </a:p>
           <a:p>
@@ -6168,7 +6742,7 @@
                   <a:srgbClr val="272E3B"/>
                 </a:solidFill>
               </a:rPr>
-              <a:t>•  Key step: Package ID, Publisher ID, and Publisher display name must match the reserved app in Partner Center exactly</a:t>
+              <a:t>•  Publisher display name  =  Partner Center 'Package/Properties/PublisherDisplayName'</a:t>
             </a:r>
           </a:p>
           <a:p>
@@ -6183,7 +6757,22 @@
                   <a:srgbClr val="272E3B"/>
                 </a:solidFill>
               </a:rPr>
-              <a:t>•  Output: a signed .msixbundle ready to upload to Partner Center</a:t>
+              <a:t>•  These must match exactly or Partner Center rejects the upload</a:t>
+            </a:r>
+          </a:p>
+          <a:p>
+            <a:pPr>
+              <a:spcAft>
+                <a:spcPts val="1200"/>
+              </a:spcAft>
+            </a:pPr>
+            <a:r>
+              <a:rPr sz="1800">
+                <a:solidFill>
+                  <a:srgbClr val="272E3B"/>
+                </a:solidFill>
+              </a:rPr>
+              <a:t>•  Set Version to 1.0.1 or higher - the Store reserves 1.0.0.0</a:t>
             </a:r>
           </a:p>
         </p:txBody>

</xml_diff>

<commit_message>
Add Windows package formats explainer slide
</commit_message>
<xml_diff>
--- a/Publishing-PWA-to-Microsoft-Store.pptx
+++ b/Publishing-PWA-to-Microsoft-Store.pptx
@@ -19,6 +19,7 @@
     <p:sldId id="267" r:id="rId18"/>
     <p:sldId id="268" r:id="rId19"/>
     <p:sldId id="269" r:id="rId20"/>
+    <p:sldId id="270" r:id="rId21"/>
   </p:sldIdLst>
   <p:sldSz cx="12191695" cy="6858000" type="screen4x3"/>
   <p:notesSz cx="6858000" cy="9144000"/>
@@ -3679,7 +3680,7 @@
                   <a:srgbClr val="1B2A4A"/>
                 </a:solidFill>
               </a:rPr>
-              <a:t>Milestone - Packaging in progress</a:t>
+              <a:t>Windows package formats the Store accepts</a:t>
             </a:r>
           </a:p>
         </p:txBody>
@@ -3761,7 +3762,7 @@
                   <a:srgbClr val="272E3B"/>
                 </a:solidFill>
               </a:rPr>
-              <a:t>•  Live app validated and hosted at https://vijayatmicrosoft.github.io/number-tiles-pwa/</a:t>
+              <a:t>•  MSIX family is the modern format (2018+); APPX family is the older Windows 8/10 UWP era format - same idea, newer container</a:t>
             </a:r>
           </a:p>
           <a:p>
@@ -3776,7 +3777,7 @@
                   <a:srgbClr val="272E3B"/>
                 </a:solidFill>
               </a:rPr>
-              <a:t>•  Privacy policy published at /privacy.html (required for the Store listing)</a:t>
+              <a:t>•  .msix - a single app package for one architecture (modern)</a:t>
             </a:r>
           </a:p>
           <a:p>
@@ -3791,7 +3792,7 @@
                   <a:srgbClr val="272E3B"/>
                 </a:solidFill>
               </a:rPr>
-              <a:t>•  Ran PWABuilder against the live URL to generate the Windows package</a:t>
+              <a:t>•  .msixbundle - a bundle of several .msix packages (multiple architectures and scales); PWABuilder's main output and what you upload</a:t>
             </a:r>
           </a:p>
           <a:p>
@@ -3806,7 +3807,7 @@
                   <a:srgbClr val="272E3B"/>
                 </a:solidFill>
               </a:rPr>
-              <a:t>•  Key step: Package ID, Publisher ID, and Publisher display name must match the reserved app in Partner Center exactly</a:t>
+              <a:t>•  .msixupload - a Store submission wrapper around a .msixbundle plus debug symbols; produced by Visual Studio, not needed here</a:t>
             </a:r>
           </a:p>
           <a:p>
@@ -3821,7 +3822,67 @@
                   <a:srgbClr val="272E3B"/>
                 </a:solidFill>
               </a:rPr>
-              <a:t>•  Output: a signed .msixbundle ready to upload to Partner Center</a:t>
+              <a:t>•  .appx - the original single-app package for one architecture (older)</a:t>
+            </a:r>
+          </a:p>
+          <a:p>
+            <a:pPr>
+              <a:spcAft>
+                <a:spcPts val="1200"/>
+              </a:spcAft>
+            </a:pPr>
+            <a:r>
+              <a:rPr sz="1800">
+                <a:solidFill>
+                  <a:srgbClr val="272E3B"/>
+                </a:solidFill>
+              </a:rPr>
+              <a:t>•  .appxbundle - a bundle of .appx packages; PWABuilder's classic compatibility package, also uploaded</a:t>
+            </a:r>
+          </a:p>
+          <a:p>
+            <a:pPr>
+              <a:spcAft>
+                <a:spcPts val="1200"/>
+              </a:spcAft>
+            </a:pPr>
+            <a:r>
+              <a:rPr sz="1800">
+                <a:solidFill>
+                  <a:srgbClr val="272E3B"/>
+                </a:solidFill>
+              </a:rPr>
+              <a:t>•  .appxupload - the Visual Studio wrapper around an .appxbundle plus symbols; not needed here</a:t>
+            </a:r>
+          </a:p>
+          <a:p>
+            <a:pPr>
+              <a:spcAft>
+                <a:spcPts val="1200"/>
+              </a:spcAft>
+            </a:pPr>
+            <a:r>
+              <a:rPr sz="1800">
+                <a:solidFill>
+                  <a:srgbClr val="272E3B"/>
+                </a:solidFill>
+              </a:rPr>
+              <a:t>•  .xap - legacy Windows Phone 7/8 format, essentially dead; ignore it</a:t>
+            </a:r>
+          </a:p>
+          <a:p>
+            <a:pPr>
+              <a:spcAft>
+                <a:spcPts val="1200"/>
+              </a:spcAft>
+            </a:pPr>
+            <a:r>
+              <a:rPr sz="1800">
+                <a:solidFill>
+                  <a:srgbClr val="272E3B"/>
+                </a:solidFill>
+              </a:rPr>
+              <a:t>•  Rule of thumb: msix = new, appx = old, bundle = multiple architectures, upload = VS wrapper with symbols</a:t>
             </a:r>
           </a:p>
         </p:txBody>
@@ -3950,7 +4011,7 @@
                   <a:srgbClr val="1B2A4A"/>
                 </a:solidFill>
               </a:rPr>
-              <a:t>Step 4 - Submit in Partner Center</a:t>
+              <a:t>Milestone - Packaging in progress</a:t>
             </a:r>
           </a:p>
         </p:txBody>
@@ -4032,7 +4093,7 @@
                   <a:srgbClr val="272E3B"/>
                 </a:solidFill>
               </a:rPr>
-              <a:t>•  Register a developer account once (individual ~$19 / company ~$99)</a:t>
+              <a:t>•  Live app validated and hosted at https://vijayatmicrosoft.github.io/number-tiles-pwa/</a:t>
             </a:r>
           </a:p>
           <a:p>
@@ -4047,7 +4108,7 @@
                   <a:srgbClr val="272E3B"/>
                 </a:solidFill>
               </a:rPr>
-              <a:t>•  Reserve the app name, then upload the .msixbundle under Packages</a:t>
+              <a:t>•  Privacy policy published at /privacy.html (required for the Store listing)</a:t>
             </a:r>
           </a:p>
           <a:p>
@@ -4062,7 +4123,7 @@
                   <a:srgbClr val="272E3B"/>
                 </a:solidFill>
               </a:rPr>
-              <a:t>•  Complete the listing: description, screenshots, category, age rating</a:t>
+              <a:t>•  Ran PWABuilder against the live URL to generate the Windows package</a:t>
             </a:r>
           </a:p>
           <a:p>
@@ -4077,7 +4138,7 @@
                   <a:srgbClr val="272E3B"/>
                 </a:solidFill>
               </a:rPr>
-              <a:t>•  Provide a privacy policy URL - it is required to pass certification</a:t>
+              <a:t>•  Key step: Package ID, Publisher ID, and Publisher display name must match the reserved app in Partner Center exactly</a:t>
             </a:r>
           </a:p>
           <a:p>
@@ -4092,7 +4153,7 @@
                   <a:srgbClr val="272E3B"/>
                 </a:solidFill>
               </a:rPr>
-              <a:t>•  Submit and wait for Store certification review</a:t>
+              <a:t>•  Output: a signed .msixbundle ready to upload to Partner Center</a:t>
             </a:r>
           </a:p>
         </p:txBody>
@@ -4221,7 +4282,7 @@
                   <a:srgbClr val="1B2A4A"/>
                 </a:solidFill>
               </a:rPr>
-              <a:t>Step 5 - Maintain &amp; update</a:t>
+              <a:t>Step 4 - Submit in Partner Center</a:t>
             </a:r>
           </a:p>
         </p:txBody>
@@ -4303,7 +4364,7 @@
                   <a:srgbClr val="272E3B"/>
                 </a:solidFill>
               </a:rPr>
-              <a:t>•  Content/UI changes: just deploy to your HTTPS host - users get them automatically</a:t>
+              <a:t>•  Register a developer account once (individual ~$19 / company ~$99)</a:t>
             </a:r>
           </a:p>
           <a:p>
@@ -4318,7 +4379,7 @@
                   <a:srgbClr val="272E3B"/>
                 </a:solidFill>
               </a:rPr>
-              <a:t>•  Bump the service worker cache version so clients pick up new assets</a:t>
+              <a:t>•  Reserve the app name, then upload the .msixbundle under Packages</a:t>
             </a:r>
           </a:p>
           <a:p>
@@ -4333,7 +4394,7 @@
                   <a:srgbClr val="272E3B"/>
                 </a:solidFill>
               </a:rPr>
-              <a:t>•  Only repackage + resubmit when the app package version/identity changes</a:t>
+              <a:t>•  Complete the listing: description, screenshots, category, age rating</a:t>
             </a:r>
           </a:p>
           <a:p>
@@ -4348,7 +4409,22 @@
                   <a:srgbClr val="272E3B"/>
                 </a:solidFill>
               </a:rPr>
-              <a:t>•  Watch Partner Center for certification status, ratings, and health metrics</a:t>
+              <a:t>•  Provide a privacy policy URL - it is required to pass certification</a:t>
+            </a:r>
+          </a:p>
+          <a:p>
+            <a:pPr>
+              <a:spcAft>
+                <a:spcPts val="1200"/>
+              </a:spcAft>
+            </a:pPr>
+            <a:r>
+              <a:rPr sz="1800">
+                <a:solidFill>
+                  <a:srgbClr val="272E3B"/>
+                </a:solidFill>
+              </a:rPr>
+              <a:t>•  Submit and wait for Store certification review</a:t>
             </a:r>
           </a:p>
         </p:txBody>
@@ -4396,6 +4472,262 @@
 </file>
 
 <file path=ppt/slides/slide14.xml><?xml version="1.0" encoding="utf-8"?>
+<p:sld xmlns:a="http://schemas.openxmlformats.org/drawingml/2006/main" xmlns:p="http://schemas.openxmlformats.org/presentationml/2006/main" xmlns:r="http://schemas.openxmlformats.org/officeDocument/2006/relationships">
+  <p:cSld>
+    <p:spTree>
+      <p:nvGrpSpPr>
+        <p:cNvPr id="1" name=""/>
+        <p:cNvGrpSpPr/>
+        <p:nvPr/>
+      </p:nvGrpSpPr>
+      <p:grpSpPr/>
+      <p:sp>
+        <p:nvSpPr>
+          <p:cNvPr id="2" name="Rectangle 1"/>
+          <p:cNvSpPr/>
+          <p:nvPr/>
+        </p:nvSpPr>
+        <p:spPr>
+          <a:xfrm>
+            <a:off x="0" y="0"/>
+            <a:ext cx="12191695" cy="6858000"/>
+          </a:xfrm>
+          <a:prstGeom prst="rect">
+            <a:avLst/>
+          </a:prstGeom>
+          <a:solidFill>
+            <a:srgbClr val="FFFFFF"/>
+          </a:solidFill>
+          <a:ln>
+            <a:noFill/>
+          </a:ln>
+          <a:effectLst/>
+        </p:spPr>
+        <p:style>
+          <a:lnRef idx="1">
+            <a:schemeClr val="accent1"/>
+          </a:lnRef>
+          <a:fillRef idx="3">
+            <a:schemeClr val="accent1"/>
+          </a:fillRef>
+          <a:effectRef idx="2">
+            <a:schemeClr val="accent1"/>
+          </a:effectRef>
+          <a:fontRef idx="minor">
+            <a:schemeClr val="lt1"/>
+          </a:fontRef>
+        </p:style>
+        <p:txBody>
+          <a:bodyPr rtlCol="0" anchor="ctr"/>
+          <a:lstStyle/>
+          <a:p>
+            <a:pPr algn="ctr"/>
+          </a:p>
+        </p:txBody>
+      </p:sp>
+      <p:sp>
+        <p:nvSpPr>
+          <p:cNvPr id="3" name="TextBox 2"/>
+          <p:cNvSpPr txBox="1"/>
+          <p:nvPr/>
+        </p:nvSpPr>
+        <p:spPr>
+          <a:xfrm>
+            <a:off x="548640" y="457200"/>
+            <a:ext cx="11064240" cy="914400"/>
+          </a:xfrm>
+          <a:prstGeom prst="rect">
+            <a:avLst/>
+          </a:prstGeom>
+          <a:noFill/>
+        </p:spPr>
+        <p:txBody>
+          <a:bodyPr wrap="square">
+            <a:spAutoFit/>
+          </a:bodyPr>
+          <a:lstStyle/>
+          <a:p>
+            <a:r>
+              <a:rPr sz="3200" b="1">
+                <a:solidFill>
+                  <a:srgbClr val="1B2A4A"/>
+                </a:solidFill>
+              </a:rPr>
+              <a:t>Step 5 - Maintain &amp; update</a:t>
+            </a:r>
+          </a:p>
+        </p:txBody>
+      </p:sp>
+      <p:sp>
+        <p:nvSpPr>
+          <p:cNvPr id="4" name="Rectangle 3"/>
+          <p:cNvSpPr/>
+          <p:nvPr/>
+        </p:nvSpPr>
+        <p:spPr>
+          <a:xfrm>
+            <a:off x="566928" y="1325880"/>
+            <a:ext cx="1828800" cy="54864"/>
+          </a:xfrm>
+          <a:prstGeom prst="rect">
+            <a:avLst/>
+          </a:prstGeom>
+          <a:solidFill>
+            <a:srgbClr val="4F8CFF"/>
+          </a:solidFill>
+          <a:ln>
+            <a:noFill/>
+          </a:ln>
+          <a:effectLst/>
+        </p:spPr>
+        <p:style>
+          <a:lnRef idx="1">
+            <a:schemeClr val="accent1"/>
+          </a:lnRef>
+          <a:fillRef idx="3">
+            <a:schemeClr val="accent1"/>
+          </a:fillRef>
+          <a:effectRef idx="2">
+            <a:schemeClr val="accent1"/>
+          </a:effectRef>
+          <a:fontRef idx="minor">
+            <a:schemeClr val="lt1"/>
+          </a:fontRef>
+        </p:style>
+        <p:txBody>
+          <a:bodyPr rtlCol="0" anchor="ctr"/>
+          <a:lstStyle/>
+          <a:p>
+            <a:pPr algn="ctr"/>
+          </a:p>
+        </p:txBody>
+      </p:sp>
+      <p:sp>
+        <p:nvSpPr>
+          <p:cNvPr id="5" name="TextBox 4"/>
+          <p:cNvSpPr txBox="1"/>
+          <p:nvPr/>
+        </p:nvSpPr>
+        <p:spPr>
+          <a:xfrm>
+            <a:off x="548640" y="1645920"/>
+            <a:ext cx="11064240" cy="4480560"/>
+          </a:xfrm>
+          <a:prstGeom prst="rect">
+            <a:avLst/>
+          </a:prstGeom>
+          <a:noFill/>
+        </p:spPr>
+        <p:txBody>
+          <a:bodyPr wrap="square" anchor="t">
+            <a:spAutoFit/>
+          </a:bodyPr>
+          <a:lstStyle/>
+          <a:p>
+            <a:pPr>
+              <a:spcAft>
+                <a:spcPts val="1200"/>
+              </a:spcAft>
+            </a:pPr>
+            <a:r>
+              <a:rPr sz="1800">
+                <a:solidFill>
+                  <a:srgbClr val="272E3B"/>
+                </a:solidFill>
+              </a:rPr>
+              <a:t>•  Content/UI changes: just deploy to your HTTPS host - users get them automatically</a:t>
+            </a:r>
+          </a:p>
+          <a:p>
+            <a:pPr>
+              <a:spcAft>
+                <a:spcPts val="1200"/>
+              </a:spcAft>
+            </a:pPr>
+            <a:r>
+              <a:rPr sz="1800">
+                <a:solidFill>
+                  <a:srgbClr val="272E3B"/>
+                </a:solidFill>
+              </a:rPr>
+              <a:t>•  Bump the service worker cache version so clients pick up new assets</a:t>
+            </a:r>
+          </a:p>
+          <a:p>
+            <a:pPr>
+              <a:spcAft>
+                <a:spcPts val="1200"/>
+              </a:spcAft>
+            </a:pPr>
+            <a:r>
+              <a:rPr sz="1800">
+                <a:solidFill>
+                  <a:srgbClr val="272E3B"/>
+                </a:solidFill>
+              </a:rPr>
+              <a:t>•  Only repackage + resubmit when the app package version/identity changes</a:t>
+            </a:r>
+          </a:p>
+          <a:p>
+            <a:pPr>
+              <a:spcAft>
+                <a:spcPts val="1200"/>
+              </a:spcAft>
+            </a:pPr>
+            <a:r>
+              <a:rPr sz="1800">
+                <a:solidFill>
+                  <a:srgbClr val="272E3B"/>
+                </a:solidFill>
+              </a:rPr>
+              <a:t>•  Watch Partner Center for certification status, ratings, and health metrics</a:t>
+            </a:r>
+          </a:p>
+        </p:txBody>
+      </p:sp>
+      <p:sp>
+        <p:nvSpPr>
+          <p:cNvPr id="6" name="TextBox 5"/>
+          <p:cNvSpPr txBox="1"/>
+          <p:nvPr/>
+        </p:nvSpPr>
+        <p:spPr>
+          <a:xfrm>
+            <a:off x="457200" y="6419088"/>
+            <a:ext cx="11277295" cy="320040"/>
+          </a:xfrm>
+          <a:prstGeom prst="rect">
+            <a:avLst/>
+          </a:prstGeom>
+          <a:noFill/>
+        </p:spPr>
+        <p:txBody>
+          <a:bodyPr wrap="square">
+            <a:spAutoFit/>
+          </a:bodyPr>
+          <a:lstStyle/>
+          <a:p>
+            <a:pPr algn="l"/>
+            <a:r>
+              <a:rPr sz="1000">
+                <a:solidFill>
+                  <a:srgbClr val="8A93A5"/>
+                </a:solidFill>
+              </a:rPr>
+              <a:t>Publishing a PWA to the Microsoft Store</a:t>
+            </a:r>
+          </a:p>
+        </p:txBody>
+      </p:sp>
+    </p:spTree>
+  </p:cSld>
+  <p:clrMapOvr>
+    <a:masterClrMapping/>
+  </p:clrMapOvr>
+</p:sld>
+</file>
+
+<file path=ppt/slides/slide15.xml><?xml version="1.0" encoding="utf-8"?>
 <p:sld xmlns:a="http://schemas.openxmlformats.org/drawingml/2006/main" xmlns:p="http://schemas.openxmlformats.org/presentationml/2006/main" xmlns:r="http://schemas.openxmlformats.org/officeDocument/2006/relationships">
   <p:cSld>
     <p:spTree>

</xml_diff>

<commit_message>
Add device-family and msixupload clarification slide
</commit_message>
<xml_diff>
--- a/Publishing-PWA-to-Microsoft-Store.pptx
+++ b/Publishing-PWA-to-Microsoft-Store.pptx
@@ -20,6 +20,7 @@
     <p:sldId id="268" r:id="rId19"/>
     <p:sldId id="269" r:id="rId20"/>
     <p:sldId id="270" r:id="rId21"/>
+    <p:sldId id="271" r:id="rId22"/>
   </p:sldIdLst>
   <p:sldSz cx="12191695" cy="6858000" type="screen4x3"/>
   <p:notesSz cx="6858000" cy="9144000"/>
@@ -4011,7 +4012,7 @@
                   <a:srgbClr val="1B2A4A"/>
                 </a:solidFill>
               </a:rPr>
-              <a:t>Milestone - Packaging in progress</a:t>
+              <a:t>Two upload questions clarified</a:t>
             </a:r>
           </a:p>
         </p:txBody>
@@ -4093,67 +4094,127 @@
                   <a:srgbClr val="272E3B"/>
                 </a:solidFill>
               </a:rPr>
-              <a:t>•  Live app validated and hosted at https://vijayatmicrosoft.github.io/number-tiles-pwa/</a:t>
-            </a:r>
-          </a:p>
-          <a:p>
-            <a:pPr>
-              <a:spcAft>
-                <a:spcPts val="1200"/>
-              </a:spcAft>
-            </a:pPr>
-            <a:r>
-              <a:rPr sz="1800">
-                <a:solidFill>
-                  <a:srgbClr val="272E3B"/>
-                </a:solidFill>
-              </a:rPr>
-              <a:t>•  Privacy policy published at /privacy.html (required for the Store listing)</a:t>
-            </a:r>
-          </a:p>
-          <a:p>
-            <a:pPr>
-              <a:spcAft>
-                <a:spcPts val="1200"/>
-              </a:spcAft>
-            </a:pPr>
-            <a:r>
-              <a:rPr sz="1800">
-                <a:solidFill>
-                  <a:srgbClr val="272E3B"/>
-                </a:solidFill>
-              </a:rPr>
-              <a:t>•  Ran PWABuilder against the live URL to generate the Windows package</a:t>
-            </a:r>
-          </a:p>
-          <a:p>
-            <a:pPr>
-              <a:spcAft>
-                <a:spcPts val="1200"/>
-              </a:spcAft>
-            </a:pPr>
-            <a:r>
-              <a:rPr sz="1800">
-                <a:solidFill>
-                  <a:srgbClr val="272E3B"/>
-                </a:solidFill>
-              </a:rPr>
-              <a:t>•  Key step: Package ID, Publisher ID, and Publisher display name must match the reserved app in Partner Center exactly</a:t>
-            </a:r>
-          </a:p>
-          <a:p>
-            <a:pPr>
-              <a:spcAft>
-                <a:spcPts val="1200"/>
-              </a:spcAft>
-            </a:pPr>
-            <a:r>
-              <a:rPr sz="1800">
-                <a:solidFill>
-                  <a:srgbClr val="272E3B"/>
-                </a:solidFill>
-              </a:rPr>
-              <a:t>•  Output: a signed .msixbundle ready to upload to Partner Center</a:t>
+              <a:t>•  Why pick a device family if the package already declares one?</a:t>
+            </a:r>
+          </a:p>
+          <a:p>
+            <a:pPr>
+              <a:spcAft>
+                <a:spcPts val="1200"/>
+              </a:spcAft>
+            </a:pPr>
+            <a:r>
+              <a:rPr sz="1800">
+                <a:solidFill>
+                  <a:srgbClr val="272E3B"/>
+                </a:solidFill>
+              </a:rPr>
+              <a:t>•  Package manifest (TargetDeviceFamily) = the technical capability: which OS families the package CAN run on</a:t>
+            </a:r>
+          </a:p>
+          <a:p>
+            <a:pPr>
+              <a:spcAft>
+                <a:spcPts val="1200"/>
+              </a:spcAft>
+            </a:pPr>
+            <a:r>
+              <a:rPr sz="1800">
+                <a:solidFill>
+                  <a:srgbClr val="272E3B"/>
+                </a:solidFill>
+              </a:rPr>
+              <a:t>•  Partner Center checkboxes = your distribution choice: which device families you WANT to offer the app to</a:t>
+            </a:r>
+          </a:p>
+          <a:p>
+            <a:pPr>
+              <a:spcAft>
+                <a:spcPts val="1200"/>
+              </a:spcAft>
+            </a:pPr>
+            <a:r>
+              <a:rPr sz="1800">
+                <a:solidFill>
+                  <a:srgbClr val="272E3B"/>
+                </a:solidFill>
+              </a:rPr>
+              <a:t>•  They are separate on purpose - e.g. a package could run on Xbox but you may choose not to support it</a:t>
+            </a:r>
+          </a:p>
+          <a:p>
+            <a:pPr>
+              <a:spcAft>
+                <a:spcPts val="1200"/>
+              </a:spcAft>
+            </a:pPr>
+            <a:r>
+              <a:rPr sz="1800">
+                <a:solidFill>
+                  <a:srgbClr val="272E3B"/>
+                </a:solidFill>
+              </a:rPr>
+              <a:t>•  If no box is checked, the Store has no market to list the app in, so you must opt in (check Windows 10/11 Desktop)</a:t>
+            </a:r>
+          </a:p>
+          <a:p>
+            <a:pPr>
+              <a:spcAft>
+                <a:spcPts val="1200"/>
+              </a:spcAft>
+            </a:pPr>
+            <a:r>
+              <a:rPr sz="1800">
+                <a:solidFill>
+                  <a:srgbClr val="272E3B"/>
+                </a:solidFill>
+              </a:rPr>
+              <a:t>•  Why is .msixupload not needed for a PWA?</a:t>
+            </a:r>
+          </a:p>
+          <a:p>
+            <a:pPr>
+              <a:spcAft>
+                <a:spcPts val="1200"/>
+              </a:spcAft>
+            </a:pPr>
+            <a:r>
+              <a:rPr sz="1800">
+                <a:solidFill>
+                  <a:srgbClr val="272E3B"/>
+                </a:solidFill>
+              </a:rPr>
+              <a:t>•  It is a Visual Studio wrapper that bundles native debug symbols (.appxsym) for crash analysis</a:t>
+            </a:r>
+          </a:p>
+          <a:p>
+            <a:pPr>
+              <a:spcAft>
+                <a:spcPts val="1200"/>
+              </a:spcAft>
+            </a:pPr>
+            <a:r>
+              <a:rPr sz="1800">
+                <a:solidFill>
+                  <a:srgbClr val="272E3B"/>
+                </a:solidFill>
+              </a:rPr>
+              <a:t>•  PWABuilder does not produce one, and the Store accepts .msixbundle directly</a:t>
+            </a:r>
+          </a:p>
+          <a:p>
+            <a:pPr>
+              <a:spcAft>
+                <a:spcPts val="1200"/>
+              </a:spcAft>
+            </a:pPr>
+            <a:r>
+              <a:rPr sz="1800">
+                <a:solidFill>
+                  <a:srgbClr val="272E3B"/>
+                </a:solidFill>
+              </a:rPr>
+              <a:t>•  A PWA is HTML, CSS, and JavaScript with no native compiled code, so there are no symbols to ship - the format is irrelevant</a:t>
             </a:r>
           </a:p>
         </p:txBody>
@@ -4282,7 +4343,7 @@
                   <a:srgbClr val="1B2A4A"/>
                 </a:solidFill>
               </a:rPr>
-              <a:t>Step 4 - Submit in Partner Center</a:t>
+              <a:t>Milestone - Packaging in progress</a:t>
             </a:r>
           </a:p>
         </p:txBody>
@@ -4364,67 +4425,67 @@
                   <a:srgbClr val="272E3B"/>
                 </a:solidFill>
               </a:rPr>
-              <a:t>•  Register a developer account once (individual ~$19 / company ~$99)</a:t>
-            </a:r>
-          </a:p>
-          <a:p>
-            <a:pPr>
-              <a:spcAft>
-                <a:spcPts val="1200"/>
-              </a:spcAft>
-            </a:pPr>
-            <a:r>
-              <a:rPr sz="1800">
-                <a:solidFill>
-                  <a:srgbClr val="272E3B"/>
-                </a:solidFill>
-              </a:rPr>
-              <a:t>•  Reserve the app name, then upload the .msixbundle under Packages</a:t>
-            </a:r>
-          </a:p>
-          <a:p>
-            <a:pPr>
-              <a:spcAft>
-                <a:spcPts val="1200"/>
-              </a:spcAft>
-            </a:pPr>
-            <a:r>
-              <a:rPr sz="1800">
-                <a:solidFill>
-                  <a:srgbClr val="272E3B"/>
-                </a:solidFill>
-              </a:rPr>
-              <a:t>•  Complete the listing: description, screenshots, category, age rating</a:t>
-            </a:r>
-          </a:p>
-          <a:p>
-            <a:pPr>
-              <a:spcAft>
-                <a:spcPts val="1200"/>
-              </a:spcAft>
-            </a:pPr>
-            <a:r>
-              <a:rPr sz="1800">
-                <a:solidFill>
-                  <a:srgbClr val="272E3B"/>
-                </a:solidFill>
-              </a:rPr>
-              <a:t>•  Provide a privacy policy URL - it is required to pass certification</a:t>
-            </a:r>
-          </a:p>
-          <a:p>
-            <a:pPr>
-              <a:spcAft>
-                <a:spcPts val="1200"/>
-              </a:spcAft>
-            </a:pPr>
-            <a:r>
-              <a:rPr sz="1800">
-                <a:solidFill>
-                  <a:srgbClr val="272E3B"/>
-                </a:solidFill>
-              </a:rPr>
-              <a:t>•  Submit and wait for Store certification review</a:t>
+              <a:t>•  Live app validated and hosted at https://vijayatmicrosoft.github.io/number-tiles-pwa/</a:t>
+            </a:r>
+          </a:p>
+          <a:p>
+            <a:pPr>
+              <a:spcAft>
+                <a:spcPts val="1200"/>
+              </a:spcAft>
+            </a:pPr>
+            <a:r>
+              <a:rPr sz="1800">
+                <a:solidFill>
+                  <a:srgbClr val="272E3B"/>
+                </a:solidFill>
+              </a:rPr>
+              <a:t>•  Privacy policy published at /privacy.html (required for the Store listing)</a:t>
+            </a:r>
+          </a:p>
+          <a:p>
+            <a:pPr>
+              <a:spcAft>
+                <a:spcPts val="1200"/>
+              </a:spcAft>
+            </a:pPr>
+            <a:r>
+              <a:rPr sz="1800">
+                <a:solidFill>
+                  <a:srgbClr val="272E3B"/>
+                </a:solidFill>
+              </a:rPr>
+              <a:t>•  Ran PWABuilder against the live URL to generate the Windows package</a:t>
+            </a:r>
+          </a:p>
+          <a:p>
+            <a:pPr>
+              <a:spcAft>
+                <a:spcPts val="1200"/>
+              </a:spcAft>
+            </a:pPr>
+            <a:r>
+              <a:rPr sz="1800">
+                <a:solidFill>
+                  <a:srgbClr val="272E3B"/>
+                </a:solidFill>
+              </a:rPr>
+              <a:t>•  Key step: Package ID, Publisher ID, and Publisher display name must match the reserved app in Partner Center exactly</a:t>
+            </a:r>
+          </a:p>
+          <a:p>
+            <a:pPr>
+              <a:spcAft>
+                <a:spcPts val="1200"/>
+              </a:spcAft>
+            </a:pPr>
+            <a:r>
+              <a:rPr sz="1800">
+                <a:solidFill>
+                  <a:srgbClr val="272E3B"/>
+                </a:solidFill>
+              </a:rPr>
+              <a:t>•  Output: a signed .msixbundle ready to upload to Partner Center</a:t>
             </a:r>
           </a:p>
         </p:txBody>
@@ -4553,7 +4614,7 @@
                   <a:srgbClr val="1B2A4A"/>
                 </a:solidFill>
               </a:rPr>
-              <a:t>Step 5 - Maintain &amp; update</a:t>
+              <a:t>Step 4 - Submit in Partner Center</a:t>
             </a:r>
           </a:p>
         </p:txBody>
@@ -4635,52 +4696,67 @@
                   <a:srgbClr val="272E3B"/>
                 </a:solidFill>
               </a:rPr>
-              <a:t>•  Content/UI changes: just deploy to your HTTPS host - users get them automatically</a:t>
-            </a:r>
-          </a:p>
-          <a:p>
-            <a:pPr>
-              <a:spcAft>
-                <a:spcPts val="1200"/>
-              </a:spcAft>
-            </a:pPr>
-            <a:r>
-              <a:rPr sz="1800">
-                <a:solidFill>
-                  <a:srgbClr val="272E3B"/>
-                </a:solidFill>
-              </a:rPr>
-              <a:t>•  Bump the service worker cache version so clients pick up new assets</a:t>
-            </a:r>
-          </a:p>
-          <a:p>
-            <a:pPr>
-              <a:spcAft>
-                <a:spcPts val="1200"/>
-              </a:spcAft>
-            </a:pPr>
-            <a:r>
-              <a:rPr sz="1800">
-                <a:solidFill>
-                  <a:srgbClr val="272E3B"/>
-                </a:solidFill>
-              </a:rPr>
-              <a:t>•  Only repackage + resubmit when the app package version/identity changes</a:t>
-            </a:r>
-          </a:p>
-          <a:p>
-            <a:pPr>
-              <a:spcAft>
-                <a:spcPts val="1200"/>
-              </a:spcAft>
-            </a:pPr>
-            <a:r>
-              <a:rPr sz="1800">
-                <a:solidFill>
-                  <a:srgbClr val="272E3B"/>
-                </a:solidFill>
-              </a:rPr>
-              <a:t>•  Watch Partner Center for certification status, ratings, and health metrics</a:t>
+              <a:t>•  Register a developer account once (individual ~$19 / company ~$99)</a:t>
+            </a:r>
+          </a:p>
+          <a:p>
+            <a:pPr>
+              <a:spcAft>
+                <a:spcPts val="1200"/>
+              </a:spcAft>
+            </a:pPr>
+            <a:r>
+              <a:rPr sz="1800">
+                <a:solidFill>
+                  <a:srgbClr val="272E3B"/>
+                </a:solidFill>
+              </a:rPr>
+              <a:t>•  Reserve the app name, then upload the .msixbundle under Packages</a:t>
+            </a:r>
+          </a:p>
+          <a:p>
+            <a:pPr>
+              <a:spcAft>
+                <a:spcPts val="1200"/>
+              </a:spcAft>
+            </a:pPr>
+            <a:r>
+              <a:rPr sz="1800">
+                <a:solidFill>
+                  <a:srgbClr val="272E3B"/>
+                </a:solidFill>
+              </a:rPr>
+              <a:t>•  Complete the listing: description, screenshots, category, age rating</a:t>
+            </a:r>
+          </a:p>
+          <a:p>
+            <a:pPr>
+              <a:spcAft>
+                <a:spcPts val="1200"/>
+              </a:spcAft>
+            </a:pPr>
+            <a:r>
+              <a:rPr sz="1800">
+                <a:solidFill>
+                  <a:srgbClr val="272E3B"/>
+                </a:solidFill>
+              </a:rPr>
+              <a:t>•  Provide a privacy policy URL - it is required to pass certification</a:t>
+            </a:r>
+          </a:p>
+          <a:p>
+            <a:pPr>
+              <a:spcAft>
+                <a:spcPts val="1200"/>
+              </a:spcAft>
+            </a:pPr>
+            <a:r>
+              <a:rPr sz="1800">
+                <a:solidFill>
+                  <a:srgbClr val="272E3B"/>
+                </a:solidFill>
+              </a:rPr>
+              <a:t>•  Submit and wait for Store certification review</a:t>
             </a:r>
           </a:p>
         </p:txBody>
@@ -4728,6 +4804,262 @@
 </file>
 
 <file path=ppt/slides/slide15.xml><?xml version="1.0" encoding="utf-8"?>
+<p:sld xmlns:a="http://schemas.openxmlformats.org/drawingml/2006/main" xmlns:p="http://schemas.openxmlformats.org/presentationml/2006/main" xmlns:r="http://schemas.openxmlformats.org/officeDocument/2006/relationships">
+  <p:cSld>
+    <p:spTree>
+      <p:nvGrpSpPr>
+        <p:cNvPr id="1" name=""/>
+        <p:cNvGrpSpPr/>
+        <p:nvPr/>
+      </p:nvGrpSpPr>
+      <p:grpSpPr/>
+      <p:sp>
+        <p:nvSpPr>
+          <p:cNvPr id="2" name="Rectangle 1"/>
+          <p:cNvSpPr/>
+          <p:nvPr/>
+        </p:nvSpPr>
+        <p:spPr>
+          <a:xfrm>
+            <a:off x="0" y="0"/>
+            <a:ext cx="12191695" cy="6858000"/>
+          </a:xfrm>
+          <a:prstGeom prst="rect">
+            <a:avLst/>
+          </a:prstGeom>
+          <a:solidFill>
+            <a:srgbClr val="FFFFFF"/>
+          </a:solidFill>
+          <a:ln>
+            <a:noFill/>
+          </a:ln>
+          <a:effectLst/>
+        </p:spPr>
+        <p:style>
+          <a:lnRef idx="1">
+            <a:schemeClr val="accent1"/>
+          </a:lnRef>
+          <a:fillRef idx="3">
+            <a:schemeClr val="accent1"/>
+          </a:fillRef>
+          <a:effectRef idx="2">
+            <a:schemeClr val="accent1"/>
+          </a:effectRef>
+          <a:fontRef idx="minor">
+            <a:schemeClr val="lt1"/>
+          </a:fontRef>
+        </p:style>
+        <p:txBody>
+          <a:bodyPr rtlCol="0" anchor="ctr"/>
+          <a:lstStyle/>
+          <a:p>
+            <a:pPr algn="ctr"/>
+          </a:p>
+        </p:txBody>
+      </p:sp>
+      <p:sp>
+        <p:nvSpPr>
+          <p:cNvPr id="3" name="TextBox 2"/>
+          <p:cNvSpPr txBox="1"/>
+          <p:nvPr/>
+        </p:nvSpPr>
+        <p:spPr>
+          <a:xfrm>
+            <a:off x="548640" y="457200"/>
+            <a:ext cx="11064240" cy="914400"/>
+          </a:xfrm>
+          <a:prstGeom prst="rect">
+            <a:avLst/>
+          </a:prstGeom>
+          <a:noFill/>
+        </p:spPr>
+        <p:txBody>
+          <a:bodyPr wrap="square">
+            <a:spAutoFit/>
+          </a:bodyPr>
+          <a:lstStyle/>
+          <a:p>
+            <a:r>
+              <a:rPr sz="3200" b="1">
+                <a:solidFill>
+                  <a:srgbClr val="1B2A4A"/>
+                </a:solidFill>
+              </a:rPr>
+              <a:t>Step 5 - Maintain &amp; update</a:t>
+            </a:r>
+          </a:p>
+        </p:txBody>
+      </p:sp>
+      <p:sp>
+        <p:nvSpPr>
+          <p:cNvPr id="4" name="Rectangle 3"/>
+          <p:cNvSpPr/>
+          <p:nvPr/>
+        </p:nvSpPr>
+        <p:spPr>
+          <a:xfrm>
+            <a:off x="566928" y="1325880"/>
+            <a:ext cx="1828800" cy="54864"/>
+          </a:xfrm>
+          <a:prstGeom prst="rect">
+            <a:avLst/>
+          </a:prstGeom>
+          <a:solidFill>
+            <a:srgbClr val="4F8CFF"/>
+          </a:solidFill>
+          <a:ln>
+            <a:noFill/>
+          </a:ln>
+          <a:effectLst/>
+        </p:spPr>
+        <p:style>
+          <a:lnRef idx="1">
+            <a:schemeClr val="accent1"/>
+          </a:lnRef>
+          <a:fillRef idx="3">
+            <a:schemeClr val="accent1"/>
+          </a:fillRef>
+          <a:effectRef idx="2">
+            <a:schemeClr val="accent1"/>
+          </a:effectRef>
+          <a:fontRef idx="minor">
+            <a:schemeClr val="lt1"/>
+          </a:fontRef>
+        </p:style>
+        <p:txBody>
+          <a:bodyPr rtlCol="0" anchor="ctr"/>
+          <a:lstStyle/>
+          <a:p>
+            <a:pPr algn="ctr"/>
+          </a:p>
+        </p:txBody>
+      </p:sp>
+      <p:sp>
+        <p:nvSpPr>
+          <p:cNvPr id="5" name="TextBox 4"/>
+          <p:cNvSpPr txBox="1"/>
+          <p:nvPr/>
+        </p:nvSpPr>
+        <p:spPr>
+          <a:xfrm>
+            <a:off x="548640" y="1645920"/>
+            <a:ext cx="11064240" cy="4480560"/>
+          </a:xfrm>
+          <a:prstGeom prst="rect">
+            <a:avLst/>
+          </a:prstGeom>
+          <a:noFill/>
+        </p:spPr>
+        <p:txBody>
+          <a:bodyPr wrap="square" anchor="t">
+            <a:spAutoFit/>
+          </a:bodyPr>
+          <a:lstStyle/>
+          <a:p>
+            <a:pPr>
+              <a:spcAft>
+                <a:spcPts val="1200"/>
+              </a:spcAft>
+            </a:pPr>
+            <a:r>
+              <a:rPr sz="1800">
+                <a:solidFill>
+                  <a:srgbClr val="272E3B"/>
+                </a:solidFill>
+              </a:rPr>
+              <a:t>•  Content/UI changes: just deploy to your HTTPS host - users get them automatically</a:t>
+            </a:r>
+          </a:p>
+          <a:p>
+            <a:pPr>
+              <a:spcAft>
+                <a:spcPts val="1200"/>
+              </a:spcAft>
+            </a:pPr>
+            <a:r>
+              <a:rPr sz="1800">
+                <a:solidFill>
+                  <a:srgbClr val="272E3B"/>
+                </a:solidFill>
+              </a:rPr>
+              <a:t>•  Bump the service worker cache version so clients pick up new assets</a:t>
+            </a:r>
+          </a:p>
+          <a:p>
+            <a:pPr>
+              <a:spcAft>
+                <a:spcPts val="1200"/>
+              </a:spcAft>
+            </a:pPr>
+            <a:r>
+              <a:rPr sz="1800">
+                <a:solidFill>
+                  <a:srgbClr val="272E3B"/>
+                </a:solidFill>
+              </a:rPr>
+              <a:t>•  Only repackage + resubmit when the app package version/identity changes</a:t>
+            </a:r>
+          </a:p>
+          <a:p>
+            <a:pPr>
+              <a:spcAft>
+                <a:spcPts val="1200"/>
+              </a:spcAft>
+            </a:pPr>
+            <a:r>
+              <a:rPr sz="1800">
+                <a:solidFill>
+                  <a:srgbClr val="272E3B"/>
+                </a:solidFill>
+              </a:rPr>
+              <a:t>•  Watch Partner Center for certification status, ratings, and health metrics</a:t>
+            </a:r>
+          </a:p>
+        </p:txBody>
+      </p:sp>
+      <p:sp>
+        <p:nvSpPr>
+          <p:cNvPr id="6" name="TextBox 5"/>
+          <p:cNvSpPr txBox="1"/>
+          <p:nvPr/>
+        </p:nvSpPr>
+        <p:spPr>
+          <a:xfrm>
+            <a:off x="457200" y="6419088"/>
+            <a:ext cx="11277295" cy="320040"/>
+          </a:xfrm>
+          <a:prstGeom prst="rect">
+            <a:avLst/>
+          </a:prstGeom>
+          <a:noFill/>
+        </p:spPr>
+        <p:txBody>
+          <a:bodyPr wrap="square">
+            <a:spAutoFit/>
+          </a:bodyPr>
+          <a:lstStyle/>
+          <a:p>
+            <a:pPr algn="l"/>
+            <a:r>
+              <a:rPr sz="1000">
+                <a:solidFill>
+                  <a:srgbClr val="8A93A5"/>
+                </a:solidFill>
+              </a:rPr>
+              <a:t>Publishing a PWA to the Microsoft Store</a:t>
+            </a:r>
+          </a:p>
+        </p:txBody>
+      </p:sp>
+    </p:spTree>
+  </p:cSld>
+  <p:clrMapOvr>
+    <a:masterClrMapping/>
+  </p:clrMapOvr>
+</p:sld>
+</file>
+
+<file path=ppt/slides/slide16.xml><?xml version="1.0" encoding="utf-8"?>
 <p:sld xmlns:a="http://schemas.openxmlformats.org/drawingml/2006/main" xmlns:p="http://schemas.openxmlformats.org/presentationml/2006/main" xmlns:r="http://schemas.openxmlformats.org/officeDocument/2006/relationships">
   <p:cSld>
     <p:spTree>

</xml_diff>

<commit_message>
Add PWABuilder role and pipeline slides
</commit_message>
<xml_diff>
--- a/Publishing-PWA-to-Microsoft-Store.pptx
+++ b/Publishing-PWA-to-Microsoft-Store.pptx
@@ -21,6 +21,8 @@
     <p:sldId id="269" r:id="rId20"/>
     <p:sldId id="270" r:id="rId21"/>
     <p:sldId id="271" r:id="rId22"/>
+    <p:sldId id="272" r:id="rId23"/>
+    <p:sldId id="273" r:id="rId24"/>
   </p:sldIdLst>
   <p:sldSz cx="12191695" cy="6858000" type="screen4x3"/>
   <p:notesSz cx="6858000" cy="9144000"/>
@@ -3380,7 +3382,7 @@
                   <a:srgbClr val="1B2A4A"/>
                 </a:solidFill>
               </a:rPr>
-              <a:t>What is inside the PWABuilder package</a:t>
+              <a:t>Where PWABuilder sits in the pipeline</a:t>
             </a:r>
           </a:p>
         </p:txBody>
@@ -3462,97 +3464,67 @@
                   <a:srgbClr val="272E3B"/>
                 </a:solidFill>
               </a:rPr>
-              <a:t>•  .msixbundle - the main Store package; upload this to Partner Center</a:t>
-            </a:r>
-          </a:p>
-          <a:p>
-            <a:pPr>
-              <a:spcAft>
-                <a:spcPts val="1200"/>
-              </a:spcAft>
-            </a:pPr>
-            <a:r>
-              <a:rPr sz="1800">
-                <a:solidFill>
-                  <a:srgbClr val="272E3B"/>
-                </a:solidFill>
-              </a:rPr>
-              <a:t>•  .classic.appxbundle - compatibility package for older Windows 10; also upload this to Partner Center</a:t>
-            </a:r>
-          </a:p>
-          <a:p>
-            <a:pPr>
-              <a:spcAft>
-                <a:spcPts val="1200"/>
-              </a:spcAft>
-            </a:pPr>
-            <a:r>
-              <a:rPr sz="1800">
-                <a:solidFill>
-                  <a:srgbClr val="272E3B"/>
-                </a:solidFill>
-              </a:rPr>
-              <a:t>•  .sideload.msix - a test copy to install locally (bypasses the Store); not uploaded</a:t>
-            </a:r>
-          </a:p>
-          <a:p>
-            <a:pPr>
-              <a:spcAft>
-                <a:spcPts val="1200"/>
-              </a:spcAft>
-            </a:pPr>
-            <a:r>
-              <a:rPr sz="1800">
-                <a:solidFill>
-                  <a:srgbClr val="272E3B"/>
-                </a:solidFill>
-              </a:rPr>
-              <a:t>•  install.ps1 - helper script that installs the sideload package and its test certificate for local testing</a:t>
-            </a:r>
-          </a:p>
-          <a:p>
-            <a:pPr>
-              <a:spcAft>
-                <a:spcPts val="1200"/>
-              </a:spcAft>
-            </a:pPr>
-            <a:r>
-              <a:rPr sz="1800">
-                <a:solidFill>
-                  <a:srgbClr val="272E3B"/>
-                </a:solidFill>
-              </a:rPr>
-              <a:t>•  utils folder - support files (test certificate and helpers) used by install.ps1</a:t>
-            </a:r>
-          </a:p>
-          <a:p>
-            <a:pPr>
-              <a:spcAft>
-                <a:spcPts val="1200"/>
-              </a:spcAft>
-            </a:pPr>
-            <a:r>
-              <a:rPr sz="1800">
-                <a:solidFill>
-                  <a:srgbClr val="272E3B"/>
-                </a:solidFill>
-              </a:rPr>
-              <a:t>•  readme.html - PWABuilder's own instructions for these files</a:t>
-            </a:r>
-          </a:p>
-          <a:p>
-            <a:pPr>
-              <a:spcAft>
-                <a:spcPts val="1200"/>
-              </a:spcAft>
-            </a:pPr>
-            <a:r>
-              <a:rPr sz="1800">
-                <a:solidFill>
-                  <a:srgbClr val="272E3B"/>
-                </a:solidFill>
-              </a:rPr>
-              <a:t>•  To submit: upload BOTH the .msixbundle and the .classic.appxbundle</a:t>
+              <a:t>•  Step 1: Your code is hosted on GitHub Pages over HTTPS, giving a live URL</a:t>
+            </a:r>
+          </a:p>
+          <a:p>
+            <a:pPr>
+              <a:spcAft>
+                <a:spcPts val="1200"/>
+              </a:spcAft>
+            </a:pPr>
+            <a:r>
+              <a:rPr sz="1800">
+                <a:solidFill>
+                  <a:srgbClr val="272E3B"/>
+                </a:solidFill>
+              </a:rPr>
+              <a:t>•  Step 2: PWABuilder reads that live URL, audits it, and wraps it into MSIX and APPX packages with your Store identity embedded</a:t>
+            </a:r>
+          </a:p>
+          <a:p>
+            <a:pPr>
+              <a:spcAft>
+                <a:spcPts val="1200"/>
+              </a:spcAft>
+            </a:pPr>
+            <a:r>
+              <a:rPr sz="1800">
+                <a:solidFill>
+                  <a:srgbClr val="272E3B"/>
+                </a:solidFill>
+              </a:rPr>
+              <a:t>•  Step 3: You upload the .msixbundle and .appxbundle to Partner Center, complete the listing, and submit</a:t>
+            </a:r>
+          </a:p>
+          <a:p>
+            <a:pPr>
+              <a:spcAft>
+                <a:spcPts val="1200"/>
+              </a:spcAft>
+            </a:pPr>
+            <a:r>
+              <a:rPr sz="1800">
+                <a:solidFill>
+                  <a:srgbClr val="272E3B"/>
+                </a:solidFill>
+              </a:rPr>
+              <a:t>•  Step 4: The Microsoft Store distributes the app; users install a native shell that loads your live site</a:t>
+            </a:r>
+          </a:p>
+          <a:p>
+            <a:pPr>
+              <a:spcAft>
+                <a:spcPts val="1200"/>
+              </a:spcAft>
+            </a:pPr>
+            <a:r>
+              <a:rPr sz="1800">
+                <a:solidFill>
+                  <a:srgbClr val="272E3B"/>
+                </a:solidFill>
+              </a:rPr>
+              <a:t>•  Key idea: hosting (GitHub Pages), packaging (PWABuilder), and distribution (Partner Center / Store) are three separate responsibilities</a:t>
             </a:r>
           </a:p>
         </p:txBody>
@@ -3681,7 +3653,7 @@
                   <a:srgbClr val="1B2A4A"/>
                 </a:solidFill>
               </a:rPr>
-              <a:t>Windows package formats the Store accepts</a:t>
+              <a:t>Matching the package identity to Partner Center</a:t>
             </a:r>
           </a:p>
         </p:txBody>
@@ -3763,127 +3735,82 @@
                   <a:srgbClr val="272E3B"/>
                 </a:solidFill>
               </a:rPr>
-              <a:t>•  MSIX family is the modern format (2018+); APPX family is the older Windows 8/10 UWP era format - same idea, newer container</a:t>
-            </a:r>
-          </a:p>
-          <a:p>
-            <a:pPr>
-              <a:spcAft>
-                <a:spcPts val="1200"/>
-              </a:spcAft>
-            </a:pPr>
-            <a:r>
-              <a:rPr sz="1800">
-                <a:solidFill>
-                  <a:srgbClr val="272E3B"/>
-                </a:solidFill>
-              </a:rPr>
-              <a:t>•  .msix - a single app package for one architecture (modern)</a:t>
-            </a:r>
-          </a:p>
-          <a:p>
-            <a:pPr>
-              <a:spcAft>
-                <a:spcPts val="1200"/>
-              </a:spcAft>
-            </a:pPr>
-            <a:r>
-              <a:rPr sz="1800">
-                <a:solidFill>
-                  <a:srgbClr val="272E3B"/>
-                </a:solidFill>
-              </a:rPr>
-              <a:t>•  .msixbundle - a bundle of several .msix packages (multiple architectures and scales); PWABuilder's main output and what you upload</a:t>
-            </a:r>
-          </a:p>
-          <a:p>
-            <a:pPr>
-              <a:spcAft>
-                <a:spcPts val="1200"/>
-              </a:spcAft>
-            </a:pPr>
-            <a:r>
-              <a:rPr sz="1800">
-                <a:solidFill>
-                  <a:srgbClr val="272E3B"/>
-                </a:solidFill>
-              </a:rPr>
-              <a:t>•  .msixupload - a Store submission wrapper around a .msixbundle plus debug symbols; produced by Visual Studio, not needed here</a:t>
-            </a:r>
-          </a:p>
-          <a:p>
-            <a:pPr>
-              <a:spcAft>
-                <a:spcPts val="1200"/>
-              </a:spcAft>
-            </a:pPr>
-            <a:r>
-              <a:rPr sz="1800">
-                <a:solidFill>
-                  <a:srgbClr val="272E3B"/>
-                </a:solidFill>
-              </a:rPr>
-              <a:t>•  .appx - the original single-app package for one architecture (older)</a:t>
-            </a:r>
-          </a:p>
-          <a:p>
-            <a:pPr>
-              <a:spcAft>
-                <a:spcPts val="1200"/>
-              </a:spcAft>
-            </a:pPr>
-            <a:r>
-              <a:rPr sz="1800">
-                <a:solidFill>
-                  <a:srgbClr val="272E3B"/>
-                </a:solidFill>
-              </a:rPr>
-              <a:t>•  .appxbundle - a bundle of .appx packages; PWABuilder's classic compatibility package, also uploaded</a:t>
-            </a:r>
-          </a:p>
-          <a:p>
-            <a:pPr>
-              <a:spcAft>
-                <a:spcPts val="1200"/>
-              </a:spcAft>
-            </a:pPr>
-            <a:r>
-              <a:rPr sz="1800">
-                <a:solidFill>
-                  <a:srgbClr val="272E3B"/>
-                </a:solidFill>
-              </a:rPr>
-              <a:t>•  .appxupload - the Visual Studio wrapper around an .appxbundle plus symbols; not needed here</a:t>
-            </a:r>
-          </a:p>
-          <a:p>
-            <a:pPr>
-              <a:spcAft>
-                <a:spcPts val="1200"/>
-              </a:spcAft>
-            </a:pPr>
-            <a:r>
-              <a:rPr sz="1800">
-                <a:solidFill>
-                  <a:srgbClr val="272E3B"/>
-                </a:solidFill>
-              </a:rPr>
-              <a:t>•  .xap - legacy Windows Phone 7/8 format, essentially dead; ignore it</a:t>
-            </a:r>
-          </a:p>
-          <a:p>
-            <a:pPr>
-              <a:spcAft>
-                <a:spcPts val="1200"/>
-              </a:spcAft>
-            </a:pPr>
-            <a:r>
-              <a:rPr sz="1800">
-                <a:solidFill>
-                  <a:srgbClr val="272E3B"/>
-                </a:solidFill>
-              </a:rPr>
-              <a:t>•  Rule of thumb: msix = new, appx = old, bundle = multiple architectures, upload = VS wrapper with symbols</a:t>
+              <a:t>•  PWABuilder shows example placeholder values - you must overwrite them with your real Partner Center identity</a:t>
+            </a:r>
+          </a:p>
+          <a:p>
+            <a:pPr>
+              <a:spcAft>
+                <a:spcPts val="1200"/>
+              </a:spcAft>
+            </a:pPr>
+            <a:r>
+              <a:rPr sz="1800">
+                <a:solidFill>
+                  <a:srgbClr val="272E3B"/>
+                </a:solidFill>
+              </a:rPr>
+              <a:t>•  Package ID  =  Partner Center 'Package/Identity/Name' (the unique app identity the Store assigns)</a:t>
+            </a:r>
+          </a:p>
+          <a:p>
+            <a:pPr>
+              <a:spcAft>
+                <a:spcPts val="1200"/>
+              </a:spcAft>
+            </a:pPr>
+            <a:r>
+              <a:rPr sz="1800">
+                <a:solidFill>
+                  <a:srgbClr val="272E3B"/>
+                </a:solidFill>
+              </a:rPr>
+              <a:t>•  Publisher ID  =  Partner Center 'Package/Identity/Publisher' (the CN=... value)</a:t>
+            </a:r>
+          </a:p>
+          <a:p>
+            <a:pPr>
+              <a:spcAft>
+                <a:spcPts val="1200"/>
+              </a:spcAft>
+            </a:pPr>
+            <a:r>
+              <a:rPr sz="1800">
+                <a:solidFill>
+                  <a:srgbClr val="272E3B"/>
+                </a:solidFill>
+              </a:rPr>
+              <a:t>•  Publisher display name  =  Partner Center 'Package/Properties/PublisherDisplayName'</a:t>
+            </a:r>
+          </a:p>
+          <a:p>
+            <a:pPr>
+              <a:spcAft>
+                <a:spcPts val="1200"/>
+              </a:spcAft>
+            </a:pPr>
+            <a:r>
+              <a:rPr sz="1800">
+                <a:solidFill>
+                  <a:srgbClr val="272E3B"/>
+                </a:solidFill>
+              </a:rPr>
+              <a:t>•  These must match exactly or Partner Center rejects the upload</a:t>
+            </a:r>
+          </a:p>
+          <a:p>
+            <a:pPr>
+              <a:spcAft>
+                <a:spcPts val="1200"/>
+              </a:spcAft>
+            </a:pPr>
+            <a:r>
+              <a:rPr sz="1800">
+                <a:solidFill>
+                  <a:srgbClr val="272E3B"/>
+                </a:solidFill>
+              </a:rPr>
+              <a:t>•  Set Version to 1.0.1 or higher - the Store reserves 1.0.0.0</a:t>
             </a:r>
           </a:p>
         </p:txBody>
@@ -4012,7 +3939,7 @@
                   <a:srgbClr val="1B2A4A"/>
                 </a:solidFill>
               </a:rPr>
-              <a:t>Two upload questions clarified</a:t>
+              <a:t>What is inside the PWABuilder package</a:t>
             </a:r>
           </a:p>
         </p:txBody>
@@ -4094,127 +4021,97 @@
                   <a:srgbClr val="272E3B"/>
                 </a:solidFill>
               </a:rPr>
-              <a:t>•  Why pick a device family if the package already declares one?</a:t>
-            </a:r>
-          </a:p>
-          <a:p>
-            <a:pPr>
-              <a:spcAft>
-                <a:spcPts val="1200"/>
-              </a:spcAft>
-            </a:pPr>
-            <a:r>
-              <a:rPr sz="1800">
-                <a:solidFill>
-                  <a:srgbClr val="272E3B"/>
-                </a:solidFill>
-              </a:rPr>
-              <a:t>•  Package manifest (TargetDeviceFamily) = the technical capability: which OS families the package CAN run on</a:t>
-            </a:r>
-          </a:p>
-          <a:p>
-            <a:pPr>
-              <a:spcAft>
-                <a:spcPts val="1200"/>
-              </a:spcAft>
-            </a:pPr>
-            <a:r>
-              <a:rPr sz="1800">
-                <a:solidFill>
-                  <a:srgbClr val="272E3B"/>
-                </a:solidFill>
-              </a:rPr>
-              <a:t>•  Partner Center checkboxes = your distribution choice: which device families you WANT to offer the app to</a:t>
-            </a:r>
-          </a:p>
-          <a:p>
-            <a:pPr>
-              <a:spcAft>
-                <a:spcPts val="1200"/>
-              </a:spcAft>
-            </a:pPr>
-            <a:r>
-              <a:rPr sz="1800">
-                <a:solidFill>
-                  <a:srgbClr val="272E3B"/>
-                </a:solidFill>
-              </a:rPr>
-              <a:t>•  They are separate on purpose - e.g. a package could run on Xbox but you may choose not to support it</a:t>
-            </a:r>
-          </a:p>
-          <a:p>
-            <a:pPr>
-              <a:spcAft>
-                <a:spcPts val="1200"/>
-              </a:spcAft>
-            </a:pPr>
-            <a:r>
-              <a:rPr sz="1800">
-                <a:solidFill>
-                  <a:srgbClr val="272E3B"/>
-                </a:solidFill>
-              </a:rPr>
-              <a:t>•  If no box is checked, the Store has no market to list the app in, so you must opt in (check Windows 10/11 Desktop)</a:t>
-            </a:r>
-          </a:p>
-          <a:p>
-            <a:pPr>
-              <a:spcAft>
-                <a:spcPts val="1200"/>
-              </a:spcAft>
-            </a:pPr>
-            <a:r>
-              <a:rPr sz="1800">
-                <a:solidFill>
-                  <a:srgbClr val="272E3B"/>
-                </a:solidFill>
-              </a:rPr>
-              <a:t>•  Why is .msixupload not needed for a PWA?</a:t>
-            </a:r>
-          </a:p>
-          <a:p>
-            <a:pPr>
-              <a:spcAft>
-                <a:spcPts val="1200"/>
-              </a:spcAft>
-            </a:pPr>
-            <a:r>
-              <a:rPr sz="1800">
-                <a:solidFill>
-                  <a:srgbClr val="272E3B"/>
-                </a:solidFill>
-              </a:rPr>
-              <a:t>•  It is a Visual Studio wrapper that bundles native debug symbols (.appxsym) for crash analysis</a:t>
-            </a:r>
-          </a:p>
-          <a:p>
-            <a:pPr>
-              <a:spcAft>
-                <a:spcPts val="1200"/>
-              </a:spcAft>
-            </a:pPr>
-            <a:r>
-              <a:rPr sz="1800">
-                <a:solidFill>
-                  <a:srgbClr val="272E3B"/>
-                </a:solidFill>
-              </a:rPr>
-              <a:t>•  PWABuilder does not produce one, and the Store accepts .msixbundle directly</a:t>
-            </a:r>
-          </a:p>
-          <a:p>
-            <a:pPr>
-              <a:spcAft>
-                <a:spcPts val="1200"/>
-              </a:spcAft>
-            </a:pPr>
-            <a:r>
-              <a:rPr sz="1800">
-                <a:solidFill>
-                  <a:srgbClr val="272E3B"/>
-                </a:solidFill>
-              </a:rPr>
-              <a:t>•  A PWA is HTML, CSS, and JavaScript with no native compiled code, so there are no symbols to ship - the format is irrelevant</a:t>
+              <a:t>•  .msixbundle - the main Store package; upload this to Partner Center</a:t>
+            </a:r>
+          </a:p>
+          <a:p>
+            <a:pPr>
+              <a:spcAft>
+                <a:spcPts val="1200"/>
+              </a:spcAft>
+            </a:pPr>
+            <a:r>
+              <a:rPr sz="1800">
+                <a:solidFill>
+                  <a:srgbClr val="272E3B"/>
+                </a:solidFill>
+              </a:rPr>
+              <a:t>•  .classic.appxbundle - compatibility package for older Windows 10; also upload this to Partner Center</a:t>
+            </a:r>
+          </a:p>
+          <a:p>
+            <a:pPr>
+              <a:spcAft>
+                <a:spcPts val="1200"/>
+              </a:spcAft>
+            </a:pPr>
+            <a:r>
+              <a:rPr sz="1800">
+                <a:solidFill>
+                  <a:srgbClr val="272E3B"/>
+                </a:solidFill>
+              </a:rPr>
+              <a:t>•  .sideload.msix - a test copy to install locally (bypasses the Store); not uploaded</a:t>
+            </a:r>
+          </a:p>
+          <a:p>
+            <a:pPr>
+              <a:spcAft>
+                <a:spcPts val="1200"/>
+              </a:spcAft>
+            </a:pPr>
+            <a:r>
+              <a:rPr sz="1800">
+                <a:solidFill>
+                  <a:srgbClr val="272E3B"/>
+                </a:solidFill>
+              </a:rPr>
+              <a:t>•  install.ps1 - helper script that installs the sideload package and its test certificate for local testing</a:t>
+            </a:r>
+          </a:p>
+          <a:p>
+            <a:pPr>
+              <a:spcAft>
+                <a:spcPts val="1200"/>
+              </a:spcAft>
+            </a:pPr>
+            <a:r>
+              <a:rPr sz="1800">
+                <a:solidFill>
+                  <a:srgbClr val="272E3B"/>
+                </a:solidFill>
+              </a:rPr>
+              <a:t>•  utils folder - support files (test certificate and helpers) used by install.ps1</a:t>
+            </a:r>
+          </a:p>
+          <a:p>
+            <a:pPr>
+              <a:spcAft>
+                <a:spcPts val="1200"/>
+              </a:spcAft>
+            </a:pPr>
+            <a:r>
+              <a:rPr sz="1800">
+                <a:solidFill>
+                  <a:srgbClr val="272E3B"/>
+                </a:solidFill>
+              </a:rPr>
+              <a:t>•  readme.html - PWABuilder's own instructions for these files</a:t>
+            </a:r>
+          </a:p>
+          <a:p>
+            <a:pPr>
+              <a:spcAft>
+                <a:spcPts val="1200"/>
+              </a:spcAft>
+            </a:pPr>
+            <a:r>
+              <a:rPr sz="1800">
+                <a:solidFill>
+                  <a:srgbClr val="272E3B"/>
+                </a:solidFill>
+              </a:rPr>
+              <a:t>•  To submit: upload BOTH the .msixbundle and the .classic.appxbundle</a:t>
             </a:r>
           </a:p>
         </p:txBody>
@@ -4343,7 +4240,7 @@
                   <a:srgbClr val="1B2A4A"/>
                 </a:solidFill>
               </a:rPr>
-              <a:t>Milestone - Packaging in progress</a:t>
+              <a:t>Windows package formats the Store accepts</a:t>
             </a:r>
           </a:p>
         </p:txBody>
@@ -4425,67 +4322,127 @@
                   <a:srgbClr val="272E3B"/>
                 </a:solidFill>
               </a:rPr>
-              <a:t>•  Live app validated and hosted at https://vijayatmicrosoft.github.io/number-tiles-pwa/</a:t>
-            </a:r>
-          </a:p>
-          <a:p>
-            <a:pPr>
-              <a:spcAft>
-                <a:spcPts val="1200"/>
-              </a:spcAft>
-            </a:pPr>
-            <a:r>
-              <a:rPr sz="1800">
-                <a:solidFill>
-                  <a:srgbClr val="272E3B"/>
-                </a:solidFill>
-              </a:rPr>
-              <a:t>•  Privacy policy published at /privacy.html (required for the Store listing)</a:t>
-            </a:r>
-          </a:p>
-          <a:p>
-            <a:pPr>
-              <a:spcAft>
-                <a:spcPts val="1200"/>
-              </a:spcAft>
-            </a:pPr>
-            <a:r>
-              <a:rPr sz="1800">
-                <a:solidFill>
-                  <a:srgbClr val="272E3B"/>
-                </a:solidFill>
-              </a:rPr>
-              <a:t>•  Ran PWABuilder against the live URL to generate the Windows package</a:t>
-            </a:r>
-          </a:p>
-          <a:p>
-            <a:pPr>
-              <a:spcAft>
-                <a:spcPts val="1200"/>
-              </a:spcAft>
-            </a:pPr>
-            <a:r>
-              <a:rPr sz="1800">
-                <a:solidFill>
-                  <a:srgbClr val="272E3B"/>
-                </a:solidFill>
-              </a:rPr>
-              <a:t>•  Key step: Package ID, Publisher ID, and Publisher display name must match the reserved app in Partner Center exactly</a:t>
-            </a:r>
-          </a:p>
-          <a:p>
-            <a:pPr>
-              <a:spcAft>
-                <a:spcPts val="1200"/>
-              </a:spcAft>
-            </a:pPr>
-            <a:r>
-              <a:rPr sz="1800">
-                <a:solidFill>
-                  <a:srgbClr val="272E3B"/>
-                </a:solidFill>
-              </a:rPr>
-              <a:t>•  Output: a signed .msixbundle ready to upload to Partner Center</a:t>
+              <a:t>•  MSIX family is the modern format (2018+); APPX family is the older Windows 8/10 UWP era format - same idea, newer container</a:t>
+            </a:r>
+          </a:p>
+          <a:p>
+            <a:pPr>
+              <a:spcAft>
+                <a:spcPts val="1200"/>
+              </a:spcAft>
+            </a:pPr>
+            <a:r>
+              <a:rPr sz="1800">
+                <a:solidFill>
+                  <a:srgbClr val="272E3B"/>
+                </a:solidFill>
+              </a:rPr>
+              <a:t>•  .msix - a single app package for one architecture (modern)</a:t>
+            </a:r>
+          </a:p>
+          <a:p>
+            <a:pPr>
+              <a:spcAft>
+                <a:spcPts val="1200"/>
+              </a:spcAft>
+            </a:pPr>
+            <a:r>
+              <a:rPr sz="1800">
+                <a:solidFill>
+                  <a:srgbClr val="272E3B"/>
+                </a:solidFill>
+              </a:rPr>
+              <a:t>•  .msixbundle - a bundle of several .msix packages (multiple architectures and scales); PWABuilder's main output and what you upload</a:t>
+            </a:r>
+          </a:p>
+          <a:p>
+            <a:pPr>
+              <a:spcAft>
+                <a:spcPts val="1200"/>
+              </a:spcAft>
+            </a:pPr>
+            <a:r>
+              <a:rPr sz="1800">
+                <a:solidFill>
+                  <a:srgbClr val="272E3B"/>
+                </a:solidFill>
+              </a:rPr>
+              <a:t>•  .msixupload - a Store submission wrapper around a .msixbundle plus debug symbols; produced by Visual Studio, not needed here</a:t>
+            </a:r>
+          </a:p>
+          <a:p>
+            <a:pPr>
+              <a:spcAft>
+                <a:spcPts val="1200"/>
+              </a:spcAft>
+            </a:pPr>
+            <a:r>
+              <a:rPr sz="1800">
+                <a:solidFill>
+                  <a:srgbClr val="272E3B"/>
+                </a:solidFill>
+              </a:rPr>
+              <a:t>•  .appx - the original single-app package for one architecture (older)</a:t>
+            </a:r>
+          </a:p>
+          <a:p>
+            <a:pPr>
+              <a:spcAft>
+                <a:spcPts val="1200"/>
+              </a:spcAft>
+            </a:pPr>
+            <a:r>
+              <a:rPr sz="1800">
+                <a:solidFill>
+                  <a:srgbClr val="272E3B"/>
+                </a:solidFill>
+              </a:rPr>
+              <a:t>•  .appxbundle - a bundle of .appx packages; PWABuilder's classic compatibility package, also uploaded</a:t>
+            </a:r>
+          </a:p>
+          <a:p>
+            <a:pPr>
+              <a:spcAft>
+                <a:spcPts val="1200"/>
+              </a:spcAft>
+            </a:pPr>
+            <a:r>
+              <a:rPr sz="1800">
+                <a:solidFill>
+                  <a:srgbClr val="272E3B"/>
+                </a:solidFill>
+              </a:rPr>
+              <a:t>•  .appxupload - the Visual Studio wrapper around an .appxbundle plus symbols; not needed here</a:t>
+            </a:r>
+          </a:p>
+          <a:p>
+            <a:pPr>
+              <a:spcAft>
+                <a:spcPts val="1200"/>
+              </a:spcAft>
+            </a:pPr>
+            <a:r>
+              <a:rPr sz="1800">
+                <a:solidFill>
+                  <a:srgbClr val="272E3B"/>
+                </a:solidFill>
+              </a:rPr>
+              <a:t>•  .xap - legacy Windows Phone 7/8 format, essentially dead; ignore it</a:t>
+            </a:r>
+          </a:p>
+          <a:p>
+            <a:pPr>
+              <a:spcAft>
+                <a:spcPts val="1200"/>
+              </a:spcAft>
+            </a:pPr>
+            <a:r>
+              <a:rPr sz="1800">
+                <a:solidFill>
+                  <a:srgbClr val="272E3B"/>
+                </a:solidFill>
+              </a:rPr>
+              <a:t>•  Rule of thumb: msix = new, appx = old, bundle = multiple architectures, upload = VS wrapper with symbols</a:t>
             </a:r>
           </a:p>
         </p:txBody>
@@ -4614,7 +4571,7 @@
                   <a:srgbClr val="1B2A4A"/>
                 </a:solidFill>
               </a:rPr>
-              <a:t>Step 4 - Submit in Partner Center</a:t>
+              <a:t>Two upload questions clarified</a:t>
             </a:r>
           </a:p>
         </p:txBody>
@@ -4696,67 +4653,127 @@
                   <a:srgbClr val="272E3B"/>
                 </a:solidFill>
               </a:rPr>
-              <a:t>•  Register a developer account once (individual ~$19 / company ~$99)</a:t>
-            </a:r>
-          </a:p>
-          <a:p>
-            <a:pPr>
-              <a:spcAft>
-                <a:spcPts val="1200"/>
-              </a:spcAft>
-            </a:pPr>
-            <a:r>
-              <a:rPr sz="1800">
-                <a:solidFill>
-                  <a:srgbClr val="272E3B"/>
-                </a:solidFill>
-              </a:rPr>
-              <a:t>•  Reserve the app name, then upload the .msixbundle under Packages</a:t>
-            </a:r>
-          </a:p>
-          <a:p>
-            <a:pPr>
-              <a:spcAft>
-                <a:spcPts val="1200"/>
-              </a:spcAft>
-            </a:pPr>
-            <a:r>
-              <a:rPr sz="1800">
-                <a:solidFill>
-                  <a:srgbClr val="272E3B"/>
-                </a:solidFill>
-              </a:rPr>
-              <a:t>•  Complete the listing: description, screenshots, category, age rating</a:t>
-            </a:r>
-          </a:p>
-          <a:p>
-            <a:pPr>
-              <a:spcAft>
-                <a:spcPts val="1200"/>
-              </a:spcAft>
-            </a:pPr>
-            <a:r>
-              <a:rPr sz="1800">
-                <a:solidFill>
-                  <a:srgbClr val="272E3B"/>
-                </a:solidFill>
-              </a:rPr>
-              <a:t>•  Provide a privacy policy URL - it is required to pass certification</a:t>
-            </a:r>
-          </a:p>
-          <a:p>
-            <a:pPr>
-              <a:spcAft>
-                <a:spcPts val="1200"/>
-              </a:spcAft>
-            </a:pPr>
-            <a:r>
-              <a:rPr sz="1800">
-                <a:solidFill>
-                  <a:srgbClr val="272E3B"/>
-                </a:solidFill>
-              </a:rPr>
-              <a:t>•  Submit and wait for Store certification review</a:t>
+              <a:t>•  Why pick a device family if the package already declares one?</a:t>
+            </a:r>
+          </a:p>
+          <a:p>
+            <a:pPr>
+              <a:spcAft>
+                <a:spcPts val="1200"/>
+              </a:spcAft>
+            </a:pPr>
+            <a:r>
+              <a:rPr sz="1800">
+                <a:solidFill>
+                  <a:srgbClr val="272E3B"/>
+                </a:solidFill>
+              </a:rPr>
+              <a:t>•  Package manifest (TargetDeviceFamily) = the technical capability: which OS families the package CAN run on</a:t>
+            </a:r>
+          </a:p>
+          <a:p>
+            <a:pPr>
+              <a:spcAft>
+                <a:spcPts val="1200"/>
+              </a:spcAft>
+            </a:pPr>
+            <a:r>
+              <a:rPr sz="1800">
+                <a:solidFill>
+                  <a:srgbClr val="272E3B"/>
+                </a:solidFill>
+              </a:rPr>
+              <a:t>•  Partner Center checkboxes = your distribution choice: which device families you WANT to offer the app to</a:t>
+            </a:r>
+          </a:p>
+          <a:p>
+            <a:pPr>
+              <a:spcAft>
+                <a:spcPts val="1200"/>
+              </a:spcAft>
+            </a:pPr>
+            <a:r>
+              <a:rPr sz="1800">
+                <a:solidFill>
+                  <a:srgbClr val="272E3B"/>
+                </a:solidFill>
+              </a:rPr>
+              <a:t>•  They are separate on purpose - e.g. a package could run on Xbox but you may choose not to support it</a:t>
+            </a:r>
+          </a:p>
+          <a:p>
+            <a:pPr>
+              <a:spcAft>
+                <a:spcPts val="1200"/>
+              </a:spcAft>
+            </a:pPr>
+            <a:r>
+              <a:rPr sz="1800">
+                <a:solidFill>
+                  <a:srgbClr val="272E3B"/>
+                </a:solidFill>
+              </a:rPr>
+              <a:t>•  If no box is checked, the Store has no market to list the app in, so you must opt in (check Windows 10/11 Desktop)</a:t>
+            </a:r>
+          </a:p>
+          <a:p>
+            <a:pPr>
+              <a:spcAft>
+                <a:spcPts val="1200"/>
+              </a:spcAft>
+            </a:pPr>
+            <a:r>
+              <a:rPr sz="1800">
+                <a:solidFill>
+                  <a:srgbClr val="272E3B"/>
+                </a:solidFill>
+              </a:rPr>
+              <a:t>•  Why is .msixupload not needed for a PWA?</a:t>
+            </a:r>
+          </a:p>
+          <a:p>
+            <a:pPr>
+              <a:spcAft>
+                <a:spcPts val="1200"/>
+              </a:spcAft>
+            </a:pPr>
+            <a:r>
+              <a:rPr sz="1800">
+                <a:solidFill>
+                  <a:srgbClr val="272E3B"/>
+                </a:solidFill>
+              </a:rPr>
+              <a:t>•  It is a Visual Studio wrapper that bundles native debug symbols (.appxsym) for crash analysis</a:t>
+            </a:r>
+          </a:p>
+          <a:p>
+            <a:pPr>
+              <a:spcAft>
+                <a:spcPts val="1200"/>
+              </a:spcAft>
+            </a:pPr>
+            <a:r>
+              <a:rPr sz="1800">
+                <a:solidFill>
+                  <a:srgbClr val="272E3B"/>
+                </a:solidFill>
+              </a:rPr>
+              <a:t>•  PWABuilder does not produce one, and the Store accepts .msixbundle directly</a:t>
+            </a:r>
+          </a:p>
+          <a:p>
+            <a:pPr>
+              <a:spcAft>
+                <a:spcPts val="1200"/>
+              </a:spcAft>
+            </a:pPr>
+            <a:r>
+              <a:rPr sz="1800">
+                <a:solidFill>
+                  <a:srgbClr val="272E3B"/>
+                </a:solidFill>
+              </a:rPr>
+              <a:t>•  A PWA is HTML, CSS, and JavaScript with no native compiled code, so there are no symbols to ship - the format is irrelevant</a:t>
             </a:r>
           </a:p>
         </p:txBody>
@@ -4885,7 +4902,7 @@
                   <a:srgbClr val="1B2A4A"/>
                 </a:solidFill>
               </a:rPr>
-              <a:t>Step 5 - Maintain &amp; update</a:t>
+              <a:t>Milestone - Packaging in progress</a:t>
             </a:r>
           </a:p>
         </p:txBody>
@@ -4967,52 +4984,67 @@
                   <a:srgbClr val="272E3B"/>
                 </a:solidFill>
               </a:rPr>
-              <a:t>•  Content/UI changes: just deploy to your HTTPS host - users get them automatically</a:t>
-            </a:r>
-          </a:p>
-          <a:p>
-            <a:pPr>
-              <a:spcAft>
-                <a:spcPts val="1200"/>
-              </a:spcAft>
-            </a:pPr>
-            <a:r>
-              <a:rPr sz="1800">
-                <a:solidFill>
-                  <a:srgbClr val="272E3B"/>
-                </a:solidFill>
-              </a:rPr>
-              <a:t>•  Bump the service worker cache version so clients pick up new assets</a:t>
-            </a:r>
-          </a:p>
-          <a:p>
-            <a:pPr>
-              <a:spcAft>
-                <a:spcPts val="1200"/>
-              </a:spcAft>
-            </a:pPr>
-            <a:r>
-              <a:rPr sz="1800">
-                <a:solidFill>
-                  <a:srgbClr val="272E3B"/>
-                </a:solidFill>
-              </a:rPr>
-              <a:t>•  Only repackage + resubmit when the app package version/identity changes</a:t>
-            </a:r>
-          </a:p>
-          <a:p>
-            <a:pPr>
-              <a:spcAft>
-                <a:spcPts val="1200"/>
-              </a:spcAft>
-            </a:pPr>
-            <a:r>
-              <a:rPr sz="1800">
-                <a:solidFill>
-                  <a:srgbClr val="272E3B"/>
-                </a:solidFill>
-              </a:rPr>
-              <a:t>•  Watch Partner Center for certification status, ratings, and health metrics</a:t>
+              <a:t>•  Live app validated and hosted at https://vijayatmicrosoft.github.io/number-tiles-pwa/</a:t>
+            </a:r>
+          </a:p>
+          <a:p>
+            <a:pPr>
+              <a:spcAft>
+                <a:spcPts val="1200"/>
+              </a:spcAft>
+            </a:pPr>
+            <a:r>
+              <a:rPr sz="1800">
+                <a:solidFill>
+                  <a:srgbClr val="272E3B"/>
+                </a:solidFill>
+              </a:rPr>
+              <a:t>•  Privacy policy published at /privacy.html (required for the Store listing)</a:t>
+            </a:r>
+          </a:p>
+          <a:p>
+            <a:pPr>
+              <a:spcAft>
+                <a:spcPts val="1200"/>
+              </a:spcAft>
+            </a:pPr>
+            <a:r>
+              <a:rPr sz="1800">
+                <a:solidFill>
+                  <a:srgbClr val="272E3B"/>
+                </a:solidFill>
+              </a:rPr>
+              <a:t>•  Ran PWABuilder against the live URL to generate the Windows package</a:t>
+            </a:r>
+          </a:p>
+          <a:p>
+            <a:pPr>
+              <a:spcAft>
+                <a:spcPts val="1200"/>
+              </a:spcAft>
+            </a:pPr>
+            <a:r>
+              <a:rPr sz="1800">
+                <a:solidFill>
+                  <a:srgbClr val="272E3B"/>
+                </a:solidFill>
+              </a:rPr>
+              <a:t>•  Key step: Package ID, Publisher ID, and Publisher display name must match the reserved app in Partner Center exactly</a:t>
+            </a:r>
+          </a:p>
+          <a:p>
+            <a:pPr>
+              <a:spcAft>
+                <a:spcPts val="1200"/>
+              </a:spcAft>
+            </a:pPr>
+            <a:r>
+              <a:rPr sz="1800">
+                <a:solidFill>
+                  <a:srgbClr val="272E3B"/>
+                </a:solidFill>
+              </a:rPr>
+              <a:t>•  Output: a signed .msixbundle ready to upload to Partner Center</a:t>
             </a:r>
           </a:p>
         </p:txBody>
@@ -5141,6 +5173,533 @@
                   <a:srgbClr val="1B2A4A"/>
                 </a:solidFill>
               </a:rPr>
+              <a:t>Step 4 - Submit in Partner Center</a:t>
+            </a:r>
+          </a:p>
+        </p:txBody>
+      </p:sp>
+      <p:sp>
+        <p:nvSpPr>
+          <p:cNvPr id="4" name="Rectangle 3"/>
+          <p:cNvSpPr/>
+          <p:nvPr/>
+        </p:nvSpPr>
+        <p:spPr>
+          <a:xfrm>
+            <a:off x="566928" y="1325880"/>
+            <a:ext cx="1828800" cy="54864"/>
+          </a:xfrm>
+          <a:prstGeom prst="rect">
+            <a:avLst/>
+          </a:prstGeom>
+          <a:solidFill>
+            <a:srgbClr val="4F8CFF"/>
+          </a:solidFill>
+          <a:ln>
+            <a:noFill/>
+          </a:ln>
+          <a:effectLst/>
+        </p:spPr>
+        <p:style>
+          <a:lnRef idx="1">
+            <a:schemeClr val="accent1"/>
+          </a:lnRef>
+          <a:fillRef idx="3">
+            <a:schemeClr val="accent1"/>
+          </a:fillRef>
+          <a:effectRef idx="2">
+            <a:schemeClr val="accent1"/>
+          </a:effectRef>
+          <a:fontRef idx="minor">
+            <a:schemeClr val="lt1"/>
+          </a:fontRef>
+        </p:style>
+        <p:txBody>
+          <a:bodyPr rtlCol="0" anchor="ctr"/>
+          <a:lstStyle/>
+          <a:p>
+            <a:pPr algn="ctr"/>
+          </a:p>
+        </p:txBody>
+      </p:sp>
+      <p:sp>
+        <p:nvSpPr>
+          <p:cNvPr id="5" name="TextBox 4"/>
+          <p:cNvSpPr txBox="1"/>
+          <p:nvPr/>
+        </p:nvSpPr>
+        <p:spPr>
+          <a:xfrm>
+            <a:off x="548640" y="1645920"/>
+            <a:ext cx="11064240" cy="4480560"/>
+          </a:xfrm>
+          <a:prstGeom prst="rect">
+            <a:avLst/>
+          </a:prstGeom>
+          <a:noFill/>
+        </p:spPr>
+        <p:txBody>
+          <a:bodyPr wrap="square" anchor="t">
+            <a:spAutoFit/>
+          </a:bodyPr>
+          <a:lstStyle/>
+          <a:p>
+            <a:pPr>
+              <a:spcAft>
+                <a:spcPts val="1200"/>
+              </a:spcAft>
+            </a:pPr>
+            <a:r>
+              <a:rPr sz="1800">
+                <a:solidFill>
+                  <a:srgbClr val="272E3B"/>
+                </a:solidFill>
+              </a:rPr>
+              <a:t>•  Register a developer account once (individual ~$19 / company ~$99)</a:t>
+            </a:r>
+          </a:p>
+          <a:p>
+            <a:pPr>
+              <a:spcAft>
+                <a:spcPts val="1200"/>
+              </a:spcAft>
+            </a:pPr>
+            <a:r>
+              <a:rPr sz="1800">
+                <a:solidFill>
+                  <a:srgbClr val="272E3B"/>
+                </a:solidFill>
+              </a:rPr>
+              <a:t>•  Reserve the app name, then upload the .msixbundle under Packages</a:t>
+            </a:r>
+          </a:p>
+          <a:p>
+            <a:pPr>
+              <a:spcAft>
+                <a:spcPts val="1200"/>
+              </a:spcAft>
+            </a:pPr>
+            <a:r>
+              <a:rPr sz="1800">
+                <a:solidFill>
+                  <a:srgbClr val="272E3B"/>
+                </a:solidFill>
+              </a:rPr>
+              <a:t>•  Complete the listing: description, screenshots, category, age rating</a:t>
+            </a:r>
+          </a:p>
+          <a:p>
+            <a:pPr>
+              <a:spcAft>
+                <a:spcPts val="1200"/>
+              </a:spcAft>
+            </a:pPr>
+            <a:r>
+              <a:rPr sz="1800">
+                <a:solidFill>
+                  <a:srgbClr val="272E3B"/>
+                </a:solidFill>
+              </a:rPr>
+              <a:t>•  Provide a privacy policy URL - it is required to pass certification</a:t>
+            </a:r>
+          </a:p>
+          <a:p>
+            <a:pPr>
+              <a:spcAft>
+                <a:spcPts val="1200"/>
+              </a:spcAft>
+            </a:pPr>
+            <a:r>
+              <a:rPr sz="1800">
+                <a:solidFill>
+                  <a:srgbClr val="272E3B"/>
+                </a:solidFill>
+              </a:rPr>
+              <a:t>•  Submit and wait for Store certification review</a:t>
+            </a:r>
+          </a:p>
+        </p:txBody>
+      </p:sp>
+      <p:sp>
+        <p:nvSpPr>
+          <p:cNvPr id="6" name="TextBox 5"/>
+          <p:cNvSpPr txBox="1"/>
+          <p:nvPr/>
+        </p:nvSpPr>
+        <p:spPr>
+          <a:xfrm>
+            <a:off x="457200" y="6419088"/>
+            <a:ext cx="11277295" cy="320040"/>
+          </a:xfrm>
+          <a:prstGeom prst="rect">
+            <a:avLst/>
+          </a:prstGeom>
+          <a:noFill/>
+        </p:spPr>
+        <p:txBody>
+          <a:bodyPr wrap="square">
+            <a:spAutoFit/>
+          </a:bodyPr>
+          <a:lstStyle/>
+          <a:p>
+            <a:pPr algn="l"/>
+            <a:r>
+              <a:rPr sz="1000">
+                <a:solidFill>
+                  <a:srgbClr val="8A93A5"/>
+                </a:solidFill>
+              </a:rPr>
+              <a:t>Publishing a PWA to the Microsoft Store</a:t>
+            </a:r>
+          </a:p>
+        </p:txBody>
+      </p:sp>
+    </p:spTree>
+  </p:cSld>
+  <p:clrMapOvr>
+    <a:masterClrMapping/>
+  </p:clrMapOvr>
+</p:sld>
+</file>
+
+<file path=ppt/slides/slide17.xml><?xml version="1.0" encoding="utf-8"?>
+<p:sld xmlns:a="http://schemas.openxmlformats.org/drawingml/2006/main" xmlns:p="http://schemas.openxmlformats.org/presentationml/2006/main" xmlns:r="http://schemas.openxmlformats.org/officeDocument/2006/relationships">
+  <p:cSld>
+    <p:spTree>
+      <p:nvGrpSpPr>
+        <p:cNvPr id="1" name=""/>
+        <p:cNvGrpSpPr/>
+        <p:nvPr/>
+      </p:nvGrpSpPr>
+      <p:grpSpPr/>
+      <p:sp>
+        <p:nvSpPr>
+          <p:cNvPr id="2" name="Rectangle 1"/>
+          <p:cNvSpPr/>
+          <p:nvPr/>
+        </p:nvSpPr>
+        <p:spPr>
+          <a:xfrm>
+            <a:off x="0" y="0"/>
+            <a:ext cx="12191695" cy="6858000"/>
+          </a:xfrm>
+          <a:prstGeom prst="rect">
+            <a:avLst/>
+          </a:prstGeom>
+          <a:solidFill>
+            <a:srgbClr val="FFFFFF"/>
+          </a:solidFill>
+          <a:ln>
+            <a:noFill/>
+          </a:ln>
+          <a:effectLst/>
+        </p:spPr>
+        <p:style>
+          <a:lnRef idx="1">
+            <a:schemeClr val="accent1"/>
+          </a:lnRef>
+          <a:fillRef idx="3">
+            <a:schemeClr val="accent1"/>
+          </a:fillRef>
+          <a:effectRef idx="2">
+            <a:schemeClr val="accent1"/>
+          </a:effectRef>
+          <a:fontRef idx="minor">
+            <a:schemeClr val="lt1"/>
+          </a:fontRef>
+        </p:style>
+        <p:txBody>
+          <a:bodyPr rtlCol="0" anchor="ctr"/>
+          <a:lstStyle/>
+          <a:p>
+            <a:pPr algn="ctr"/>
+          </a:p>
+        </p:txBody>
+      </p:sp>
+      <p:sp>
+        <p:nvSpPr>
+          <p:cNvPr id="3" name="TextBox 2"/>
+          <p:cNvSpPr txBox="1"/>
+          <p:nvPr/>
+        </p:nvSpPr>
+        <p:spPr>
+          <a:xfrm>
+            <a:off x="548640" y="457200"/>
+            <a:ext cx="11064240" cy="914400"/>
+          </a:xfrm>
+          <a:prstGeom prst="rect">
+            <a:avLst/>
+          </a:prstGeom>
+          <a:noFill/>
+        </p:spPr>
+        <p:txBody>
+          <a:bodyPr wrap="square">
+            <a:spAutoFit/>
+          </a:bodyPr>
+          <a:lstStyle/>
+          <a:p>
+            <a:r>
+              <a:rPr sz="3200" b="1">
+                <a:solidFill>
+                  <a:srgbClr val="1B2A4A"/>
+                </a:solidFill>
+              </a:rPr>
+              <a:t>Step 5 - Maintain &amp; update</a:t>
+            </a:r>
+          </a:p>
+        </p:txBody>
+      </p:sp>
+      <p:sp>
+        <p:nvSpPr>
+          <p:cNvPr id="4" name="Rectangle 3"/>
+          <p:cNvSpPr/>
+          <p:nvPr/>
+        </p:nvSpPr>
+        <p:spPr>
+          <a:xfrm>
+            <a:off x="566928" y="1325880"/>
+            <a:ext cx="1828800" cy="54864"/>
+          </a:xfrm>
+          <a:prstGeom prst="rect">
+            <a:avLst/>
+          </a:prstGeom>
+          <a:solidFill>
+            <a:srgbClr val="4F8CFF"/>
+          </a:solidFill>
+          <a:ln>
+            <a:noFill/>
+          </a:ln>
+          <a:effectLst/>
+        </p:spPr>
+        <p:style>
+          <a:lnRef idx="1">
+            <a:schemeClr val="accent1"/>
+          </a:lnRef>
+          <a:fillRef idx="3">
+            <a:schemeClr val="accent1"/>
+          </a:fillRef>
+          <a:effectRef idx="2">
+            <a:schemeClr val="accent1"/>
+          </a:effectRef>
+          <a:fontRef idx="minor">
+            <a:schemeClr val="lt1"/>
+          </a:fontRef>
+        </p:style>
+        <p:txBody>
+          <a:bodyPr rtlCol="0" anchor="ctr"/>
+          <a:lstStyle/>
+          <a:p>
+            <a:pPr algn="ctr"/>
+          </a:p>
+        </p:txBody>
+      </p:sp>
+      <p:sp>
+        <p:nvSpPr>
+          <p:cNvPr id="5" name="TextBox 4"/>
+          <p:cNvSpPr txBox="1"/>
+          <p:nvPr/>
+        </p:nvSpPr>
+        <p:spPr>
+          <a:xfrm>
+            <a:off x="548640" y="1645920"/>
+            <a:ext cx="11064240" cy="4480560"/>
+          </a:xfrm>
+          <a:prstGeom prst="rect">
+            <a:avLst/>
+          </a:prstGeom>
+          <a:noFill/>
+        </p:spPr>
+        <p:txBody>
+          <a:bodyPr wrap="square" anchor="t">
+            <a:spAutoFit/>
+          </a:bodyPr>
+          <a:lstStyle/>
+          <a:p>
+            <a:pPr>
+              <a:spcAft>
+                <a:spcPts val="1200"/>
+              </a:spcAft>
+            </a:pPr>
+            <a:r>
+              <a:rPr sz="1800">
+                <a:solidFill>
+                  <a:srgbClr val="272E3B"/>
+                </a:solidFill>
+              </a:rPr>
+              <a:t>•  Content/UI changes: just deploy to your HTTPS host - users get them automatically</a:t>
+            </a:r>
+          </a:p>
+          <a:p>
+            <a:pPr>
+              <a:spcAft>
+                <a:spcPts val="1200"/>
+              </a:spcAft>
+            </a:pPr>
+            <a:r>
+              <a:rPr sz="1800">
+                <a:solidFill>
+                  <a:srgbClr val="272E3B"/>
+                </a:solidFill>
+              </a:rPr>
+              <a:t>•  Bump the service worker cache version so clients pick up new assets</a:t>
+            </a:r>
+          </a:p>
+          <a:p>
+            <a:pPr>
+              <a:spcAft>
+                <a:spcPts val="1200"/>
+              </a:spcAft>
+            </a:pPr>
+            <a:r>
+              <a:rPr sz="1800">
+                <a:solidFill>
+                  <a:srgbClr val="272E3B"/>
+                </a:solidFill>
+              </a:rPr>
+              <a:t>•  Only repackage + resubmit when the app package version/identity changes</a:t>
+            </a:r>
+          </a:p>
+          <a:p>
+            <a:pPr>
+              <a:spcAft>
+                <a:spcPts val="1200"/>
+              </a:spcAft>
+            </a:pPr>
+            <a:r>
+              <a:rPr sz="1800">
+                <a:solidFill>
+                  <a:srgbClr val="272E3B"/>
+                </a:solidFill>
+              </a:rPr>
+              <a:t>•  Watch Partner Center for certification status, ratings, and health metrics</a:t>
+            </a:r>
+          </a:p>
+        </p:txBody>
+      </p:sp>
+      <p:sp>
+        <p:nvSpPr>
+          <p:cNvPr id="6" name="TextBox 5"/>
+          <p:cNvSpPr txBox="1"/>
+          <p:nvPr/>
+        </p:nvSpPr>
+        <p:spPr>
+          <a:xfrm>
+            <a:off x="457200" y="6419088"/>
+            <a:ext cx="11277295" cy="320040"/>
+          </a:xfrm>
+          <a:prstGeom prst="rect">
+            <a:avLst/>
+          </a:prstGeom>
+          <a:noFill/>
+        </p:spPr>
+        <p:txBody>
+          <a:bodyPr wrap="square">
+            <a:spAutoFit/>
+          </a:bodyPr>
+          <a:lstStyle/>
+          <a:p>
+            <a:pPr algn="l"/>
+            <a:r>
+              <a:rPr sz="1000">
+                <a:solidFill>
+                  <a:srgbClr val="8A93A5"/>
+                </a:solidFill>
+              </a:rPr>
+              <a:t>Publishing a PWA to the Microsoft Store</a:t>
+            </a:r>
+          </a:p>
+        </p:txBody>
+      </p:sp>
+    </p:spTree>
+  </p:cSld>
+  <p:clrMapOvr>
+    <a:masterClrMapping/>
+  </p:clrMapOvr>
+</p:sld>
+</file>
+
+<file path=ppt/slides/slide18.xml><?xml version="1.0" encoding="utf-8"?>
+<p:sld xmlns:a="http://schemas.openxmlformats.org/drawingml/2006/main" xmlns:p="http://schemas.openxmlformats.org/presentationml/2006/main" xmlns:r="http://schemas.openxmlformats.org/officeDocument/2006/relationships">
+  <p:cSld>
+    <p:spTree>
+      <p:nvGrpSpPr>
+        <p:cNvPr id="1" name=""/>
+        <p:cNvGrpSpPr/>
+        <p:nvPr/>
+      </p:nvGrpSpPr>
+      <p:grpSpPr/>
+      <p:sp>
+        <p:nvSpPr>
+          <p:cNvPr id="2" name="Rectangle 1"/>
+          <p:cNvSpPr/>
+          <p:nvPr/>
+        </p:nvSpPr>
+        <p:spPr>
+          <a:xfrm>
+            <a:off x="0" y="0"/>
+            <a:ext cx="12191695" cy="6858000"/>
+          </a:xfrm>
+          <a:prstGeom prst="rect">
+            <a:avLst/>
+          </a:prstGeom>
+          <a:solidFill>
+            <a:srgbClr val="FFFFFF"/>
+          </a:solidFill>
+          <a:ln>
+            <a:noFill/>
+          </a:ln>
+          <a:effectLst/>
+        </p:spPr>
+        <p:style>
+          <a:lnRef idx="1">
+            <a:schemeClr val="accent1"/>
+          </a:lnRef>
+          <a:fillRef idx="3">
+            <a:schemeClr val="accent1"/>
+          </a:fillRef>
+          <a:effectRef idx="2">
+            <a:schemeClr val="accent1"/>
+          </a:effectRef>
+          <a:fontRef idx="minor">
+            <a:schemeClr val="lt1"/>
+          </a:fontRef>
+        </p:style>
+        <p:txBody>
+          <a:bodyPr rtlCol="0" anchor="ctr"/>
+          <a:lstStyle/>
+          <a:p>
+            <a:pPr algn="ctr"/>
+          </a:p>
+        </p:txBody>
+      </p:sp>
+      <p:sp>
+        <p:nvSpPr>
+          <p:cNvPr id="3" name="TextBox 2"/>
+          <p:cNvSpPr txBox="1"/>
+          <p:nvPr/>
+        </p:nvSpPr>
+        <p:spPr>
+          <a:xfrm>
+            <a:off x="548640" y="457200"/>
+            <a:ext cx="11064240" cy="914400"/>
+          </a:xfrm>
+          <a:prstGeom prst="rect">
+            <a:avLst/>
+          </a:prstGeom>
+          <a:noFill/>
+        </p:spPr>
+        <p:txBody>
+          <a:bodyPr wrap="square">
+            <a:spAutoFit/>
+          </a:bodyPr>
+          <a:lstStyle/>
+          <a:p>
+            <a:r>
+              <a:rPr sz="3200" b="1">
+                <a:solidFill>
+                  <a:srgbClr val="1B2A4A"/>
+                </a:solidFill>
+              </a:rPr>
               <a:t>Reusable checklist</a:t>
             </a:r>
           </a:p>
@@ -7279,7 +7838,7 @@
                   <a:srgbClr val="1B2A4A"/>
                 </a:solidFill>
               </a:rPr>
-              <a:t>Matching the package identity to Partner Center</a:t>
+              <a:t>The exact role of PWABuilder</a:t>
             </a:r>
           </a:p>
         </p:txBody>
@@ -7361,82 +7920,112 @@
                   <a:srgbClr val="272E3B"/>
                 </a:solidFill>
               </a:rPr>
-              <a:t>•  PWABuilder shows example placeholder values - you must overwrite them with your real Partner Center identity</a:t>
-            </a:r>
-          </a:p>
-          <a:p>
-            <a:pPr>
-              <a:spcAft>
-                <a:spcPts val="1200"/>
-              </a:spcAft>
-            </a:pPr>
-            <a:r>
-              <a:rPr sz="1800">
-                <a:solidFill>
-                  <a:srgbClr val="272E3B"/>
-                </a:solidFill>
-              </a:rPr>
-              <a:t>•  Package ID  =  Partner Center 'Package/Identity/Name' (the unique app identity the Store assigns)</a:t>
-            </a:r>
-          </a:p>
-          <a:p>
-            <a:pPr>
-              <a:spcAft>
-                <a:spcPts val="1200"/>
-              </a:spcAft>
-            </a:pPr>
-            <a:r>
-              <a:rPr sz="1800">
-                <a:solidFill>
-                  <a:srgbClr val="272E3B"/>
-                </a:solidFill>
-              </a:rPr>
-              <a:t>•  Publisher ID  =  Partner Center 'Package/Identity/Publisher' (the CN=... value)</a:t>
-            </a:r>
-          </a:p>
-          <a:p>
-            <a:pPr>
-              <a:spcAft>
-                <a:spcPts val="1200"/>
-              </a:spcAft>
-            </a:pPr>
-            <a:r>
-              <a:rPr sz="1800">
-                <a:solidFill>
-                  <a:srgbClr val="272E3B"/>
-                </a:solidFill>
-              </a:rPr>
-              <a:t>•  Publisher display name  =  Partner Center 'Package/Properties/PublisherDisplayName'</a:t>
-            </a:r>
-          </a:p>
-          <a:p>
-            <a:pPr>
-              <a:spcAft>
-                <a:spcPts val="1200"/>
-              </a:spcAft>
-            </a:pPr>
-            <a:r>
-              <a:rPr sz="1800">
-                <a:solidFill>
-                  <a:srgbClr val="272E3B"/>
-                </a:solidFill>
-              </a:rPr>
-              <a:t>•  These must match exactly or Partner Center rejects the upload</a:t>
-            </a:r>
-          </a:p>
-          <a:p>
-            <a:pPr>
-              <a:spcAft>
-                <a:spcPts val="1200"/>
-              </a:spcAft>
-            </a:pPr>
-            <a:r>
-              <a:rPr sz="1800">
-                <a:solidFill>
-                  <a:srgbClr val="272E3B"/>
-                </a:solidFill>
-              </a:rPr>
-              <a:t>•  Set Version to 1.0.1 or higher - the Store reserves 1.0.0.0</a:t>
+              <a:t>•  PWABuilder is the bridge between your web app and the Microsoft Store</a:t>
+            </a:r>
+          </a:p>
+          <a:p>
+            <a:pPr>
+              <a:spcAft>
+                <a:spcPts val="1200"/>
+              </a:spcAft>
+            </a:pPr>
+            <a:r>
+              <a:rPr sz="1800">
+                <a:solidFill>
+                  <a:srgbClr val="272E3B"/>
+                </a:solidFill>
+              </a:rPr>
+              <a:t>•  1. Audited the PWA: fetched the live URL and validated manifest, service worker, and HTTPS</a:t>
+            </a:r>
+          </a:p>
+          <a:p>
+            <a:pPr>
+              <a:spcAft>
+                <a:spcPts val="1200"/>
+              </a:spcAft>
+            </a:pPr>
+            <a:r>
+              <a:rPr sz="1800">
+                <a:solidFill>
+                  <a:srgbClr val="272E3B"/>
+                </a:solidFill>
+              </a:rPr>
+              <a:t>•  2. Wrapped the web app in a Windows app container (the core job): generated the native AppxManifest, embedded your Store identity (Package ID, Publisher ID), and packed icons and metadata</a:t>
+            </a:r>
+          </a:p>
+          <a:p>
+            <a:pPr>
+              <a:spcAft>
+                <a:spcPts val="1200"/>
+              </a:spcAft>
+            </a:pPr>
+            <a:r>
+              <a:rPr sz="1800">
+                <a:solidFill>
+                  <a:srgbClr val="272E3B"/>
+                </a:solidFill>
+              </a:rPr>
+              <a:t>•  3. Produced the deliverables: .msixbundle (main), .classic.appxbundle (compatibility), plus sideload test artifacts</a:t>
+            </a:r>
+          </a:p>
+          <a:p>
+            <a:pPr>
+              <a:spcAft>
+                <a:spcPts val="1200"/>
+              </a:spcAft>
+            </a:pPr>
+            <a:r>
+              <a:rPr sz="1800">
+                <a:solidFill>
+                  <a:srgbClr val="272E3B"/>
+                </a:solidFill>
+              </a:rPr>
+              <a:t>•  What it does NOT do: it does not host your app - your code still runs from GitHub Pages</a:t>
+            </a:r>
+          </a:p>
+          <a:p>
+            <a:pPr>
+              <a:spcAft>
+                <a:spcPts val="1200"/>
+              </a:spcAft>
+            </a:pPr>
+            <a:r>
+              <a:rPr sz="1800">
+                <a:solidFill>
+                  <a:srgbClr val="272E3B"/>
+                </a:solidFill>
+              </a:rPr>
+              <a:t>•  The generated package is a thin native shell that loads your live HTTPS site in a Windows WebView</a:t>
+            </a:r>
+          </a:p>
+          <a:p>
+            <a:pPr>
+              <a:spcAft>
+                <a:spcPts val="1200"/>
+              </a:spcAft>
+            </a:pPr>
+            <a:r>
+              <a:rPr sz="1800">
+                <a:solidFill>
+                  <a:srgbClr val="272E3B"/>
+                </a:solidFill>
+              </a:rPr>
+              <a:t>•  Push an update to GitHub and installed users get it automatically; PWABuilder does not run or maintain your code, and does not submit for you</a:t>
+            </a:r>
+          </a:p>
+          <a:p>
+            <a:pPr>
+              <a:spcAft>
+                <a:spcPts val="1200"/>
+              </a:spcAft>
+            </a:pPr>
+            <a:r>
+              <a:rPr sz="1800">
+                <a:solidFill>
+                  <a:srgbClr val="272E3B"/>
+                </a:solidFill>
+              </a:rPr>
+              <a:t>•  In one line: PWABuilder turns a live PWA URL into signed, Store-ready Windows packages - a packager, not a host or runtime</a:t>
             </a:r>
           </a:p>
         </p:txBody>

</xml_diff>

<commit_message>
Add Code Signing and Certificates section (divider + 5 slides)
</commit_message>
<xml_diff>
--- a/Publishing-PWA-to-Microsoft-Store.pptx
+++ b/Publishing-PWA-to-Microsoft-Store.pptx
@@ -23,6 +23,12 @@
     <p:sldId id="271" r:id="rId22"/>
     <p:sldId id="272" r:id="rId23"/>
     <p:sldId id="273" r:id="rId24"/>
+    <p:sldId id="274" r:id="rId25"/>
+    <p:sldId id="275" r:id="rId26"/>
+    <p:sldId id="276" r:id="rId27"/>
+    <p:sldId id="277" r:id="rId28"/>
+    <p:sldId id="278" r:id="rId29"/>
+    <p:sldId id="279" r:id="rId30"/>
   </p:sldIdLst>
   <p:sldSz cx="12191695" cy="6858000" type="screen4x3"/>
   <p:notesSz cx="6858000" cy="9144000"/>
@@ -5904,6 +5910,146 @@
 </p:sld>
 </file>
 
+<file path=ppt/slides/slide19.xml><?xml version="1.0" encoding="utf-8"?>
+<p:sld xmlns:a="http://schemas.openxmlformats.org/drawingml/2006/main" xmlns:p="http://schemas.openxmlformats.org/presentationml/2006/main" xmlns:r="http://schemas.openxmlformats.org/officeDocument/2006/relationships">
+  <p:cSld>
+    <p:spTree>
+      <p:nvGrpSpPr>
+        <p:cNvPr id="1" name=""/>
+        <p:cNvGrpSpPr/>
+        <p:nvPr/>
+      </p:nvGrpSpPr>
+      <p:grpSpPr/>
+      <p:sp>
+        <p:nvSpPr>
+          <p:cNvPr id="2" name="Rectangle 1"/>
+          <p:cNvSpPr/>
+          <p:nvPr/>
+        </p:nvSpPr>
+        <p:spPr>
+          <a:xfrm>
+            <a:off x="0" y="0"/>
+            <a:ext cx="12191695" cy="6858000"/>
+          </a:xfrm>
+          <a:prstGeom prst="rect">
+            <a:avLst/>
+          </a:prstGeom>
+          <a:solidFill>
+            <a:srgbClr val="11182B"/>
+          </a:solidFill>
+          <a:ln>
+            <a:noFill/>
+          </a:ln>
+          <a:effectLst/>
+        </p:spPr>
+        <p:style>
+          <a:lnRef idx="1">
+            <a:schemeClr val="accent1"/>
+          </a:lnRef>
+          <a:fillRef idx="3">
+            <a:schemeClr val="accent1"/>
+          </a:fillRef>
+          <a:effectRef idx="2">
+            <a:schemeClr val="accent1"/>
+          </a:effectRef>
+          <a:fontRef idx="minor">
+            <a:schemeClr val="lt1"/>
+          </a:fontRef>
+        </p:style>
+        <p:txBody>
+          <a:bodyPr rtlCol="0" anchor="ctr"/>
+          <a:lstStyle/>
+          <a:p>
+            <a:pPr algn="ctr"/>
+          </a:p>
+        </p:txBody>
+      </p:sp>
+      <p:sp>
+        <p:nvSpPr>
+          <p:cNvPr id="3" name="Rectangle 2"/>
+          <p:cNvSpPr/>
+          <p:nvPr/>
+        </p:nvSpPr>
+        <p:spPr>
+          <a:xfrm>
+            <a:off x="4998567" y="2606040"/>
+            <a:ext cx="2194560" cy="109728"/>
+          </a:xfrm>
+          <a:prstGeom prst="rect">
+            <a:avLst/>
+          </a:prstGeom>
+          <a:solidFill>
+            <a:srgbClr val="4F8CFF"/>
+          </a:solidFill>
+          <a:ln>
+            <a:noFill/>
+          </a:ln>
+          <a:effectLst/>
+        </p:spPr>
+        <p:style>
+          <a:lnRef idx="1">
+            <a:schemeClr val="accent1"/>
+          </a:lnRef>
+          <a:fillRef idx="3">
+            <a:schemeClr val="accent1"/>
+          </a:fillRef>
+          <a:effectRef idx="2">
+            <a:schemeClr val="accent1"/>
+          </a:effectRef>
+          <a:fontRef idx="minor">
+            <a:schemeClr val="lt1"/>
+          </a:fontRef>
+        </p:style>
+        <p:txBody>
+          <a:bodyPr rtlCol="0" anchor="ctr"/>
+          <a:lstStyle/>
+          <a:p>
+            <a:pPr algn="ctr"/>
+          </a:p>
+        </p:txBody>
+      </p:sp>
+      <p:sp>
+        <p:nvSpPr>
+          <p:cNvPr id="4" name="TextBox 3"/>
+          <p:cNvSpPr txBox="1"/>
+          <p:nvPr/>
+        </p:nvSpPr>
+        <p:spPr>
+          <a:xfrm>
+            <a:off x="822960" y="2926080"/>
+            <a:ext cx="10515600" cy="1463040"/>
+          </a:xfrm>
+          <a:prstGeom prst="rect">
+            <a:avLst/>
+          </a:prstGeom>
+          <a:noFill/>
+        </p:spPr>
+        <p:txBody>
+          <a:bodyPr wrap="square" anchor="ctr">
+            <a:spAutoFit/>
+          </a:bodyPr>
+          <a:lstStyle/>
+          <a:p>
+            <a:pPr algn="ctr"/>
+            <a:r>
+              <a:rPr sz="4000" b="1">
+                <a:solidFill>
+                  <a:srgbClr val="F5F7FA"/>
+                </a:solidFill>
+              </a:rPr>
+              <a:t>Code Signing and Certificates</a:t>
+            </a:r>
+          </a:p>
+        </p:txBody>
+      </p:sp>
+    </p:spTree>
+  </p:cSld>
+  <p:clrMapOvr>
+    <a:masterClrMapping/>
+  </p:clrMapOvr>
+</p:sld>
+</file>
+
 <file path=ppt/slides/slide2.xml><?xml version="1.0" encoding="utf-8"?>
 <p:sld xmlns:a="http://schemas.openxmlformats.org/drawingml/2006/main" xmlns:p="http://schemas.openxmlformats.org/presentationml/2006/main" xmlns:r="http://schemas.openxmlformats.org/officeDocument/2006/relationships">
   <p:cSld>
@@ -6114,6 +6260,1301 @@
                 </a:solidFill>
               </a:rPr>
               <a:t>•  Installable, offline-capable, and app-like via the manifest + service worker</a:t>
+            </a:r>
+          </a:p>
+        </p:txBody>
+      </p:sp>
+      <p:sp>
+        <p:nvSpPr>
+          <p:cNvPr id="6" name="TextBox 5"/>
+          <p:cNvSpPr txBox="1"/>
+          <p:nvPr/>
+        </p:nvSpPr>
+        <p:spPr>
+          <a:xfrm>
+            <a:off x="457200" y="6419088"/>
+            <a:ext cx="11277295" cy="320040"/>
+          </a:xfrm>
+          <a:prstGeom prst="rect">
+            <a:avLst/>
+          </a:prstGeom>
+          <a:noFill/>
+        </p:spPr>
+        <p:txBody>
+          <a:bodyPr wrap="square">
+            <a:spAutoFit/>
+          </a:bodyPr>
+          <a:lstStyle/>
+          <a:p>
+            <a:pPr algn="l"/>
+            <a:r>
+              <a:rPr sz="1000">
+                <a:solidFill>
+                  <a:srgbClr val="8A93A5"/>
+                </a:solidFill>
+              </a:rPr>
+              <a:t>Publishing a PWA to the Microsoft Store</a:t>
+            </a:r>
+          </a:p>
+        </p:txBody>
+      </p:sp>
+    </p:spTree>
+  </p:cSld>
+  <p:clrMapOvr>
+    <a:masterClrMapping/>
+  </p:clrMapOvr>
+</p:sld>
+</file>
+
+<file path=ppt/slides/slide20.xml><?xml version="1.0" encoding="utf-8"?>
+<p:sld xmlns:a="http://schemas.openxmlformats.org/drawingml/2006/main" xmlns:p="http://schemas.openxmlformats.org/presentationml/2006/main" xmlns:r="http://schemas.openxmlformats.org/officeDocument/2006/relationships">
+  <p:cSld>
+    <p:spTree>
+      <p:nvGrpSpPr>
+        <p:cNvPr id="1" name=""/>
+        <p:cNvGrpSpPr/>
+        <p:nvPr/>
+      </p:nvGrpSpPr>
+      <p:grpSpPr/>
+      <p:sp>
+        <p:nvSpPr>
+          <p:cNvPr id="2" name="Rectangle 1"/>
+          <p:cNvSpPr/>
+          <p:nvPr/>
+        </p:nvSpPr>
+        <p:spPr>
+          <a:xfrm>
+            <a:off x="0" y="0"/>
+            <a:ext cx="12191695" cy="6858000"/>
+          </a:xfrm>
+          <a:prstGeom prst="rect">
+            <a:avLst/>
+          </a:prstGeom>
+          <a:solidFill>
+            <a:srgbClr val="FFFFFF"/>
+          </a:solidFill>
+          <a:ln>
+            <a:noFill/>
+          </a:ln>
+          <a:effectLst/>
+        </p:spPr>
+        <p:style>
+          <a:lnRef idx="1">
+            <a:schemeClr val="accent1"/>
+          </a:lnRef>
+          <a:fillRef idx="3">
+            <a:schemeClr val="accent1"/>
+          </a:fillRef>
+          <a:effectRef idx="2">
+            <a:schemeClr val="accent1"/>
+          </a:effectRef>
+          <a:fontRef idx="minor">
+            <a:schemeClr val="lt1"/>
+          </a:fontRef>
+        </p:style>
+        <p:txBody>
+          <a:bodyPr rtlCol="0" anchor="ctr"/>
+          <a:lstStyle/>
+          <a:p>
+            <a:pPr algn="ctr"/>
+          </a:p>
+        </p:txBody>
+      </p:sp>
+      <p:sp>
+        <p:nvSpPr>
+          <p:cNvPr id="3" name="TextBox 2"/>
+          <p:cNvSpPr txBox="1"/>
+          <p:nvPr/>
+        </p:nvSpPr>
+        <p:spPr>
+          <a:xfrm>
+            <a:off x="548640" y="457200"/>
+            <a:ext cx="11064240" cy="914400"/>
+          </a:xfrm>
+          <a:prstGeom prst="rect">
+            <a:avLst/>
+          </a:prstGeom>
+          <a:noFill/>
+        </p:spPr>
+        <p:txBody>
+          <a:bodyPr wrap="square">
+            <a:spAutoFit/>
+          </a:bodyPr>
+          <a:lstStyle/>
+          <a:p>
+            <a:r>
+              <a:rPr sz="3200" b="1">
+                <a:solidFill>
+                  <a:srgbClr val="1B2A4A"/>
+                </a:solidFill>
+              </a:rPr>
+              <a:t>Why Windows requires signing</a:t>
+            </a:r>
+          </a:p>
+        </p:txBody>
+      </p:sp>
+      <p:sp>
+        <p:nvSpPr>
+          <p:cNvPr id="4" name="Rectangle 3"/>
+          <p:cNvSpPr/>
+          <p:nvPr/>
+        </p:nvSpPr>
+        <p:spPr>
+          <a:xfrm>
+            <a:off x="566928" y="1325880"/>
+            <a:ext cx="1828800" cy="54864"/>
+          </a:xfrm>
+          <a:prstGeom prst="rect">
+            <a:avLst/>
+          </a:prstGeom>
+          <a:solidFill>
+            <a:srgbClr val="4F8CFF"/>
+          </a:solidFill>
+          <a:ln>
+            <a:noFill/>
+          </a:ln>
+          <a:effectLst/>
+        </p:spPr>
+        <p:style>
+          <a:lnRef idx="1">
+            <a:schemeClr val="accent1"/>
+          </a:lnRef>
+          <a:fillRef idx="3">
+            <a:schemeClr val="accent1"/>
+          </a:fillRef>
+          <a:effectRef idx="2">
+            <a:schemeClr val="accent1"/>
+          </a:effectRef>
+          <a:fontRef idx="minor">
+            <a:schemeClr val="lt1"/>
+          </a:fontRef>
+        </p:style>
+        <p:txBody>
+          <a:bodyPr rtlCol="0" anchor="ctr"/>
+          <a:lstStyle/>
+          <a:p>
+            <a:pPr algn="ctr"/>
+          </a:p>
+        </p:txBody>
+      </p:sp>
+      <p:sp>
+        <p:nvSpPr>
+          <p:cNvPr id="5" name="TextBox 4"/>
+          <p:cNvSpPr txBox="1"/>
+          <p:nvPr/>
+        </p:nvSpPr>
+        <p:spPr>
+          <a:xfrm>
+            <a:off x="548640" y="1645920"/>
+            <a:ext cx="11064240" cy="4480560"/>
+          </a:xfrm>
+          <a:prstGeom prst="rect">
+            <a:avLst/>
+          </a:prstGeom>
+          <a:noFill/>
+        </p:spPr>
+        <p:txBody>
+          <a:bodyPr wrap="square" anchor="t">
+            <a:spAutoFit/>
+          </a:bodyPr>
+          <a:lstStyle/>
+          <a:p>
+            <a:pPr>
+              <a:spcAft>
+                <a:spcPts val="1200"/>
+              </a:spcAft>
+            </a:pPr>
+            <a:r>
+              <a:rPr sz="1800">
+                <a:solidFill>
+                  <a:srgbClr val="272E3B"/>
+                </a:solidFill>
+              </a:rPr>
+              <a:t>•  Windows refuses to install an unsigned MSIX or APPX package</a:t>
+            </a:r>
+          </a:p>
+          <a:p>
+            <a:pPr>
+              <a:spcAft>
+                <a:spcPts val="1200"/>
+              </a:spcAft>
+            </a:pPr>
+            <a:r>
+              <a:rPr sz="1800">
+                <a:solidFill>
+                  <a:srgbClr val="272E3B"/>
+                </a:solidFill>
+              </a:rPr>
+              <a:t>•  A signature answers two questions: who made this (authenticity) and was it changed since (integrity)</a:t>
+            </a:r>
+          </a:p>
+          <a:p>
+            <a:pPr>
+              <a:spcAft>
+                <a:spcPts val="1200"/>
+              </a:spcAft>
+            </a:pPr>
+            <a:r>
+              <a:rPr sz="1800">
+                <a:solidFill>
+                  <a:srgbClr val="272E3B"/>
+                </a:solidFill>
+              </a:rPr>
+              <a:t>•  Think of it as a tamper-proof wax seal stamped with a unique signet ring</a:t>
+            </a:r>
+          </a:p>
+        </p:txBody>
+      </p:sp>
+      <p:sp>
+        <p:nvSpPr>
+          <p:cNvPr id="6" name="TextBox 5"/>
+          <p:cNvSpPr txBox="1"/>
+          <p:nvPr/>
+        </p:nvSpPr>
+        <p:spPr>
+          <a:xfrm>
+            <a:off x="457200" y="6419088"/>
+            <a:ext cx="11277295" cy="320040"/>
+          </a:xfrm>
+          <a:prstGeom prst="rect">
+            <a:avLst/>
+          </a:prstGeom>
+          <a:noFill/>
+        </p:spPr>
+        <p:txBody>
+          <a:bodyPr wrap="square">
+            <a:spAutoFit/>
+          </a:bodyPr>
+          <a:lstStyle/>
+          <a:p>
+            <a:pPr algn="l"/>
+            <a:r>
+              <a:rPr sz="1000">
+                <a:solidFill>
+                  <a:srgbClr val="8A93A5"/>
+                </a:solidFill>
+              </a:rPr>
+              <a:t>Publishing a PWA to the Microsoft Store</a:t>
+            </a:r>
+          </a:p>
+        </p:txBody>
+      </p:sp>
+    </p:spTree>
+  </p:cSld>
+  <p:clrMapOvr>
+    <a:masterClrMapping/>
+  </p:clrMapOvr>
+</p:sld>
+</file>
+
+<file path=ppt/slides/slide21.xml><?xml version="1.0" encoding="utf-8"?>
+<p:sld xmlns:a="http://schemas.openxmlformats.org/drawingml/2006/main" xmlns:p="http://schemas.openxmlformats.org/presentationml/2006/main" xmlns:r="http://schemas.openxmlformats.org/officeDocument/2006/relationships">
+  <p:cSld>
+    <p:spTree>
+      <p:nvGrpSpPr>
+        <p:cNvPr id="1" name=""/>
+        <p:cNvGrpSpPr/>
+        <p:nvPr/>
+      </p:nvGrpSpPr>
+      <p:grpSpPr/>
+      <p:sp>
+        <p:nvSpPr>
+          <p:cNvPr id="2" name="Rectangle 1"/>
+          <p:cNvSpPr/>
+          <p:nvPr/>
+        </p:nvSpPr>
+        <p:spPr>
+          <a:xfrm>
+            <a:off x="0" y="0"/>
+            <a:ext cx="12191695" cy="6858000"/>
+          </a:xfrm>
+          <a:prstGeom prst="rect">
+            <a:avLst/>
+          </a:prstGeom>
+          <a:solidFill>
+            <a:srgbClr val="FFFFFF"/>
+          </a:solidFill>
+          <a:ln>
+            <a:noFill/>
+          </a:ln>
+          <a:effectLst/>
+        </p:spPr>
+        <p:style>
+          <a:lnRef idx="1">
+            <a:schemeClr val="accent1"/>
+          </a:lnRef>
+          <a:fillRef idx="3">
+            <a:schemeClr val="accent1"/>
+          </a:fillRef>
+          <a:effectRef idx="2">
+            <a:schemeClr val="accent1"/>
+          </a:effectRef>
+          <a:fontRef idx="minor">
+            <a:schemeClr val="lt1"/>
+          </a:fontRef>
+        </p:style>
+        <p:txBody>
+          <a:bodyPr rtlCol="0" anchor="ctr"/>
+          <a:lstStyle/>
+          <a:p>
+            <a:pPr algn="ctr"/>
+          </a:p>
+        </p:txBody>
+      </p:sp>
+      <p:sp>
+        <p:nvSpPr>
+          <p:cNvPr id="3" name="TextBox 2"/>
+          <p:cNvSpPr txBox="1"/>
+          <p:nvPr/>
+        </p:nvSpPr>
+        <p:spPr>
+          <a:xfrm>
+            <a:off x="548640" y="457200"/>
+            <a:ext cx="11064240" cy="914400"/>
+          </a:xfrm>
+          <a:prstGeom prst="rect">
+            <a:avLst/>
+          </a:prstGeom>
+          <a:noFill/>
+        </p:spPr>
+        <p:txBody>
+          <a:bodyPr wrap="square">
+            <a:spAutoFit/>
+          </a:bodyPr>
+          <a:lstStyle/>
+          <a:p>
+            <a:r>
+              <a:rPr sz="3200" b="1">
+                <a:solidFill>
+                  <a:srgbClr val="1B2A4A"/>
+                </a:solidFill>
+              </a:rPr>
+              <a:t>How a digital signature works</a:t>
+            </a:r>
+          </a:p>
+        </p:txBody>
+      </p:sp>
+      <p:sp>
+        <p:nvSpPr>
+          <p:cNvPr id="4" name="Rectangle 3"/>
+          <p:cNvSpPr/>
+          <p:nvPr/>
+        </p:nvSpPr>
+        <p:spPr>
+          <a:xfrm>
+            <a:off x="566928" y="1325880"/>
+            <a:ext cx="1828800" cy="54864"/>
+          </a:xfrm>
+          <a:prstGeom prst="rect">
+            <a:avLst/>
+          </a:prstGeom>
+          <a:solidFill>
+            <a:srgbClr val="4F8CFF"/>
+          </a:solidFill>
+          <a:ln>
+            <a:noFill/>
+          </a:ln>
+          <a:effectLst/>
+        </p:spPr>
+        <p:style>
+          <a:lnRef idx="1">
+            <a:schemeClr val="accent1"/>
+          </a:lnRef>
+          <a:fillRef idx="3">
+            <a:schemeClr val="accent1"/>
+          </a:fillRef>
+          <a:effectRef idx="2">
+            <a:schemeClr val="accent1"/>
+          </a:effectRef>
+          <a:fontRef idx="minor">
+            <a:schemeClr val="lt1"/>
+          </a:fontRef>
+        </p:style>
+        <p:txBody>
+          <a:bodyPr rtlCol="0" anchor="ctr"/>
+          <a:lstStyle/>
+          <a:p>
+            <a:pPr algn="ctr"/>
+          </a:p>
+        </p:txBody>
+      </p:sp>
+      <p:sp>
+        <p:nvSpPr>
+          <p:cNvPr id="5" name="TextBox 4"/>
+          <p:cNvSpPr txBox="1"/>
+          <p:nvPr/>
+        </p:nvSpPr>
+        <p:spPr>
+          <a:xfrm>
+            <a:off x="548640" y="1645920"/>
+            <a:ext cx="11064240" cy="4480560"/>
+          </a:xfrm>
+          <a:prstGeom prst="rect">
+            <a:avLst/>
+          </a:prstGeom>
+          <a:noFill/>
+        </p:spPr>
+        <p:txBody>
+          <a:bodyPr wrap="square" anchor="t">
+            <a:spAutoFit/>
+          </a:bodyPr>
+          <a:lstStyle/>
+          <a:p>
+            <a:pPr>
+              <a:spcAft>
+                <a:spcPts val="1200"/>
+              </a:spcAft>
+            </a:pPr>
+            <a:r>
+              <a:rPr sz="1800">
+                <a:solidFill>
+                  <a:srgbClr val="272E3B"/>
+                </a:solidFill>
+              </a:rPr>
+              <a:t>•  Uses asymmetric cryptography: a private key (secret) and a public key (shared)</a:t>
+            </a:r>
+          </a:p>
+          <a:p>
+            <a:pPr>
+              <a:spcAft>
+                <a:spcPts val="1200"/>
+              </a:spcAft>
+            </a:pPr>
+            <a:r>
+              <a:rPr sz="1800">
+                <a:solidFill>
+                  <a:srgbClr val="272E3B"/>
+                </a:solidFill>
+              </a:rPr>
+              <a:t>•  Sign: hash the package with SHA-256, then encrypt that hash with the private key to produce the signature</a:t>
+            </a:r>
+          </a:p>
+          <a:p>
+            <a:pPr>
+              <a:spcAft>
+                <a:spcPts val="1200"/>
+              </a:spcAft>
+            </a:pPr>
+            <a:r>
+              <a:rPr sz="1800">
+                <a:solidFill>
+                  <a:srgbClr val="272E3B"/>
+                </a:solidFill>
+              </a:rPr>
+              <a:t>•  Verify: Windows re-hashes the package and checks it against the signature using the public key</a:t>
+            </a:r>
+          </a:p>
+          <a:p>
+            <a:pPr>
+              <a:spcAft>
+                <a:spcPts val="1200"/>
+              </a:spcAft>
+            </a:pPr>
+            <a:r>
+              <a:rPr sz="1800">
+                <a:solidFill>
+                  <a:srgbClr val="272E3B"/>
+                </a:solidFill>
+              </a:rPr>
+              <a:t>•  If they match, the package is unmodified and was signed by the holder of the private key</a:t>
+            </a:r>
+          </a:p>
+        </p:txBody>
+      </p:sp>
+      <p:sp>
+        <p:nvSpPr>
+          <p:cNvPr id="6" name="TextBox 5"/>
+          <p:cNvSpPr txBox="1"/>
+          <p:nvPr/>
+        </p:nvSpPr>
+        <p:spPr>
+          <a:xfrm>
+            <a:off x="457200" y="6419088"/>
+            <a:ext cx="11277295" cy="320040"/>
+          </a:xfrm>
+          <a:prstGeom prst="rect">
+            <a:avLst/>
+          </a:prstGeom>
+          <a:noFill/>
+        </p:spPr>
+        <p:txBody>
+          <a:bodyPr wrap="square">
+            <a:spAutoFit/>
+          </a:bodyPr>
+          <a:lstStyle/>
+          <a:p>
+            <a:pPr algn="l"/>
+            <a:r>
+              <a:rPr sz="1000">
+                <a:solidFill>
+                  <a:srgbClr val="8A93A5"/>
+                </a:solidFill>
+              </a:rPr>
+              <a:t>Publishing a PWA to the Microsoft Store</a:t>
+            </a:r>
+          </a:p>
+        </p:txBody>
+      </p:sp>
+    </p:spTree>
+  </p:cSld>
+  <p:clrMapOvr>
+    <a:masterClrMapping/>
+  </p:clrMapOvr>
+</p:sld>
+</file>
+
+<file path=ppt/slides/slide22.xml><?xml version="1.0" encoding="utf-8"?>
+<p:sld xmlns:a="http://schemas.openxmlformats.org/drawingml/2006/main" xmlns:p="http://schemas.openxmlformats.org/presentationml/2006/main" xmlns:r="http://schemas.openxmlformats.org/officeDocument/2006/relationships">
+  <p:cSld>
+    <p:spTree>
+      <p:nvGrpSpPr>
+        <p:cNvPr id="1" name=""/>
+        <p:cNvGrpSpPr/>
+        <p:nvPr/>
+      </p:nvGrpSpPr>
+      <p:grpSpPr/>
+      <p:sp>
+        <p:nvSpPr>
+          <p:cNvPr id="2" name="Rectangle 1"/>
+          <p:cNvSpPr/>
+          <p:nvPr/>
+        </p:nvSpPr>
+        <p:spPr>
+          <a:xfrm>
+            <a:off x="0" y="0"/>
+            <a:ext cx="12191695" cy="6858000"/>
+          </a:xfrm>
+          <a:prstGeom prst="rect">
+            <a:avLst/>
+          </a:prstGeom>
+          <a:solidFill>
+            <a:srgbClr val="FFFFFF"/>
+          </a:solidFill>
+          <a:ln>
+            <a:noFill/>
+          </a:ln>
+          <a:effectLst/>
+        </p:spPr>
+        <p:style>
+          <a:lnRef idx="1">
+            <a:schemeClr val="accent1"/>
+          </a:lnRef>
+          <a:fillRef idx="3">
+            <a:schemeClr val="accent1"/>
+          </a:fillRef>
+          <a:effectRef idx="2">
+            <a:schemeClr val="accent1"/>
+          </a:effectRef>
+          <a:fontRef idx="minor">
+            <a:schemeClr val="lt1"/>
+          </a:fontRef>
+        </p:style>
+        <p:txBody>
+          <a:bodyPr rtlCol="0" anchor="ctr"/>
+          <a:lstStyle/>
+          <a:p>
+            <a:pPr algn="ctr"/>
+          </a:p>
+        </p:txBody>
+      </p:sp>
+      <p:sp>
+        <p:nvSpPr>
+          <p:cNvPr id="3" name="TextBox 2"/>
+          <p:cNvSpPr txBox="1"/>
+          <p:nvPr/>
+        </p:nvSpPr>
+        <p:spPr>
+          <a:xfrm>
+            <a:off x="548640" y="457200"/>
+            <a:ext cx="11064240" cy="914400"/>
+          </a:xfrm>
+          <a:prstGeom prst="rect">
+            <a:avLst/>
+          </a:prstGeom>
+          <a:noFill/>
+        </p:spPr>
+        <p:txBody>
+          <a:bodyPr wrap="square">
+            <a:spAutoFit/>
+          </a:bodyPr>
+          <a:lstStyle/>
+          <a:p>
+            <a:r>
+              <a:rPr sz="3200" b="1">
+                <a:solidFill>
+                  <a:srgbClr val="1B2A4A"/>
+                </a:solidFill>
+              </a:rPr>
+              <a:t>Certificates and the chain of trust</a:t>
+            </a:r>
+          </a:p>
+        </p:txBody>
+      </p:sp>
+      <p:sp>
+        <p:nvSpPr>
+          <p:cNvPr id="4" name="Rectangle 3"/>
+          <p:cNvSpPr/>
+          <p:nvPr/>
+        </p:nvSpPr>
+        <p:spPr>
+          <a:xfrm>
+            <a:off x="566928" y="1325880"/>
+            <a:ext cx="1828800" cy="54864"/>
+          </a:xfrm>
+          <a:prstGeom prst="rect">
+            <a:avLst/>
+          </a:prstGeom>
+          <a:solidFill>
+            <a:srgbClr val="4F8CFF"/>
+          </a:solidFill>
+          <a:ln>
+            <a:noFill/>
+          </a:ln>
+          <a:effectLst/>
+        </p:spPr>
+        <p:style>
+          <a:lnRef idx="1">
+            <a:schemeClr val="accent1"/>
+          </a:lnRef>
+          <a:fillRef idx="3">
+            <a:schemeClr val="accent1"/>
+          </a:fillRef>
+          <a:effectRef idx="2">
+            <a:schemeClr val="accent1"/>
+          </a:effectRef>
+          <a:fontRef idx="minor">
+            <a:schemeClr val="lt1"/>
+          </a:fontRef>
+        </p:style>
+        <p:txBody>
+          <a:bodyPr rtlCol="0" anchor="ctr"/>
+          <a:lstStyle/>
+          <a:p>
+            <a:pPr algn="ctr"/>
+          </a:p>
+        </p:txBody>
+      </p:sp>
+      <p:sp>
+        <p:nvSpPr>
+          <p:cNvPr id="5" name="TextBox 4"/>
+          <p:cNvSpPr txBox="1"/>
+          <p:nvPr/>
+        </p:nvSpPr>
+        <p:spPr>
+          <a:xfrm>
+            <a:off x="548640" y="1645920"/>
+            <a:ext cx="11064240" cy="4480560"/>
+          </a:xfrm>
+          <a:prstGeom prst="rect">
+            <a:avLst/>
+          </a:prstGeom>
+          <a:noFill/>
+        </p:spPr>
+        <p:txBody>
+          <a:bodyPr wrap="square" anchor="t">
+            <a:spAutoFit/>
+          </a:bodyPr>
+          <a:lstStyle/>
+          <a:p>
+            <a:pPr>
+              <a:spcAft>
+                <a:spcPts val="1200"/>
+              </a:spcAft>
+            </a:pPr>
+            <a:r>
+              <a:rPr sz="1800">
+                <a:solidFill>
+                  <a:srgbClr val="272E3B"/>
+                </a:solidFill>
+              </a:rPr>
+              <a:t>•  A public key alone does not prove identity</a:t>
+            </a:r>
+          </a:p>
+          <a:p>
+            <a:pPr>
+              <a:spcAft>
+                <a:spcPts val="1200"/>
+              </a:spcAft>
+            </a:pPr>
+            <a:r>
+              <a:rPr sz="1800">
+                <a:solidFill>
+                  <a:srgbClr val="272E3B"/>
+                </a:solidFill>
+              </a:rPr>
+              <a:t>•  A certificate binds a public key to an identity and is vouched for by a Certificate Authority (CA)</a:t>
+            </a:r>
+          </a:p>
+          <a:p>
+            <a:pPr>
+              <a:spcAft>
+                <a:spcPts val="1200"/>
+              </a:spcAft>
+            </a:pPr>
+            <a:r>
+              <a:rPr sz="1800">
+                <a:solidFill>
+                  <a:srgbClr val="272E3B"/>
+                </a:solidFill>
+              </a:rPr>
+              <a:t>•  Windows trusts a set of root CAs and walks the chain: package to your certificate to a trusted root</a:t>
+            </a:r>
+          </a:p>
+          <a:p>
+            <a:pPr>
+              <a:spcAft>
+                <a:spcPts val="1200"/>
+              </a:spcAft>
+            </a:pPr>
+            <a:r>
+              <a:rPr sz="1800">
+                <a:solidFill>
+                  <a:srgbClr val="272E3B"/>
+                </a:solidFill>
+              </a:rPr>
+              <a:t>•  A self-signed certificate has no CA backing, so Windows shows an untrusted publisher warning</a:t>
+            </a:r>
+          </a:p>
+        </p:txBody>
+      </p:sp>
+      <p:sp>
+        <p:nvSpPr>
+          <p:cNvPr id="6" name="TextBox 5"/>
+          <p:cNvSpPr txBox="1"/>
+          <p:nvPr/>
+        </p:nvSpPr>
+        <p:spPr>
+          <a:xfrm>
+            <a:off x="457200" y="6419088"/>
+            <a:ext cx="11277295" cy="320040"/>
+          </a:xfrm>
+          <a:prstGeom prst="rect">
+            <a:avLst/>
+          </a:prstGeom>
+          <a:noFill/>
+        </p:spPr>
+        <p:txBody>
+          <a:bodyPr wrap="square">
+            <a:spAutoFit/>
+          </a:bodyPr>
+          <a:lstStyle/>
+          <a:p>
+            <a:pPr algn="l"/>
+            <a:r>
+              <a:rPr sz="1000">
+                <a:solidFill>
+                  <a:srgbClr val="8A93A5"/>
+                </a:solidFill>
+              </a:rPr>
+              <a:t>Publishing a PWA to the Microsoft Store</a:t>
+            </a:r>
+          </a:p>
+        </p:txBody>
+      </p:sp>
+    </p:spTree>
+  </p:cSld>
+  <p:clrMapOvr>
+    <a:masterClrMapping/>
+  </p:clrMapOvr>
+</p:sld>
+</file>
+
+<file path=ppt/slides/slide23.xml><?xml version="1.0" encoding="utf-8"?>
+<p:sld xmlns:a="http://schemas.openxmlformats.org/drawingml/2006/main" xmlns:p="http://schemas.openxmlformats.org/presentationml/2006/main" xmlns:r="http://schemas.openxmlformats.org/officeDocument/2006/relationships">
+  <p:cSld>
+    <p:spTree>
+      <p:nvGrpSpPr>
+        <p:cNvPr id="1" name=""/>
+        <p:cNvGrpSpPr/>
+        <p:nvPr/>
+      </p:nvGrpSpPr>
+      <p:grpSpPr/>
+      <p:sp>
+        <p:nvSpPr>
+          <p:cNvPr id="2" name="Rectangle 1"/>
+          <p:cNvSpPr/>
+          <p:nvPr/>
+        </p:nvSpPr>
+        <p:spPr>
+          <a:xfrm>
+            <a:off x="0" y="0"/>
+            <a:ext cx="12191695" cy="6858000"/>
+          </a:xfrm>
+          <a:prstGeom prst="rect">
+            <a:avLst/>
+          </a:prstGeom>
+          <a:solidFill>
+            <a:srgbClr val="FFFFFF"/>
+          </a:solidFill>
+          <a:ln>
+            <a:noFill/>
+          </a:ln>
+          <a:effectLst/>
+        </p:spPr>
+        <p:style>
+          <a:lnRef idx="1">
+            <a:schemeClr val="accent1"/>
+          </a:lnRef>
+          <a:fillRef idx="3">
+            <a:schemeClr val="accent1"/>
+          </a:fillRef>
+          <a:effectRef idx="2">
+            <a:schemeClr val="accent1"/>
+          </a:effectRef>
+          <a:fontRef idx="minor">
+            <a:schemeClr val="lt1"/>
+          </a:fontRef>
+        </p:style>
+        <p:txBody>
+          <a:bodyPr rtlCol="0" anchor="ctr"/>
+          <a:lstStyle/>
+          <a:p>
+            <a:pPr algn="ctr"/>
+          </a:p>
+        </p:txBody>
+      </p:sp>
+      <p:sp>
+        <p:nvSpPr>
+          <p:cNvPr id="3" name="TextBox 2"/>
+          <p:cNvSpPr txBox="1"/>
+          <p:nvPr/>
+        </p:nvSpPr>
+        <p:spPr>
+          <a:xfrm>
+            <a:off x="548640" y="457200"/>
+            <a:ext cx="11064240" cy="914400"/>
+          </a:xfrm>
+          <a:prstGeom prst="rect">
+            <a:avLst/>
+          </a:prstGeom>
+          <a:noFill/>
+        </p:spPr>
+        <p:txBody>
+          <a:bodyPr wrap="square">
+            <a:spAutoFit/>
+          </a:bodyPr>
+          <a:lstStyle/>
+          <a:p>
+            <a:r>
+              <a:rPr sz="3200" b="1">
+                <a:solidFill>
+                  <a:srgbClr val="1B2A4A"/>
+                </a:solidFill>
+              </a:rPr>
+              <a:t>Why you did not need your own certificate</a:t>
+            </a:r>
+          </a:p>
+        </p:txBody>
+      </p:sp>
+      <p:sp>
+        <p:nvSpPr>
+          <p:cNvPr id="4" name="Rectangle 3"/>
+          <p:cNvSpPr/>
+          <p:nvPr/>
+        </p:nvSpPr>
+        <p:spPr>
+          <a:xfrm>
+            <a:off x="566928" y="1325880"/>
+            <a:ext cx="1828800" cy="54864"/>
+          </a:xfrm>
+          <a:prstGeom prst="rect">
+            <a:avLst/>
+          </a:prstGeom>
+          <a:solidFill>
+            <a:srgbClr val="4F8CFF"/>
+          </a:solidFill>
+          <a:ln>
+            <a:noFill/>
+          </a:ln>
+          <a:effectLst/>
+        </p:spPr>
+        <p:style>
+          <a:lnRef idx="1">
+            <a:schemeClr val="accent1"/>
+          </a:lnRef>
+          <a:fillRef idx="3">
+            <a:schemeClr val="accent1"/>
+          </a:fillRef>
+          <a:effectRef idx="2">
+            <a:schemeClr val="accent1"/>
+          </a:effectRef>
+          <a:fontRef idx="minor">
+            <a:schemeClr val="lt1"/>
+          </a:fontRef>
+        </p:style>
+        <p:txBody>
+          <a:bodyPr rtlCol="0" anchor="ctr"/>
+          <a:lstStyle/>
+          <a:p>
+            <a:pPr algn="ctr"/>
+          </a:p>
+        </p:txBody>
+      </p:sp>
+      <p:sp>
+        <p:nvSpPr>
+          <p:cNvPr id="5" name="TextBox 4"/>
+          <p:cNvSpPr txBox="1"/>
+          <p:nvPr/>
+        </p:nvSpPr>
+        <p:spPr>
+          <a:xfrm>
+            <a:off x="548640" y="1645920"/>
+            <a:ext cx="11064240" cy="4480560"/>
+          </a:xfrm>
+          <a:prstGeom prst="rect">
+            <a:avLst/>
+          </a:prstGeom>
+          <a:noFill/>
+        </p:spPr>
+        <p:txBody>
+          <a:bodyPr wrap="square" anchor="t">
+            <a:spAutoFit/>
+          </a:bodyPr>
+          <a:lstStyle/>
+          <a:p>
+            <a:pPr>
+              <a:spcAft>
+                <a:spcPts val="1200"/>
+              </a:spcAft>
+            </a:pPr>
+            <a:r>
+              <a:rPr sz="1800">
+                <a:solidFill>
+                  <a:srgbClr val="272E3B"/>
+                </a:solidFill>
+              </a:rPr>
+              <a:t>•  For Store apps, Microsoft signs the package for you during certification</a:t>
+            </a:r>
+          </a:p>
+          <a:p>
+            <a:pPr>
+              <a:spcAft>
+                <a:spcPts val="1200"/>
+              </a:spcAft>
+            </a:pPr>
+            <a:r>
+              <a:rPr sz="1800">
+                <a:solidFill>
+                  <a:srgbClr val="272E3B"/>
+                </a:solidFill>
+              </a:rPr>
+              <a:t>•  The trust chain becomes: Microsoft Root CA to Microsoft Store CA to your app</a:t>
+            </a:r>
+          </a:p>
+          <a:p>
+            <a:pPr>
+              <a:spcAft>
+                <a:spcPts val="1200"/>
+              </a:spcAft>
+            </a:pPr>
+            <a:r>
+              <a:rPr sz="1800">
+                <a:solidFill>
+                  <a:srgbClr val="272E3B"/>
+                </a:solidFill>
+              </a:rPr>
+              <a:t>•  Every Windows device already trusts Microsoft's root, so the app installs cleanly</a:t>
+            </a:r>
+          </a:p>
+          <a:p>
+            <a:pPr>
+              <a:spcAft>
+                <a:spcPts val="1200"/>
+              </a:spcAft>
+            </a:pPr>
+            <a:r>
+              <a:rPr sz="1800">
+                <a:solidFill>
+                  <a:srgbClr val="272E3B"/>
+                </a:solidFill>
+              </a:rPr>
+              <a:t>•  This is why the Publisher ID (CN=GUID) had to match: it is your identity in Microsoft's signing system</a:t>
+            </a:r>
+          </a:p>
+          <a:p>
+            <a:pPr>
+              <a:spcAft>
+                <a:spcPts val="1200"/>
+              </a:spcAft>
+            </a:pPr>
+            <a:r>
+              <a:rPr sz="1800">
+                <a:solidFill>
+                  <a:srgbClr val="272E3B"/>
+                </a:solidFill>
+              </a:rPr>
+              <a:t>•  You would only buy a code-signing certificate if you distributed the app outside the Store</a:t>
+            </a:r>
+          </a:p>
+        </p:txBody>
+      </p:sp>
+      <p:sp>
+        <p:nvSpPr>
+          <p:cNvPr id="6" name="TextBox 5"/>
+          <p:cNvSpPr txBox="1"/>
+          <p:nvPr/>
+        </p:nvSpPr>
+        <p:spPr>
+          <a:xfrm>
+            <a:off x="457200" y="6419088"/>
+            <a:ext cx="11277295" cy="320040"/>
+          </a:xfrm>
+          <a:prstGeom prst="rect">
+            <a:avLst/>
+          </a:prstGeom>
+          <a:noFill/>
+        </p:spPr>
+        <p:txBody>
+          <a:bodyPr wrap="square">
+            <a:spAutoFit/>
+          </a:bodyPr>
+          <a:lstStyle/>
+          <a:p>
+            <a:pPr algn="l"/>
+            <a:r>
+              <a:rPr sz="1000">
+                <a:solidFill>
+                  <a:srgbClr val="8A93A5"/>
+                </a:solidFill>
+              </a:rPr>
+              <a:t>Publishing a PWA to the Microsoft Store</a:t>
+            </a:r>
+          </a:p>
+        </p:txBody>
+      </p:sp>
+    </p:spTree>
+  </p:cSld>
+  <p:clrMapOvr>
+    <a:masterClrMapping/>
+  </p:clrMapOvr>
+</p:sld>
+</file>
+
+<file path=ppt/slides/slide24.xml><?xml version="1.0" encoding="utf-8"?>
+<p:sld xmlns:a="http://schemas.openxmlformats.org/drawingml/2006/main" xmlns:p="http://schemas.openxmlformats.org/presentationml/2006/main" xmlns:r="http://schemas.openxmlformats.org/officeDocument/2006/relationships">
+  <p:cSld>
+    <p:spTree>
+      <p:nvGrpSpPr>
+        <p:cNvPr id="1" name=""/>
+        <p:cNvGrpSpPr/>
+        <p:nvPr/>
+      </p:nvGrpSpPr>
+      <p:grpSpPr/>
+      <p:sp>
+        <p:nvSpPr>
+          <p:cNvPr id="2" name="Rectangle 1"/>
+          <p:cNvSpPr/>
+          <p:nvPr/>
+        </p:nvSpPr>
+        <p:spPr>
+          <a:xfrm>
+            <a:off x="0" y="0"/>
+            <a:ext cx="12191695" cy="6858000"/>
+          </a:xfrm>
+          <a:prstGeom prst="rect">
+            <a:avLst/>
+          </a:prstGeom>
+          <a:solidFill>
+            <a:srgbClr val="FFFFFF"/>
+          </a:solidFill>
+          <a:ln>
+            <a:noFill/>
+          </a:ln>
+          <a:effectLst/>
+        </p:spPr>
+        <p:style>
+          <a:lnRef idx="1">
+            <a:schemeClr val="accent1"/>
+          </a:lnRef>
+          <a:fillRef idx="3">
+            <a:schemeClr val="accent1"/>
+          </a:fillRef>
+          <a:effectRef idx="2">
+            <a:schemeClr val="accent1"/>
+          </a:effectRef>
+          <a:fontRef idx="minor">
+            <a:schemeClr val="lt1"/>
+          </a:fontRef>
+        </p:style>
+        <p:txBody>
+          <a:bodyPr rtlCol="0" anchor="ctr"/>
+          <a:lstStyle/>
+          <a:p>
+            <a:pPr algn="ctr"/>
+          </a:p>
+        </p:txBody>
+      </p:sp>
+      <p:sp>
+        <p:nvSpPr>
+          <p:cNvPr id="3" name="TextBox 2"/>
+          <p:cNvSpPr txBox="1"/>
+          <p:nvPr/>
+        </p:nvSpPr>
+        <p:spPr>
+          <a:xfrm>
+            <a:off x="548640" y="457200"/>
+            <a:ext cx="11064240" cy="914400"/>
+          </a:xfrm>
+          <a:prstGeom prst="rect">
+            <a:avLst/>
+          </a:prstGeom>
+          <a:noFill/>
+        </p:spPr>
+        <p:txBody>
+          <a:bodyPr wrap="square">
+            <a:spAutoFit/>
+          </a:bodyPr>
+          <a:lstStyle/>
+          <a:p>
+            <a:r>
+              <a:rPr sz="3200" b="1">
+                <a:solidFill>
+                  <a:srgbClr val="1B2A4A"/>
+                </a:solidFill>
+              </a:rPr>
+              <a:t>The test certificate in your package</a:t>
+            </a:r>
+          </a:p>
+        </p:txBody>
+      </p:sp>
+      <p:sp>
+        <p:nvSpPr>
+          <p:cNvPr id="4" name="Rectangle 3"/>
+          <p:cNvSpPr/>
+          <p:nvPr/>
+        </p:nvSpPr>
+        <p:spPr>
+          <a:xfrm>
+            <a:off x="566928" y="1325880"/>
+            <a:ext cx="1828800" cy="54864"/>
+          </a:xfrm>
+          <a:prstGeom prst="rect">
+            <a:avLst/>
+          </a:prstGeom>
+          <a:solidFill>
+            <a:srgbClr val="4F8CFF"/>
+          </a:solidFill>
+          <a:ln>
+            <a:noFill/>
+          </a:ln>
+          <a:effectLst/>
+        </p:spPr>
+        <p:style>
+          <a:lnRef idx="1">
+            <a:schemeClr val="accent1"/>
+          </a:lnRef>
+          <a:fillRef idx="3">
+            <a:schemeClr val="accent1"/>
+          </a:fillRef>
+          <a:effectRef idx="2">
+            <a:schemeClr val="accent1"/>
+          </a:effectRef>
+          <a:fontRef idx="minor">
+            <a:schemeClr val="lt1"/>
+          </a:fontRef>
+        </p:style>
+        <p:txBody>
+          <a:bodyPr rtlCol="0" anchor="ctr"/>
+          <a:lstStyle/>
+          <a:p>
+            <a:pPr algn="ctr"/>
+          </a:p>
+        </p:txBody>
+      </p:sp>
+      <p:sp>
+        <p:nvSpPr>
+          <p:cNvPr id="5" name="TextBox 4"/>
+          <p:cNvSpPr txBox="1"/>
+          <p:nvPr/>
+        </p:nvSpPr>
+        <p:spPr>
+          <a:xfrm>
+            <a:off x="548640" y="1645920"/>
+            <a:ext cx="11064240" cy="4480560"/>
+          </a:xfrm>
+          <a:prstGeom prst="rect">
+            <a:avLst/>
+          </a:prstGeom>
+          <a:noFill/>
+        </p:spPr>
+        <p:txBody>
+          <a:bodyPr wrap="square" anchor="t">
+            <a:spAutoFit/>
+          </a:bodyPr>
+          <a:lstStyle/>
+          <a:p>
+            <a:pPr>
+              <a:spcAft>
+                <a:spcPts val="1200"/>
+              </a:spcAft>
+            </a:pPr>
+            <a:r>
+              <a:rPr sz="1800">
+                <a:solidFill>
+                  <a:srgbClr val="272E3B"/>
+                </a:solidFill>
+              </a:rPr>
+              <a:t>•  PWABuilder also generated a self-signed test certificate (in the utils folder, used by install.ps1)</a:t>
+            </a:r>
+          </a:p>
+          <a:p>
+            <a:pPr>
+              <a:spcAft>
+                <a:spcPts val="1200"/>
+              </a:spcAft>
+            </a:pPr>
+            <a:r>
+              <a:rPr sz="1800">
+                <a:solidFill>
+                  <a:srgbClr val="272E3B"/>
+                </a:solidFill>
+              </a:rPr>
+              <a:t>•  install.ps1 trusts that certificate on your machine, then installs the sideload .msix for local testing</a:t>
+            </a:r>
+          </a:p>
+          <a:p>
+            <a:pPr>
+              <a:spcAft>
+                <a:spcPts val="1200"/>
+              </a:spcAft>
+            </a:pPr>
+            <a:r>
+              <a:rPr sz="1800">
+                <a:solidFill>
+                  <a:srgbClr val="272E3B"/>
+                </a:solidFill>
+              </a:rPr>
+              <a:t>•  Self-signed is fine on your own PC but is not trusted by anyone else</a:t>
+            </a:r>
+          </a:p>
+          <a:p>
+            <a:pPr>
+              <a:spcAft>
+                <a:spcPts val="1200"/>
+              </a:spcAft>
+            </a:pPr>
+            <a:r>
+              <a:rPr sz="1800">
+                <a:solidFill>
+                  <a:srgbClr val="272E3B"/>
+                </a:solidFill>
+              </a:rPr>
+              <a:t>•  Public trust comes from Microsoft's signature, not yours</a:t>
+            </a:r>
+          </a:p>
+          <a:p>
+            <a:pPr>
+              <a:spcAft>
+                <a:spcPts val="1200"/>
+              </a:spcAft>
+            </a:pPr>
+            <a:r>
+              <a:rPr sz="1800">
+                <a:solidFill>
+                  <a:srgbClr val="272E3B"/>
+                </a:solidFill>
+              </a:rPr>
+              <a:t>•  Bonus: timestamping proves it was signed while the certificate was valid, so it keeps working after the cert expires</a:t>
             </a:r>
           </a:p>
         </p:txBody>

</xml_diff>